<commit_message>
Refine Prague Pulse identity, 2027 edition and festival navigation
</commit_message>
<xml_diff>
--- a/odevzdani/cviceni-02-specifikace/prezentace.pptx
+++ b/odevzdani/cviceni-02-specifikace/prezentace.pptx
@@ -507,7 +507,7 @@
           <a:lstStyle/>
           <a:p>
             <a:r>
-              <a:t>Představujeme Prague Rocks Festival, fiktivní třídenní hudební festival v Praze. Cílem webu je umožnit návštěvníkovi rychle zjistit, kdy a kde hrají oblíbené kapely, a připravit si vlastní program. Jde o aktuálně připravený podklad k milníku, ne doklad historického odevzdání. Základem je specifikace a XML datová základna. Zachováváme tři dny, tři scény a šedesát účinkujících; nové jméno a výraznější grafický směr vznikly z požadavku zadavatele.</a:t>
+              <a:t>Představujeme Prague Pulse Fest, fiktivní třídenní hudební festival v Praze. Cílem webu je umožnit návštěvníkovi rychle zjistit, kdy a kde hrají oblíbené kapely, a připravit si vlastní program. Jde o aktuálně připravený podklad k milníku, ne doklad historického odevzdání. Základem je specifikace a XML datová základna. Zachováváme tři dny, tři scény a šedesát účinkujících; původní název, posun termínu na srpen 2027 a výraznější grafický směr vznikly z požadavku zadavatele.</a:t>
             </a:r>
           </a:p>
         </p:txBody>
@@ -577,7 +577,7 @@
           <a:lstStyle/>
           <a:p>
             <a:r>
-              <a:t>Festival propojuje několik současných žánrů. První ročník se odehrává od prvního do třetího srpna 2026 ve fiktivně uspořádaném areálu Vltava Park u reálného Výstaviště Praha. XML obsahuje identitu festivalu, tři dny, tři scény, šedesát interpretů a šedesát vystoupení. Každé vystoupení má odkaz na existující den, scénu a interpreta. Nejde tedy o čtyři nezávislé seznamy; vztahy lze zkontrolovat a použít pro program i detail kapely.</a:t>
+              <a:t>Festival propojuje několik současných žánrů. První ročník se odehrává od prvního do třetího srpna 2027 ve fiktivně uspořádaném areálu Vltava Park u reálného Výstaviště Praha. XML obsahuje identitu festivalu, tři dny, tři scény, šedesát interpretů a šedesát vystoupení. Každé vystoupení má odkaz na existující den, scénu a interpreta. Nejde tedy o čtyři nezávislé seznamy; vztahy lze zkontrolovat a použít pro program i detail kapely.</a:t>
             </a:r>
           </a:p>
         </p:txBody>
@@ -787,7 +787,7 @@
           <a:lstStyle/>
           <a:p>
             <a:r>
-              <a:t>První scénář řeší návštěvníka na telefonu, který zná den a scénu. Filtrovaný seznam mu umožní uložit koncert a později se vrátit k vlastnímu programu. Ve druhém scénáři návštěvník zadá jen část názvu Neon, otevře Neon Wave a zjistí čas i scénu koncertu. Očekávané výsledky jsou měřitelné: filtry nesmějí vracet jiné dny a oblíbené musí vydržet obnovení. Třetím scénářem ve specifikaci je objednávka hosta s výstupem PDF.</a:t>
+              <a:t>První scénář řeší návštěvníka na telefonu, který zná den a scénu. Filtrovaný seznam mu umožní uložit koncert a později se vrátit k vlastnímu programu. Ve druhém scénáři návštěvník zadá jen část názvu Atlas, otevře Atlas Motel a zjistí čas i scénu koncertu. Očekávané výsledky jsou měřitelné: filtry nesmějí vracet jiné dny a oblíbené musí vydržet obnovení. Třetím scénářem ve specifikaci je objednávka hosta s výstupem PDF.</a:t>
             </a:r>
           </a:p>
         </p:txBody>
@@ -4028,7 +4028,7 @@
               </a:defRPr>
             </a:pPr>
             <a:r>
-              <a:t>ROCKS</a:t>
+              <a:t>PULSE</a:t>
             </a:r>
           </a:p>
         </p:txBody>
@@ -4070,7 +4070,7 @@
               </a:defRPr>
             </a:pPr>
             <a:r>
-              <a:t>FESTIVAL / 2026</a:t>
+              <a:t>FEST / 2027</a:t>
             </a:r>
           </a:p>
         </p:txBody>
@@ -4258,7 +4258,7 @@
               </a:defRPr>
             </a:pPr>
             <a:r>
-              <a:t>Prague Rocks Festival</a:t>
+              <a:t>Prague Pulse Fest</a:t>
             </a:r>
           </a:p>
           <a:p>
@@ -4277,7 +4277,7 @@
               </a:defRPr>
             </a:pPr>
             <a:r>
-              <a:t>1—3 / 08 / 2026 · Praha</a:t>
+              <a:t>1—3 / 08 / 2027 · Praha</a:t>
             </a:r>
           </a:p>
         </p:txBody>
@@ -4403,7 +4403,7 @@
               </a:defRPr>
             </a:pPr>
             <a:r>
-              <a:t>2026</a:t>
+              <a:t>2027</a:t>
             </a:r>
           </a:p>
         </p:txBody>
@@ -4754,7 +4754,7 @@
               </a:defRPr>
             </a:pPr>
             <a:r>
-              <a:t>ROCKS</a:t>
+              <a:t>PULSE</a:t>
             </a:r>
           </a:p>
         </p:txBody>
@@ -4796,7 +4796,7 @@
               </a:defRPr>
             </a:pPr>
             <a:r>
-              <a:t>FESTIVAL / 2026</a:t>
+              <a:t>FEST / 2027</a:t>
             </a:r>
           </a:p>
         </p:txBody>
@@ -5516,7 +5516,7 @@
               </a:defRPr>
             </a:pPr>
             <a:r>
-              <a:t>1.–3. srpna 2026 · Vltava Park / Výstaviště Praha</a:t>
+              <a:t>1.–3. srpna 2027 · Vltava Park / Výstaviště Praha</a:t>
             </a:r>
           </a:p>
           <a:p>
@@ -5764,7 +5764,7 @@
               </a:defRPr>
             </a:pPr>
             <a:r>
-              <a:t>ROCKS</a:t>
+              <a:t>PULSE</a:t>
             </a:r>
           </a:p>
         </p:txBody>
@@ -5806,7 +5806,7 @@
               </a:defRPr>
             </a:pPr>
             <a:r>
-              <a:t>FESTIVAL / 2026</a:t>
+              <a:t>FEST / 2027</a:t>
             </a:r>
           </a:p>
         </p:txBody>
@@ -6915,7 +6915,7 @@
               </a:defRPr>
             </a:pPr>
             <a:r>
-              <a:t>ROCKS</a:t>
+              <a:t>PULSE</a:t>
             </a:r>
           </a:p>
         </p:txBody>
@@ -6957,7 +6957,7 @@
               </a:defRPr>
             </a:pPr>
             <a:r>
-              <a:t>FESTIVAL / 2026</a:t>
+              <a:t>FEST / 2027</a:t>
             </a:r>
           </a:p>
         </p:txBody>
@@ -8219,7 +8219,7 @@
               </a:defRPr>
             </a:pPr>
             <a:r>
-              <a:t>ROCKS</a:t>
+              <a:t>PULSE</a:t>
             </a:r>
           </a:p>
         </p:txBody>
@@ -8261,7 +8261,7 @@
               </a:defRPr>
             </a:pPr>
             <a:r>
-              <a:t>FESTIVAL / 2026</a:t>
+              <a:t>FEST / 2027</a:t>
             </a:r>
           </a:p>
         </p:txBody>
@@ -8825,7 +8825,7 @@
               </a:defRPr>
             </a:pPr>
             <a:r>
-              <a:t>Dotaz „Neon“ → Neon Wave → detail → vystoupení.</a:t>
+              <a:t>Dotaz „Atlas“ → Atlas Motel → detail → vystoupení.</a:t>
             </a:r>
           </a:p>
           <a:p>
@@ -9131,7 +9131,7 @@
               </a:defRPr>
             </a:pPr>
             <a:r>
-              <a:t>ROCKS</a:t>
+              <a:t>PULSE</a:t>
             </a:r>
           </a:p>
         </p:txBody>
@@ -9173,7 +9173,7 @@
               </a:defRPr>
             </a:pPr>
             <a:r>
-              <a:t>FESTIVAL / 2026</a:t>
+              <a:t>FEST / 2027</a:t>
             </a:r>
           </a:p>
         </p:txBody>

</xml_diff>

<commit_message>
Add dark festival storefront, real photography and group checkout
</commit_message>
<xml_diff>
--- a/odevzdani/cviceni-02-specifikace/prezentace.pptx
+++ b/odevzdani/cviceni-02-specifikace/prezentace.pptx
@@ -507,7 +507,7 @@
           <a:lstStyle/>
           <a:p>
             <a:r>
-              <a:t>Představujeme Prague Pulse Fest, fiktivní třídenní hudební festival v Praze. Cílem webu je umožnit návštěvníkovi rychle zjistit, kdy a kde hrají oblíbené kapely, a připravit si vlastní program. Jde o aktuálně připravený podklad k milníku, ne doklad historického odevzdání. Základem je specifikace a XML datová základna. Zachováváme tři dny, tři scény a šedesát účinkujících; původní název, posun termínu na srpen 2027 a výraznější grafický směr vznikly z požadavku zadavatele.</a:t>
+              <a:t>Představujeme Prague Pulse Fest, fiktivní třídenní hudební festival v Praze. Cílem webu je umožnit návštěvníkovi rychle zjistit, kdy a kde hrají oblíbené kapely, a připravit si vlastní program. Jde o aktuálně připravený podklad k milníku, ne doklad historického odevzdání. Základem je specifikace a XML datová základna. Zachováváme tři dny, tři scény a šedesát účinkujících; původní název, posun termínu na srpen 2027 a výraznější grafický směr vznikly z požadavku zadavatele. Současná datová základna obsahuje skutečné interprety jako navržený line-up; nejde o potvrzení jejich účasti. Noisia je pouze archivní poslechový blok.</a:t>
             </a:r>
           </a:p>
         </p:txBody>
@@ -577,7 +577,7 @@
           <a:lstStyle/>
           <a:p>
             <a:r>
-              <a:t>Festival propojuje několik současných žánrů. První ročník se odehrává od prvního do třetího srpna 2027 ve fiktivně uspořádaném areálu Vltava Park u reálného Výstaviště Praha. XML obsahuje identitu festivalu, tři dny, tři scény, šedesát interpretů a šedesát vystoupení. Každé vystoupení má odkaz na existující den, scénu a interpreta. Nejde tedy o čtyři nezávislé seznamy; vztahy lze zkontrolovat a použít pro program i detail kapely.</a:t>
+              <a:t>Festival propojuje několik současných žánrů. První ročník se odehrává od prvního do třetího srpna 2027 ve fiktivně uspořádaném areálu Vltava Park u reálného Výstaviště Praha. XML obsahuje identitu festivalu, tři dny, tři scény, šedesát interpretů a šedesát programových položek. Každé vystoupení má odkaz na existující den, scénu a interpreta. Nejde tedy o čtyři nezávislé seznamy; vztahy lze zkontrolovat a použít pro program i detail kapely.</a:t>
             </a:r>
           </a:p>
         </p:txBody>
@@ -787,7 +787,7 @@
           <a:lstStyle/>
           <a:p>
             <a:r>
-              <a:t>První scénář řeší návštěvníka na telefonu, který zná den a scénu. Filtrovaný seznam mu umožní uložit koncert a později se vrátit k vlastnímu programu. Ve druhém scénáři návštěvník zadá jen část názvu Atlas, otevře Atlas Motel a zjistí čas i scénu koncertu. Očekávané výsledky jsou měřitelné: filtry nesmějí vracet jiné dny a oblíbené musí vydržet obnovení. Třetím scénářem ve specifikaci je objednávka hosta s výstupem PDF.</a:t>
+              <a:t>První scénář řeší návštěvníka na telefonu, který zná den a scénu. Filtrovaný seznam mu umožní uložit koncert a později se vrátit k vlastnímu programu. Ve druhém scénáři návštěvník zadá jen název DARKZY, otevře DARKZY a zjistí čas i scénu koncertu. Očekávané výsledky jsou měřitelné: filtry nesmějí vracet jiné dny a oblíbené musí vydržet obnovení. Třetím scénářem ve specifikaci je objednávka hosta s výstupem PDF.</a:t>
             </a:r>
           </a:p>
         </p:txBody>
@@ -4077,50 +4077,7 @@
       </p:sp>
       <p:sp>
         <p:nvSpPr>
-          <p:cNvPr id="7" name="Rectangle 6"/>
-          <p:cNvSpPr/>
-          <p:nvPr/>
-        </p:nvSpPr>
-        <p:spPr>
-          <a:xfrm>
-            <a:off x="2266950" y="463550"/>
-            <a:ext cx="115570" cy="561340"/>
-          </a:xfrm>
-          <a:prstGeom prst="rect">
-            <a:avLst/>
-          </a:prstGeom>
-          <a:solidFill>
-            <a:srgbClr val="F4F0E7"/>
-          </a:solidFill>
-          <a:ln>
-            <a:noFill/>
-          </a:ln>
-        </p:spPr>
-        <p:style>
-          <a:lnRef idx="1">
-            <a:schemeClr val="accent1"/>
-          </a:lnRef>
-          <a:fillRef idx="3">
-            <a:schemeClr val="accent1"/>
-          </a:fillRef>
-          <a:effectRef idx="2">
-            <a:schemeClr val="accent1"/>
-          </a:effectRef>
-          <a:fontRef idx="minor">
-            <a:schemeClr val="lt1"/>
-          </a:fontRef>
-        </p:style>
-        <p:txBody>
-          <a:bodyPr rtlCol="0" anchor="ctr"/>
-          <a:lstStyle/>
-          <a:p>
-            <a:pPr algn="ctr"/>
-          </a:p>
-        </p:txBody>
-      </p:sp>
-      <p:sp>
-        <p:nvSpPr>
-          <p:cNvPr id="8" name="TextBox 7"/>
+          <p:cNvPr id="7" name="TextBox 6"/>
           <p:cNvSpPr txBox="1"/>
           <p:nvPr/>
         </p:nvSpPr>
@@ -4162,7 +4119,7 @@
       </p:sp>
       <p:sp>
         <p:nvSpPr>
-          <p:cNvPr id="9" name="TextBox 8"/>
+          <p:cNvPr id="8" name="TextBox 7"/>
           <p:cNvSpPr txBox="1"/>
           <p:nvPr/>
         </p:nvSpPr>
@@ -4223,7 +4180,7 @@
       </p:sp>
       <p:sp>
         <p:nvSpPr>
-          <p:cNvPr id="10" name="TextBox 9"/>
+          <p:cNvPr id="9" name="TextBox 8"/>
           <p:cNvSpPr txBox="1"/>
           <p:nvPr/>
         </p:nvSpPr>
@@ -4284,7 +4241,7 @@
       </p:sp>
       <p:sp>
         <p:nvSpPr>
-          <p:cNvPr id="11" name="TextBox 10"/>
+          <p:cNvPr id="10" name="TextBox 9"/>
           <p:cNvSpPr txBox="1"/>
           <p:nvPr/>
         </p:nvSpPr>
@@ -4326,7 +4283,7 @@
       </p:sp>
       <p:sp>
         <p:nvSpPr>
-          <p:cNvPr id="12" name="TextBox 11"/>
+          <p:cNvPr id="11" name="TextBox 10"/>
           <p:cNvSpPr txBox="1"/>
           <p:nvPr/>
         </p:nvSpPr>
@@ -4368,7 +4325,7 @@
       </p:sp>
       <p:sp>
         <p:nvSpPr>
-          <p:cNvPr id="13" name="TextBox 12"/>
+          <p:cNvPr id="12" name="TextBox 11"/>
           <p:cNvSpPr txBox="1"/>
           <p:nvPr/>
         </p:nvSpPr>
@@ -4410,7 +4367,7 @@
       </p:sp>
       <p:sp>
         <p:nvSpPr>
-          <p:cNvPr id="14" name="TextBox 13"/>
+          <p:cNvPr id="13" name="TextBox 12"/>
           <p:cNvSpPr txBox="1"/>
           <p:nvPr/>
         </p:nvSpPr>
@@ -4471,7 +4428,7 @@
       </p:sp>
       <p:sp>
         <p:nvSpPr>
-          <p:cNvPr id="15" name="TextBox 14"/>
+          <p:cNvPr id="14" name="TextBox 13"/>
           <p:cNvSpPr txBox="1"/>
           <p:nvPr/>
         </p:nvSpPr>
@@ -4532,7 +4489,7 @@
       </p:sp>
       <p:sp>
         <p:nvSpPr>
-          <p:cNvPr id="16" name="TextBox 15"/>
+          <p:cNvPr id="15" name="TextBox 14"/>
           <p:cNvSpPr txBox="1"/>
           <p:nvPr/>
         </p:nvSpPr>
@@ -4574,7 +4531,7 @@
       </p:sp>
       <p:sp>
         <p:nvSpPr>
-          <p:cNvPr id="17" name="TextBox 16"/>
+          <p:cNvPr id="16" name="TextBox 15"/>
           <p:cNvSpPr txBox="1"/>
           <p:nvPr/>
         </p:nvSpPr>
@@ -4803,20 +4760,62 @@
       </p:sp>
       <p:sp>
         <p:nvSpPr>
-          <p:cNvPr id="6" name="Rectangle 5"/>
+          <p:cNvPr id="6" name="TextBox 5"/>
+          <p:cNvSpPr txBox="1"/>
+          <p:nvPr/>
+        </p:nvSpPr>
+        <p:spPr>
+          <a:xfrm>
+            <a:off x="5588000" y="533400"/>
+            <a:ext cx="6070600" cy="220979"/>
+          </a:xfrm>
+          <a:prstGeom prst="rect">
+            <a:avLst/>
+          </a:prstGeom>
+          <a:noFill/>
+        </p:spPr>
+        <p:txBody>
+          <a:bodyPr wrap="none" lIns="0" rIns="0" tIns="0" bIns="0">
+            <a:spAutoFit/>
+          </a:bodyPr>
+          <a:lstStyle/>
+          <a:p>
+            <a:pPr>
+              <a:lnSpc>
+                <a:spcPts val="1240"/>
+              </a:lnSpc>
+              <a:spcAft>
+                <a:spcPts val="0"/>
+              </a:spcAft>
+              <a:defRPr sz="1000" b="1">
+                <a:solidFill>
+                  <a:srgbClr val="68635B"/>
+                </a:solidFill>
+                <a:latin typeface="Arial"/>
+              </a:defRPr>
+            </a:pPr>
+            <a:r>
+              <a:t>IDENTITA A DATOVÝ MODEL</a:t>
+            </a:r>
+          </a:p>
+        </p:txBody>
+      </p:sp>
+      <p:sp>
+        <p:nvSpPr>
+          <p:cNvPr id="7" name="Rectangle 6"/>
           <p:cNvSpPr/>
           <p:nvPr/>
         </p:nvSpPr>
         <p:spPr>
           <a:xfrm>
-            <a:off x="1866900" y="368300"/>
-            <a:ext cx="88900" cy="431800"/>
+            <a:off x="533400" y="1155700"/>
+            <a:ext cx="11125200" cy="25400"/>
           </a:xfrm>
           <a:prstGeom prst="rect">
             <a:avLst/>
           </a:prstGeom>
           <a:solidFill>
-            <a:srgbClr val="F45E2B"/>
+            <a:srgbClr val="181817"/>
           </a:solidFill>
           <a:ln>
             <a:noFill/>
@@ -4846,14 +4845,14 @@
       </p:sp>
       <p:sp>
         <p:nvSpPr>
-          <p:cNvPr id="7" name="TextBox 6"/>
+          <p:cNvPr id="8" name="TextBox 7"/>
           <p:cNvSpPr txBox="1"/>
           <p:nvPr/>
         </p:nvSpPr>
         <p:spPr>
           <a:xfrm>
-            <a:off x="5588000" y="533400"/>
-            <a:ext cx="6070600" cy="220979"/>
+            <a:off x="508000" y="1422400"/>
+            <a:ext cx="11176000" cy="1079500"/>
           </a:xfrm>
           <a:prstGeom prst="rect">
             <a:avLst/>
@@ -4868,40 +4867,40 @@
           <a:p>
             <a:pPr>
               <a:lnSpc>
-                <a:spcPts val="1240"/>
-              </a:lnSpc>
-              <a:spcAft>
-                <a:spcPts val="0"/>
-              </a:spcAft>
-              <a:defRPr sz="1000" b="1">
-                <a:solidFill>
-                  <a:srgbClr val="68635B"/>
-                </a:solidFill>
-                <a:latin typeface="Arial"/>
-              </a:defRPr>
-            </a:pPr>
-            <a:r>
-              <a:t>IDENTITA A DATOVÝ MODEL</a:t>
-            </a:r>
-          </a:p>
-        </p:txBody>
-      </p:sp>
-      <p:sp>
-        <p:nvSpPr>
-          <p:cNvPr id="8" name="Rectangle 7"/>
+                <a:spcPts val="3740"/>
+              </a:lnSpc>
+              <a:spcAft>
+                <a:spcPts val="0"/>
+              </a:spcAft>
+              <a:defRPr sz="3400" b="1">
+                <a:solidFill>
+                  <a:srgbClr val="181817"/>
+                </a:solidFill>
+                <a:latin typeface="Arial"/>
+              </a:defRPr>
+            </a:pPr>
+            <a:r>
+              <a:t>Jedna akce. Propojená data.</a:t>
+            </a:r>
+          </a:p>
+        </p:txBody>
+      </p:sp>
+      <p:sp>
+        <p:nvSpPr>
+          <p:cNvPr id="9" name="Rectangle 8"/>
           <p:cNvSpPr/>
           <p:nvPr/>
         </p:nvSpPr>
         <p:spPr>
           <a:xfrm>
-            <a:off x="533400" y="1155700"/>
-            <a:ext cx="11125200" cy="25400"/>
+            <a:off x="533400" y="2794000"/>
+            <a:ext cx="2552700" cy="2095500"/>
           </a:xfrm>
           <a:prstGeom prst="rect">
             <a:avLst/>
           </a:prstGeom>
           <a:solidFill>
-            <a:srgbClr val="181817"/>
+            <a:srgbClr val="F45E2B"/>
           </a:solidFill>
           <a:ln>
             <a:noFill/>
@@ -4931,14 +4930,14 @@
       </p:sp>
       <p:sp>
         <p:nvSpPr>
-          <p:cNvPr id="9" name="TextBox 8"/>
+          <p:cNvPr id="10" name="TextBox 9"/>
           <p:cNvSpPr txBox="1"/>
           <p:nvPr/>
         </p:nvSpPr>
         <p:spPr>
           <a:xfrm>
-            <a:off x="508000" y="1422400"/>
-            <a:ext cx="11176000" cy="1079500"/>
+            <a:off x="762000" y="2921000"/>
+            <a:ext cx="2133600" cy="1102868"/>
           </a:xfrm>
           <a:prstGeom prst="rect">
             <a:avLst/>
@@ -4953,12 +4952,12 @@
           <a:p>
             <a:pPr>
               <a:lnSpc>
-                <a:spcPts val="3740"/>
-              </a:lnSpc>
-              <a:spcAft>
-                <a:spcPts val="0"/>
-              </a:spcAft>
-              <a:defRPr sz="3400" b="1">
+                <a:spcPts val="8184"/>
+              </a:lnSpc>
+              <a:spcAft>
+                <a:spcPts val="0"/>
+              </a:spcAft>
+              <a:defRPr sz="6600" b="1">
                 <a:solidFill>
                   <a:srgbClr val="181817"/>
                 </a:solidFill>
@@ -4966,27 +4965,69 @@
               </a:defRPr>
             </a:pPr>
             <a:r>
-              <a:t>Jedna akce. Propojená data.</a:t>
-            </a:r>
-          </a:p>
-        </p:txBody>
-      </p:sp>
-      <p:sp>
-        <p:nvSpPr>
-          <p:cNvPr id="10" name="Rectangle 9"/>
+              <a:t>3</a:t>
+            </a:r>
+          </a:p>
+        </p:txBody>
+      </p:sp>
+      <p:sp>
+        <p:nvSpPr>
+          <p:cNvPr id="11" name="TextBox 10"/>
+          <p:cNvSpPr txBox="1"/>
+          <p:nvPr/>
+        </p:nvSpPr>
+        <p:spPr>
+          <a:xfrm>
+            <a:off x="762000" y="4165600"/>
+            <a:ext cx="2133600" cy="252476"/>
+          </a:xfrm>
+          <a:prstGeom prst="rect">
+            <a:avLst/>
+          </a:prstGeom>
+          <a:noFill/>
+        </p:spPr>
+        <p:txBody>
+          <a:bodyPr wrap="none" lIns="0" rIns="0" tIns="0" bIns="0">
+            <a:spAutoFit/>
+          </a:bodyPr>
+          <a:lstStyle/>
+          <a:p>
+            <a:pPr>
+              <a:lnSpc>
+                <a:spcPts val="1488"/>
+              </a:lnSpc>
+              <a:spcAft>
+                <a:spcPts val="0"/>
+              </a:spcAft>
+              <a:defRPr sz="1200" b="1">
+                <a:solidFill>
+                  <a:srgbClr val="181817"/>
+                </a:solidFill>
+                <a:latin typeface="Arial"/>
+              </a:defRPr>
+            </a:pPr>
+            <a:r>
+              <a:t>festivalové dny</a:t>
+            </a:r>
+          </a:p>
+        </p:txBody>
+      </p:sp>
+      <p:sp>
+        <p:nvSpPr>
+          <p:cNvPr id="12" name="Rectangle 11"/>
           <p:cNvSpPr/>
           <p:nvPr/>
         </p:nvSpPr>
         <p:spPr>
           <a:xfrm>
-            <a:off x="533400" y="2794000"/>
+            <a:off x="3390900" y="2794000"/>
             <a:ext cx="2552700" cy="2095500"/>
           </a:xfrm>
           <a:prstGeom prst="rect">
             <a:avLst/>
           </a:prstGeom>
           <a:solidFill>
-            <a:srgbClr val="F45E2B"/>
+            <a:srgbClr val="E7E0D5"/>
           </a:solidFill>
           <a:ln>
             <a:noFill/>
@@ -5016,13 +5057,13 @@
       </p:sp>
       <p:sp>
         <p:nvSpPr>
-          <p:cNvPr id="11" name="TextBox 10"/>
+          <p:cNvPr id="13" name="TextBox 12"/>
           <p:cNvSpPr txBox="1"/>
           <p:nvPr/>
         </p:nvSpPr>
         <p:spPr>
           <a:xfrm>
-            <a:off x="762000" y="2921000"/>
+            <a:off x="3619500" y="2921000"/>
             <a:ext cx="2133600" cy="1102868"/>
           </a:xfrm>
           <a:prstGeom prst="rect">
@@ -5058,13 +5099,13 @@
       </p:sp>
       <p:sp>
         <p:nvSpPr>
-          <p:cNvPr id="12" name="TextBox 11"/>
+          <p:cNvPr id="14" name="TextBox 13"/>
           <p:cNvSpPr txBox="1"/>
           <p:nvPr/>
         </p:nvSpPr>
         <p:spPr>
           <a:xfrm>
-            <a:off x="762000" y="4165600"/>
+            <a:off x="3619500" y="4165600"/>
             <a:ext cx="2133600" cy="252476"/>
           </a:xfrm>
           <a:prstGeom prst="rect">
@@ -5093,20 +5134,20 @@
               </a:defRPr>
             </a:pPr>
             <a:r>
-              <a:t>festivalové dny</a:t>
-            </a:r>
-          </a:p>
-        </p:txBody>
-      </p:sp>
-      <p:sp>
-        <p:nvSpPr>
-          <p:cNvPr id="13" name="Rectangle 12"/>
+              <a:t>hudební scény</a:t>
+            </a:r>
+          </a:p>
+        </p:txBody>
+      </p:sp>
+      <p:sp>
+        <p:nvSpPr>
+          <p:cNvPr id="15" name="Rectangle 14"/>
           <p:cNvSpPr/>
           <p:nvPr/>
         </p:nvSpPr>
         <p:spPr>
           <a:xfrm>
-            <a:off x="3390900" y="2794000"/>
+            <a:off x="6248400" y="2794000"/>
             <a:ext cx="2552700" cy="2095500"/>
           </a:xfrm>
           <a:prstGeom prst="rect">
@@ -5143,13 +5184,13 @@
       </p:sp>
       <p:sp>
         <p:nvSpPr>
-          <p:cNvPr id="14" name="TextBox 13"/>
+          <p:cNvPr id="16" name="TextBox 15"/>
           <p:cNvSpPr txBox="1"/>
           <p:nvPr/>
         </p:nvSpPr>
         <p:spPr>
           <a:xfrm>
-            <a:off x="3619500" y="2921000"/>
+            <a:off x="6477000" y="2921000"/>
             <a:ext cx="2133600" cy="1102868"/>
           </a:xfrm>
           <a:prstGeom prst="rect">
@@ -5178,20 +5219,20 @@
               </a:defRPr>
             </a:pPr>
             <a:r>
-              <a:t>3</a:t>
-            </a:r>
-          </a:p>
-        </p:txBody>
-      </p:sp>
-      <p:sp>
-        <p:nvSpPr>
-          <p:cNvPr id="15" name="TextBox 14"/>
+              <a:t>60</a:t>
+            </a:r>
+          </a:p>
+        </p:txBody>
+      </p:sp>
+      <p:sp>
+        <p:nvSpPr>
+          <p:cNvPr id="17" name="TextBox 16"/>
           <p:cNvSpPr txBox="1"/>
           <p:nvPr/>
         </p:nvSpPr>
         <p:spPr>
           <a:xfrm>
-            <a:off x="3619500" y="4165600"/>
+            <a:off x="6477000" y="4165600"/>
             <a:ext cx="2133600" cy="252476"/>
           </a:xfrm>
           <a:prstGeom prst="rect">
@@ -5220,20 +5261,20 @@
               </a:defRPr>
             </a:pPr>
             <a:r>
-              <a:t>hudební scény</a:t>
-            </a:r>
-          </a:p>
-        </p:txBody>
-      </p:sp>
-      <p:sp>
-        <p:nvSpPr>
-          <p:cNvPr id="16" name="Rectangle 15"/>
+              <a:t>účinkujících</a:t>
+            </a:r>
+          </a:p>
+        </p:txBody>
+      </p:sp>
+      <p:sp>
+        <p:nvSpPr>
+          <p:cNvPr id="18" name="Rectangle 17"/>
           <p:cNvSpPr/>
           <p:nvPr/>
         </p:nvSpPr>
         <p:spPr>
           <a:xfrm>
-            <a:off x="6248400" y="2794000"/>
+            <a:off x="9105900" y="2794000"/>
             <a:ext cx="2552700" cy="2095500"/>
           </a:xfrm>
           <a:prstGeom prst="rect">
@@ -5270,13 +5311,13 @@
       </p:sp>
       <p:sp>
         <p:nvSpPr>
-          <p:cNvPr id="17" name="TextBox 16"/>
+          <p:cNvPr id="19" name="TextBox 18"/>
           <p:cNvSpPr txBox="1"/>
           <p:nvPr/>
         </p:nvSpPr>
         <p:spPr>
           <a:xfrm>
-            <a:off x="6477000" y="2921000"/>
+            <a:off x="9334500" y="2921000"/>
             <a:ext cx="2133600" cy="1102868"/>
           </a:xfrm>
           <a:prstGeom prst="rect">
@@ -5312,13 +5353,13 @@
       </p:sp>
       <p:sp>
         <p:nvSpPr>
-          <p:cNvPr id="18" name="TextBox 17"/>
+          <p:cNvPr id="20" name="TextBox 19"/>
           <p:cNvSpPr txBox="1"/>
           <p:nvPr/>
         </p:nvSpPr>
         <p:spPr>
           <a:xfrm>
-            <a:off x="6477000" y="4165600"/>
+            <a:off x="9334500" y="4165600"/>
             <a:ext cx="2133600" cy="252476"/>
           </a:xfrm>
           <a:prstGeom prst="rect">
@@ -5347,64 +5388,21 @@
               </a:defRPr>
             </a:pPr>
             <a:r>
-              <a:t>účinkujících</a:t>
-            </a:r>
-          </a:p>
-        </p:txBody>
-      </p:sp>
-      <p:sp>
-        <p:nvSpPr>
-          <p:cNvPr id="19" name="Rectangle 18"/>
-          <p:cNvSpPr/>
-          <p:nvPr/>
-        </p:nvSpPr>
-        <p:spPr>
-          <a:xfrm>
-            <a:off x="9105900" y="2794000"/>
-            <a:ext cx="2552700" cy="2095500"/>
-          </a:xfrm>
-          <a:prstGeom prst="rect">
-            <a:avLst/>
-          </a:prstGeom>
-          <a:solidFill>
-            <a:srgbClr val="E7E0D5"/>
-          </a:solidFill>
-          <a:ln>
-            <a:noFill/>
-          </a:ln>
-        </p:spPr>
-        <p:style>
-          <a:lnRef idx="1">
-            <a:schemeClr val="accent1"/>
-          </a:lnRef>
-          <a:fillRef idx="3">
-            <a:schemeClr val="accent1"/>
-          </a:fillRef>
-          <a:effectRef idx="2">
-            <a:schemeClr val="accent1"/>
-          </a:effectRef>
-          <a:fontRef idx="minor">
-            <a:schemeClr val="lt1"/>
-          </a:fontRef>
-        </p:style>
-        <p:txBody>
-          <a:bodyPr rtlCol="0" anchor="ctr"/>
-          <a:lstStyle/>
-          <a:p>
-            <a:pPr algn="ctr"/>
-          </a:p>
-        </p:txBody>
-      </p:sp>
-      <p:sp>
-        <p:nvSpPr>
-          <p:cNvPr id="20" name="TextBox 19"/>
+              <a:t>programových položek</a:t>
+            </a:r>
+          </a:p>
+        </p:txBody>
+      </p:sp>
+      <p:sp>
+        <p:nvSpPr>
+          <p:cNvPr id="21" name="TextBox 20"/>
           <p:cNvSpPr txBox="1"/>
           <p:nvPr/>
         </p:nvSpPr>
         <p:spPr>
           <a:xfrm>
-            <a:off x="9334500" y="2921000"/>
-            <a:ext cx="2133600" cy="1102868"/>
+            <a:off x="533400" y="5295900"/>
+            <a:ext cx="11125200" cy="939800"/>
           </a:xfrm>
           <a:prstGeom prst="rect">
             <a:avLst/>
@@ -5419,12 +5417,12 @@
           <a:p>
             <a:pPr>
               <a:lnSpc>
-                <a:spcPts val="8184"/>
-              </a:lnSpc>
-              <a:spcAft>
-                <a:spcPts val="0"/>
-              </a:spcAft>
-              <a:defRPr sz="6600" b="1">
+                <a:spcPts val="2232"/>
+              </a:lnSpc>
+              <a:spcAft>
+                <a:spcPts val="0"/>
+              </a:spcAft>
+              <a:defRPr sz="1800" b="0">
                 <a:solidFill>
                   <a:srgbClr val="181817"/>
                 </a:solidFill>
@@ -5432,21 +5430,40 @@
               </a:defRPr>
             </a:pPr>
             <a:r>
-              <a:t>60</a:t>
-            </a:r>
-          </a:p>
-        </p:txBody>
-      </p:sp>
-      <p:sp>
-        <p:nvSpPr>
-          <p:cNvPr id="21" name="TextBox 20"/>
+              <a:t>1.–3. srpna 2027 · Vltava Park / Výstaviště Praha</a:t>
+            </a:r>
+          </a:p>
+          <a:p>
+            <a:pPr>
+              <a:lnSpc>
+                <a:spcPts val="2232"/>
+              </a:lnSpc>
+              <a:spcAft>
+                <a:spcPts val="0"/>
+              </a:spcAft>
+              <a:defRPr sz="1800" b="0">
+                <a:solidFill>
+                  <a:srgbClr val="181817"/>
+                </a:solidFill>
+                <a:latin typeface="Arial"/>
+              </a:defRPr>
+            </a:pPr>
+            <a:r>
+              <a:t>Rock, indie, pop, elektronika, hip-hop, jazz a folk.</a:t>
+            </a:r>
+          </a:p>
+        </p:txBody>
+      </p:sp>
+      <p:sp>
+        <p:nvSpPr>
+          <p:cNvPr id="22" name="TextBox 21"/>
           <p:cNvSpPr txBox="1"/>
           <p:nvPr/>
         </p:nvSpPr>
         <p:spPr>
           <a:xfrm>
-            <a:off x="9334500" y="4165600"/>
-            <a:ext cx="2133600" cy="252476"/>
+            <a:off x="533400" y="6413500"/>
+            <a:ext cx="10033000" cy="181610"/>
           </a:xfrm>
           <a:prstGeom prst="rect">
             <a:avLst/>
@@ -5461,81 +5478,20 @@
           <a:p>
             <a:pPr>
               <a:lnSpc>
-                <a:spcPts val="1488"/>
-              </a:lnSpc>
-              <a:spcAft>
-                <a:spcPts val="0"/>
-              </a:spcAft>
-              <a:defRPr sz="1200" b="1">
-                <a:solidFill>
-                  <a:srgbClr val="181817"/>
-                </a:solidFill>
-                <a:latin typeface="Arial"/>
-              </a:defRPr>
-            </a:pPr>
-            <a:r>
-              <a:t>vystoupení</a:t>
-            </a:r>
-          </a:p>
-        </p:txBody>
-      </p:sp>
-      <p:sp>
-        <p:nvSpPr>
-          <p:cNvPr id="22" name="TextBox 21"/>
-          <p:cNvSpPr txBox="1"/>
-          <p:nvPr/>
-        </p:nvSpPr>
-        <p:spPr>
-          <a:xfrm>
-            <a:off x="533400" y="5295900"/>
-            <a:ext cx="11125200" cy="939800"/>
-          </a:xfrm>
-          <a:prstGeom prst="rect">
-            <a:avLst/>
-          </a:prstGeom>
-          <a:noFill/>
-        </p:spPr>
-        <p:txBody>
-          <a:bodyPr wrap="none" lIns="0" rIns="0" tIns="0" bIns="0">
-            <a:spAutoFit/>
-          </a:bodyPr>
-          <a:lstStyle/>
-          <a:p>
-            <a:pPr>
-              <a:lnSpc>
-                <a:spcPts val="2232"/>
-              </a:lnSpc>
-              <a:spcAft>
-                <a:spcPts val="0"/>
-              </a:spcAft>
-              <a:defRPr sz="1800" b="0">
-                <a:solidFill>
-                  <a:srgbClr val="181817"/>
-                </a:solidFill>
-                <a:latin typeface="Arial"/>
-              </a:defRPr>
-            </a:pPr>
-            <a:r>
-              <a:t>1.–3. srpna 2027 · Vltava Park / Výstaviště Praha</a:t>
-            </a:r>
-          </a:p>
-          <a:p>
-            <a:pPr>
-              <a:lnSpc>
-                <a:spcPts val="2232"/>
-              </a:lnSpc>
-              <a:spcAft>
-                <a:spcPts val="0"/>
-              </a:spcAft>
-              <a:defRPr sz="1800" b="0">
-                <a:solidFill>
-                  <a:srgbClr val="181817"/>
-                </a:solidFill>
-                <a:latin typeface="Arial"/>
-              </a:defRPr>
-            </a:pPr>
-            <a:r>
-              <a:t>Rock, indie, pop, elektronika, hip-hop, jazz a folk.</a:t>
+                <a:spcPts val="930"/>
+              </a:lnSpc>
+              <a:spcAft>
+                <a:spcPts val="0"/>
+              </a:spcAft>
+              <a:defRPr sz="750" b="0">
+                <a:solidFill>
+                  <a:srgbClr val="68635B"/>
+                </a:solidFill>
+                <a:latin typeface="Arial"/>
+              </a:defRPr>
+            </a:pPr>
+            <a:r>
+              <a:t>DODATEČNĚ PŘIPRAVENÝ PODKLAD K MILNÍKU</a:t>
             </a:r>
           </a:p>
         </p:txBody>
@@ -5543,48 +5499,6 @@
       <p:sp>
         <p:nvSpPr>
           <p:cNvPr id="23" name="TextBox 22"/>
-          <p:cNvSpPr txBox="1"/>
-          <p:nvPr/>
-        </p:nvSpPr>
-        <p:spPr>
-          <a:xfrm>
-            <a:off x="533400" y="6413500"/>
-            <a:ext cx="10033000" cy="181610"/>
-          </a:xfrm>
-          <a:prstGeom prst="rect">
-            <a:avLst/>
-          </a:prstGeom>
-          <a:noFill/>
-        </p:spPr>
-        <p:txBody>
-          <a:bodyPr wrap="none" lIns="0" rIns="0" tIns="0" bIns="0">
-            <a:spAutoFit/>
-          </a:bodyPr>
-          <a:lstStyle/>
-          <a:p>
-            <a:pPr>
-              <a:lnSpc>
-                <a:spcPts val="930"/>
-              </a:lnSpc>
-              <a:spcAft>
-                <a:spcPts val="0"/>
-              </a:spcAft>
-              <a:defRPr sz="750" b="0">
-                <a:solidFill>
-                  <a:srgbClr val="68635B"/>
-                </a:solidFill>
-                <a:latin typeface="Arial"/>
-              </a:defRPr>
-            </a:pPr>
-            <a:r>
-              <a:t>DODATEČNĚ PŘIPRAVENÝ PODKLAD K MILNÍKU</a:t>
-            </a:r>
-          </a:p>
-        </p:txBody>
-      </p:sp>
-      <p:sp>
-        <p:nvSpPr>
-          <p:cNvPr id="24" name="TextBox 23"/>
           <p:cNvSpPr txBox="1"/>
           <p:nvPr/>
         </p:nvSpPr>
@@ -5813,20 +5727,62 @@
       </p:sp>
       <p:sp>
         <p:nvSpPr>
-          <p:cNvPr id="6" name="Rectangle 5"/>
+          <p:cNvPr id="6" name="TextBox 5"/>
+          <p:cNvSpPr txBox="1"/>
+          <p:nvPr/>
+        </p:nvSpPr>
+        <p:spPr>
+          <a:xfrm>
+            <a:off x="5588000" y="533400"/>
+            <a:ext cx="6070600" cy="220979"/>
+          </a:xfrm>
+          <a:prstGeom prst="rect">
+            <a:avLst/>
+          </a:prstGeom>
+          <a:noFill/>
+        </p:spPr>
+        <p:txBody>
+          <a:bodyPr wrap="none" lIns="0" rIns="0" tIns="0" bIns="0">
+            <a:spAutoFit/>
+          </a:bodyPr>
+          <a:lstStyle/>
+          <a:p>
+            <a:pPr>
+              <a:lnSpc>
+                <a:spcPts val="1240"/>
+              </a:lnSpc>
+              <a:spcAft>
+                <a:spcPts val="0"/>
+              </a:spcAft>
+              <a:defRPr sz="1000" b="1">
+                <a:solidFill>
+                  <a:srgbClr val="68635B"/>
+                </a:solidFill>
+                <a:latin typeface="Arial"/>
+              </a:defRPr>
+            </a:pPr>
+            <a:r>
+              <a:t>POTŘEBY → FUNKCE</a:t>
+            </a:r>
+          </a:p>
+        </p:txBody>
+      </p:sp>
+      <p:sp>
+        <p:nvSpPr>
+          <p:cNvPr id="7" name="Rectangle 6"/>
           <p:cNvSpPr/>
           <p:nvPr/>
         </p:nvSpPr>
         <p:spPr>
           <a:xfrm>
-            <a:off x="1866900" y="368300"/>
-            <a:ext cx="88900" cy="431800"/>
+            <a:off x="533400" y="1155700"/>
+            <a:ext cx="11125200" cy="25400"/>
           </a:xfrm>
           <a:prstGeom prst="rect">
             <a:avLst/>
           </a:prstGeom>
           <a:solidFill>
-            <a:srgbClr val="F45E2B"/>
+            <a:srgbClr val="181817"/>
           </a:solidFill>
           <a:ln>
             <a:noFill/>
@@ -5856,14 +5812,14 @@
       </p:sp>
       <p:sp>
         <p:nvSpPr>
-          <p:cNvPr id="7" name="TextBox 6"/>
+          <p:cNvPr id="8" name="TextBox 7"/>
           <p:cNvSpPr txBox="1"/>
           <p:nvPr/>
         </p:nvSpPr>
         <p:spPr>
           <a:xfrm>
-            <a:off x="5588000" y="533400"/>
-            <a:ext cx="6070600" cy="220979"/>
+            <a:off x="508000" y="1422400"/>
+            <a:ext cx="11176000" cy="1079500"/>
           </a:xfrm>
           <a:prstGeom prst="rect">
             <a:avLst/>
@@ -5878,34 +5834,34 @@
           <a:p>
             <a:pPr>
               <a:lnSpc>
-                <a:spcPts val="1240"/>
-              </a:lnSpc>
-              <a:spcAft>
-                <a:spcPts val="0"/>
-              </a:spcAft>
-              <a:defRPr sz="1000" b="1">
-                <a:solidFill>
-                  <a:srgbClr val="68635B"/>
-                </a:solidFill>
-                <a:latin typeface="Arial"/>
-              </a:defRPr>
-            </a:pPr>
-            <a:r>
-              <a:t>POTŘEBY → FUNKCE</a:t>
-            </a:r>
-          </a:p>
-        </p:txBody>
-      </p:sp>
-      <p:sp>
-        <p:nvSpPr>
-          <p:cNvPr id="8" name="Rectangle 7"/>
+                <a:spcPts val="3740"/>
+              </a:lnSpc>
+              <a:spcAft>
+                <a:spcPts val="0"/>
+              </a:spcAft>
+              <a:defRPr sz="3400" b="1">
+                <a:solidFill>
+                  <a:srgbClr val="181817"/>
+                </a:solidFill>
+                <a:latin typeface="Arial"/>
+              </a:defRPr>
+            </a:pPr>
+            <a:r>
+              <a:t>Pro koho web připravujeme?</a:t>
+            </a:r>
+          </a:p>
+        </p:txBody>
+      </p:sp>
+      <p:sp>
+        <p:nvSpPr>
+          <p:cNvPr id="9" name="Rectangle 8"/>
           <p:cNvSpPr/>
           <p:nvPr/>
         </p:nvSpPr>
         <p:spPr>
           <a:xfrm>
-            <a:off x="533400" y="1155700"/>
-            <a:ext cx="11125200" cy="25400"/>
+            <a:off x="533400" y="2768600"/>
+            <a:ext cx="3556000" cy="2603500"/>
           </a:xfrm>
           <a:prstGeom prst="rect">
             <a:avLst/>
@@ -5941,48 +5897,6 @@
       </p:sp>
       <p:sp>
         <p:nvSpPr>
-          <p:cNvPr id="9" name="TextBox 8"/>
-          <p:cNvSpPr txBox="1"/>
-          <p:nvPr/>
-        </p:nvSpPr>
-        <p:spPr>
-          <a:xfrm>
-            <a:off x="508000" y="1422400"/>
-            <a:ext cx="11176000" cy="1079500"/>
-          </a:xfrm>
-          <a:prstGeom prst="rect">
-            <a:avLst/>
-          </a:prstGeom>
-          <a:noFill/>
-        </p:spPr>
-        <p:txBody>
-          <a:bodyPr wrap="none" lIns="0" rIns="0" tIns="0" bIns="0">
-            <a:spAutoFit/>
-          </a:bodyPr>
-          <a:lstStyle/>
-          <a:p>
-            <a:pPr>
-              <a:lnSpc>
-                <a:spcPts val="3740"/>
-              </a:lnSpc>
-              <a:spcAft>
-                <a:spcPts val="0"/>
-              </a:spcAft>
-              <a:defRPr sz="3400" b="1">
-                <a:solidFill>
-                  <a:srgbClr val="181817"/>
-                </a:solidFill>
-                <a:latin typeface="Arial"/>
-              </a:defRPr>
-            </a:pPr>
-            <a:r>
-              <a:t>Pro koho web připravujeme?</a:t>
-            </a:r>
-          </a:p>
-        </p:txBody>
-      </p:sp>
-      <p:sp>
-        <p:nvSpPr>
           <p:cNvPr id="10" name="Rectangle 9"/>
           <p:cNvSpPr/>
           <p:nvPr/>
@@ -5990,13 +5904,13 @@
         <p:spPr>
           <a:xfrm>
             <a:off x="533400" y="2768600"/>
-            <a:ext cx="3556000" cy="2603500"/>
+            <a:ext cx="3556000" cy="76200"/>
           </a:xfrm>
           <a:prstGeom prst="rect">
             <a:avLst/>
           </a:prstGeom>
           <a:solidFill>
-            <a:srgbClr val="181817"/>
+            <a:srgbClr val="F45E2B"/>
           </a:solidFill>
           <a:ln>
             <a:noFill/>
@@ -6026,20 +5940,177 @@
       </p:sp>
       <p:sp>
         <p:nvSpPr>
-          <p:cNvPr id="11" name="Rectangle 10"/>
+          <p:cNvPr id="11" name="TextBox 10"/>
+          <p:cNvSpPr txBox="1"/>
+          <p:nvPr/>
+        </p:nvSpPr>
+        <p:spPr>
+          <a:xfrm>
+            <a:off x="749300" y="3035300"/>
+            <a:ext cx="3124200" cy="685800"/>
+          </a:xfrm>
+          <a:prstGeom prst="rect">
+            <a:avLst/>
+          </a:prstGeom>
+          <a:noFill/>
+        </p:spPr>
+        <p:txBody>
+          <a:bodyPr wrap="none" lIns="0" rIns="0" tIns="0" bIns="0">
+            <a:spAutoFit/>
+          </a:bodyPr>
+          <a:lstStyle/>
+          <a:p>
+            <a:pPr>
+              <a:lnSpc>
+                <a:spcPts val="2200"/>
+              </a:lnSpc>
+              <a:spcAft>
+                <a:spcPts val="0"/>
+              </a:spcAft>
+              <a:defRPr sz="2000" b="1">
+                <a:solidFill>
+                  <a:srgbClr val="F4F0E7"/>
+                </a:solidFill>
+                <a:latin typeface="Arial"/>
+              </a:defRPr>
+            </a:pPr>
+            <a:r>
+              <a:t>Na cestě</a:t>
+            </a:r>
+          </a:p>
+        </p:txBody>
+      </p:sp>
+      <p:sp>
+        <p:nvSpPr>
+          <p:cNvPr id="12" name="TextBox 11"/>
+          <p:cNvSpPr txBox="1"/>
+          <p:nvPr/>
+        </p:nvSpPr>
+        <p:spPr>
+          <a:xfrm>
+            <a:off x="749300" y="3733800"/>
+            <a:ext cx="3124200" cy="1511300"/>
+          </a:xfrm>
+          <a:prstGeom prst="rect">
+            <a:avLst/>
+          </a:prstGeom>
+          <a:noFill/>
+        </p:spPr>
+        <p:txBody>
+          <a:bodyPr wrap="none" lIns="0" rIns="0" tIns="0" bIns="0">
+            <a:spAutoFit/>
+          </a:bodyPr>
+          <a:lstStyle/>
+          <a:p>
+            <a:pPr>
+              <a:lnSpc>
+                <a:spcPts val="1689"/>
+              </a:lnSpc>
+              <a:spcAft>
+                <a:spcPts val="0"/>
+              </a:spcAft>
+              <a:defRPr sz="1420" b="0">
+                <a:solidFill>
+                  <a:srgbClr val="F4F0E7"/>
+                </a:solidFill>
+                <a:latin typeface="Arial"/>
+              </a:defRPr>
+            </a:pPr>
+            <a:r>
+              <a:t>Mobilní návštěvník potřebuje čas</a:t>
+            </a:r>
+          </a:p>
+          <a:p>
+            <a:pPr>
+              <a:lnSpc>
+                <a:spcPts val="1689"/>
+              </a:lnSpc>
+              <a:spcAft>
+                <a:spcPts val="0"/>
+              </a:spcAft>
+              <a:defRPr sz="1420" b="0">
+                <a:solidFill>
+                  <a:srgbClr val="F4F0E7"/>
+                </a:solidFill>
+                <a:latin typeface="Arial"/>
+              </a:defRPr>
+            </a:pPr>
+            <a:r>
+              <a:t>a scénu bez procházení celého</a:t>
+            </a:r>
+          </a:p>
+          <a:p>
+            <a:pPr>
+              <a:lnSpc>
+                <a:spcPts val="1689"/>
+              </a:lnSpc>
+              <a:spcAft>
+                <a:spcPts val="0"/>
+              </a:spcAft>
+              <a:defRPr sz="1420" b="0">
+                <a:solidFill>
+                  <a:srgbClr val="F4F0E7"/>
+                </a:solidFill>
+                <a:latin typeface="Arial"/>
+              </a:defRPr>
+            </a:pPr>
+            <a:r>
+              <a:t>webu.</a:t>
+            </a:r>
+          </a:p>
+          <a:p>
+            <a:pPr>
+              <a:lnSpc>
+                <a:spcPts val="1689"/>
+              </a:lnSpc>
+              <a:spcAft>
+                <a:spcPts val="0"/>
+              </a:spcAft>
+              <a:defRPr sz="1420" b="0">
+                <a:solidFill>
+                  <a:srgbClr val="F4F0E7"/>
+                </a:solidFill>
+                <a:latin typeface="Arial"/>
+              </a:defRPr>
+            </a:pPr>
+          </a:p>
+          <a:p>
+            <a:pPr>
+              <a:lnSpc>
+                <a:spcPts val="1689"/>
+              </a:lnSpc>
+              <a:spcAft>
+                <a:spcPts val="0"/>
+              </a:spcAft>
+              <a:defRPr sz="1420" b="0">
+                <a:solidFill>
+                  <a:srgbClr val="F4F0E7"/>
+                </a:solidFill>
+                <a:latin typeface="Arial"/>
+              </a:defRPr>
+            </a:pPr>
+            <a:r>
+              <a:t>Filtry programu a osobní výběr.</a:t>
+            </a:r>
+          </a:p>
+        </p:txBody>
+      </p:sp>
+      <p:sp>
+        <p:nvSpPr>
+          <p:cNvPr id="13" name="Rectangle 12"/>
           <p:cNvSpPr/>
           <p:nvPr/>
         </p:nvSpPr>
         <p:spPr>
           <a:xfrm>
-            <a:off x="533400" y="2768600"/>
-            <a:ext cx="3556000" cy="76200"/>
+            <a:off x="4318000" y="2768600"/>
+            <a:ext cx="3556000" cy="2603500"/>
           </a:xfrm>
           <a:prstGeom prst="rect">
             <a:avLst/>
           </a:prstGeom>
           <a:solidFill>
-            <a:srgbClr val="F45E2B"/>
+            <a:srgbClr val="E7E0D5"/>
           </a:solidFill>
           <a:ln>
             <a:noFill/>
@@ -6069,163 +6140,6 @@
       </p:sp>
       <p:sp>
         <p:nvSpPr>
-          <p:cNvPr id="12" name="TextBox 11"/>
-          <p:cNvSpPr txBox="1"/>
-          <p:nvPr/>
-        </p:nvSpPr>
-        <p:spPr>
-          <a:xfrm>
-            <a:off x="749300" y="3035300"/>
-            <a:ext cx="3124200" cy="685800"/>
-          </a:xfrm>
-          <a:prstGeom prst="rect">
-            <a:avLst/>
-          </a:prstGeom>
-          <a:noFill/>
-        </p:spPr>
-        <p:txBody>
-          <a:bodyPr wrap="none" lIns="0" rIns="0" tIns="0" bIns="0">
-            <a:spAutoFit/>
-          </a:bodyPr>
-          <a:lstStyle/>
-          <a:p>
-            <a:pPr>
-              <a:lnSpc>
-                <a:spcPts val="2200"/>
-              </a:lnSpc>
-              <a:spcAft>
-                <a:spcPts val="0"/>
-              </a:spcAft>
-              <a:defRPr sz="2000" b="1">
-                <a:solidFill>
-                  <a:srgbClr val="F4F0E7"/>
-                </a:solidFill>
-                <a:latin typeface="Arial"/>
-              </a:defRPr>
-            </a:pPr>
-            <a:r>
-              <a:t>Na cestě</a:t>
-            </a:r>
-          </a:p>
-        </p:txBody>
-      </p:sp>
-      <p:sp>
-        <p:nvSpPr>
-          <p:cNvPr id="13" name="TextBox 12"/>
-          <p:cNvSpPr txBox="1"/>
-          <p:nvPr/>
-        </p:nvSpPr>
-        <p:spPr>
-          <a:xfrm>
-            <a:off x="749300" y="3733800"/>
-            <a:ext cx="3124200" cy="1511300"/>
-          </a:xfrm>
-          <a:prstGeom prst="rect">
-            <a:avLst/>
-          </a:prstGeom>
-          <a:noFill/>
-        </p:spPr>
-        <p:txBody>
-          <a:bodyPr wrap="none" lIns="0" rIns="0" tIns="0" bIns="0">
-            <a:spAutoFit/>
-          </a:bodyPr>
-          <a:lstStyle/>
-          <a:p>
-            <a:pPr>
-              <a:lnSpc>
-                <a:spcPts val="1689"/>
-              </a:lnSpc>
-              <a:spcAft>
-                <a:spcPts val="0"/>
-              </a:spcAft>
-              <a:defRPr sz="1420" b="0">
-                <a:solidFill>
-                  <a:srgbClr val="F4F0E7"/>
-                </a:solidFill>
-                <a:latin typeface="Arial"/>
-              </a:defRPr>
-            </a:pPr>
-            <a:r>
-              <a:t>Mobilní návštěvník potřebuje čas</a:t>
-            </a:r>
-          </a:p>
-          <a:p>
-            <a:pPr>
-              <a:lnSpc>
-                <a:spcPts val="1689"/>
-              </a:lnSpc>
-              <a:spcAft>
-                <a:spcPts val="0"/>
-              </a:spcAft>
-              <a:defRPr sz="1420" b="0">
-                <a:solidFill>
-                  <a:srgbClr val="F4F0E7"/>
-                </a:solidFill>
-                <a:latin typeface="Arial"/>
-              </a:defRPr>
-            </a:pPr>
-            <a:r>
-              <a:t>a scénu bez procházení celého</a:t>
-            </a:r>
-          </a:p>
-          <a:p>
-            <a:pPr>
-              <a:lnSpc>
-                <a:spcPts val="1689"/>
-              </a:lnSpc>
-              <a:spcAft>
-                <a:spcPts val="0"/>
-              </a:spcAft>
-              <a:defRPr sz="1420" b="0">
-                <a:solidFill>
-                  <a:srgbClr val="F4F0E7"/>
-                </a:solidFill>
-                <a:latin typeface="Arial"/>
-              </a:defRPr>
-            </a:pPr>
-            <a:r>
-              <a:t>webu.</a:t>
-            </a:r>
-          </a:p>
-          <a:p>
-            <a:pPr>
-              <a:lnSpc>
-                <a:spcPts val="1689"/>
-              </a:lnSpc>
-              <a:spcAft>
-                <a:spcPts val="0"/>
-              </a:spcAft>
-              <a:defRPr sz="1420" b="0">
-                <a:solidFill>
-                  <a:srgbClr val="F4F0E7"/>
-                </a:solidFill>
-                <a:latin typeface="Arial"/>
-              </a:defRPr>
-            </a:pPr>
-          </a:p>
-          <a:p>
-            <a:pPr>
-              <a:lnSpc>
-                <a:spcPts val="1689"/>
-              </a:lnSpc>
-              <a:spcAft>
-                <a:spcPts val="0"/>
-              </a:spcAft>
-              <a:defRPr sz="1420" b="0">
-                <a:solidFill>
-                  <a:srgbClr val="F4F0E7"/>
-                </a:solidFill>
-                <a:latin typeface="Arial"/>
-              </a:defRPr>
-            </a:pPr>
-            <a:r>
-              <a:t>Filtry programu a osobní výběr.</a:t>
-            </a:r>
-          </a:p>
-        </p:txBody>
-      </p:sp>
-      <p:sp>
-        <p:nvSpPr>
           <p:cNvPr id="14" name="Rectangle 13"/>
           <p:cNvSpPr/>
           <p:nvPr/>
@@ -6233,13 +6147,13 @@
         <p:spPr>
           <a:xfrm>
             <a:off x="4318000" y="2768600"/>
-            <a:ext cx="3556000" cy="2603500"/>
+            <a:ext cx="3556000" cy="76200"/>
           </a:xfrm>
           <a:prstGeom prst="rect">
             <a:avLst/>
           </a:prstGeom>
           <a:solidFill>
-            <a:srgbClr val="E7E0D5"/>
+            <a:srgbClr val="F45E2B"/>
           </a:solidFill>
           <a:ln>
             <a:noFill/>
@@ -6269,20 +6183,177 @@
       </p:sp>
       <p:sp>
         <p:nvSpPr>
-          <p:cNvPr id="15" name="Rectangle 14"/>
+          <p:cNvPr id="15" name="TextBox 14"/>
+          <p:cNvSpPr txBox="1"/>
+          <p:nvPr/>
+        </p:nvSpPr>
+        <p:spPr>
+          <a:xfrm>
+            <a:off x="4533900" y="3035300"/>
+            <a:ext cx="3124200" cy="685800"/>
+          </a:xfrm>
+          <a:prstGeom prst="rect">
+            <a:avLst/>
+          </a:prstGeom>
+          <a:noFill/>
+        </p:spPr>
+        <p:txBody>
+          <a:bodyPr wrap="none" lIns="0" rIns="0" tIns="0" bIns="0">
+            <a:spAutoFit/>
+          </a:bodyPr>
+          <a:lstStyle/>
+          <a:p>
+            <a:pPr>
+              <a:lnSpc>
+                <a:spcPts val="2200"/>
+              </a:lnSpc>
+              <a:spcAft>
+                <a:spcPts val="0"/>
+              </a:spcAft>
+              <a:defRPr sz="2000" b="1">
+                <a:solidFill>
+                  <a:srgbClr val="181817"/>
+                </a:solidFill>
+                <a:latin typeface="Arial"/>
+              </a:defRPr>
+            </a:pPr>
+            <a:r>
+              <a:t>Za konkrétní kapelou</a:t>
+            </a:r>
+          </a:p>
+        </p:txBody>
+      </p:sp>
+      <p:sp>
+        <p:nvSpPr>
+          <p:cNvPr id="16" name="TextBox 15"/>
+          <p:cNvSpPr txBox="1"/>
+          <p:nvPr/>
+        </p:nvSpPr>
+        <p:spPr>
+          <a:xfrm>
+            <a:off x="4533900" y="3733800"/>
+            <a:ext cx="3124200" cy="1511300"/>
+          </a:xfrm>
+          <a:prstGeom prst="rect">
+            <a:avLst/>
+          </a:prstGeom>
+          <a:noFill/>
+        </p:spPr>
+        <p:txBody>
+          <a:bodyPr wrap="none" lIns="0" rIns="0" tIns="0" bIns="0">
+            <a:spAutoFit/>
+          </a:bodyPr>
+          <a:lstStyle/>
+          <a:p>
+            <a:pPr>
+              <a:lnSpc>
+                <a:spcPts val="1689"/>
+              </a:lnSpc>
+              <a:spcAft>
+                <a:spcPts val="0"/>
+              </a:spcAft>
+              <a:defRPr sz="1420" b="0">
+                <a:solidFill>
+                  <a:srgbClr val="181817"/>
+                </a:solidFill>
+                <a:latin typeface="Arial"/>
+              </a:defRPr>
+            </a:pPr>
+            <a:r>
+              <a:t>Fanoušek zná část názvu,</a:t>
+            </a:r>
+          </a:p>
+          <a:p>
+            <a:pPr>
+              <a:lnSpc>
+                <a:spcPts val="1689"/>
+              </a:lnSpc>
+              <a:spcAft>
+                <a:spcPts val="0"/>
+              </a:spcAft>
+              <a:defRPr sz="1420" b="0">
+                <a:solidFill>
+                  <a:srgbClr val="181817"/>
+                </a:solidFill>
+                <a:latin typeface="Arial"/>
+              </a:defRPr>
+            </a:pPr>
+            <a:r>
+              <a:t>potřebuje zjistit, kdy kapela hraje.</a:t>
+            </a:r>
+          </a:p>
+          <a:p>
+            <a:pPr>
+              <a:lnSpc>
+                <a:spcPts val="1689"/>
+              </a:lnSpc>
+              <a:spcAft>
+                <a:spcPts val="0"/>
+              </a:spcAft>
+              <a:defRPr sz="1420" b="0">
+                <a:solidFill>
+                  <a:srgbClr val="181817"/>
+                </a:solidFill>
+                <a:latin typeface="Arial"/>
+              </a:defRPr>
+            </a:pPr>
+          </a:p>
+          <a:p>
+            <a:pPr>
+              <a:lnSpc>
+                <a:spcPts val="1689"/>
+              </a:lnSpc>
+              <a:spcAft>
+                <a:spcPts val="0"/>
+              </a:spcAft>
+              <a:defRPr sz="1420" b="0">
+                <a:solidFill>
+                  <a:srgbClr val="181817"/>
+                </a:solidFill>
+                <a:latin typeface="Arial"/>
+              </a:defRPr>
+            </a:pPr>
+            <a:r>
+              <a:t>Hledání, detail a související</a:t>
+            </a:r>
+          </a:p>
+          <a:p>
+            <a:pPr>
+              <a:lnSpc>
+                <a:spcPts val="1689"/>
+              </a:lnSpc>
+              <a:spcAft>
+                <a:spcPts val="0"/>
+              </a:spcAft>
+              <a:defRPr sz="1420" b="0">
+                <a:solidFill>
+                  <a:srgbClr val="181817"/>
+                </a:solidFill>
+                <a:latin typeface="Arial"/>
+              </a:defRPr>
+            </a:pPr>
+            <a:r>
+              <a:t>koncert.</a:t>
+            </a:r>
+          </a:p>
+        </p:txBody>
+      </p:sp>
+      <p:sp>
+        <p:nvSpPr>
+          <p:cNvPr id="17" name="Rectangle 16"/>
           <p:cNvSpPr/>
           <p:nvPr/>
         </p:nvSpPr>
         <p:spPr>
           <a:xfrm>
-            <a:off x="4318000" y="2768600"/>
-            <a:ext cx="3556000" cy="76200"/>
+            <a:off x="8102600" y="2768600"/>
+            <a:ext cx="3556000" cy="2603500"/>
           </a:xfrm>
           <a:prstGeom prst="rect">
             <a:avLst/>
           </a:prstGeom>
           <a:solidFill>
-            <a:srgbClr val="F45E2B"/>
+            <a:srgbClr val="E7E0D5"/>
           </a:solidFill>
           <a:ln>
             <a:noFill/>
@@ -6312,163 +6383,6 @@
       </p:sp>
       <p:sp>
         <p:nvSpPr>
-          <p:cNvPr id="16" name="TextBox 15"/>
-          <p:cNvSpPr txBox="1"/>
-          <p:nvPr/>
-        </p:nvSpPr>
-        <p:spPr>
-          <a:xfrm>
-            <a:off x="4533900" y="3035300"/>
-            <a:ext cx="3124200" cy="685800"/>
-          </a:xfrm>
-          <a:prstGeom prst="rect">
-            <a:avLst/>
-          </a:prstGeom>
-          <a:noFill/>
-        </p:spPr>
-        <p:txBody>
-          <a:bodyPr wrap="none" lIns="0" rIns="0" tIns="0" bIns="0">
-            <a:spAutoFit/>
-          </a:bodyPr>
-          <a:lstStyle/>
-          <a:p>
-            <a:pPr>
-              <a:lnSpc>
-                <a:spcPts val="2200"/>
-              </a:lnSpc>
-              <a:spcAft>
-                <a:spcPts val="0"/>
-              </a:spcAft>
-              <a:defRPr sz="2000" b="1">
-                <a:solidFill>
-                  <a:srgbClr val="181817"/>
-                </a:solidFill>
-                <a:latin typeface="Arial"/>
-              </a:defRPr>
-            </a:pPr>
-            <a:r>
-              <a:t>Za konkrétní kapelou</a:t>
-            </a:r>
-          </a:p>
-        </p:txBody>
-      </p:sp>
-      <p:sp>
-        <p:nvSpPr>
-          <p:cNvPr id="17" name="TextBox 16"/>
-          <p:cNvSpPr txBox="1"/>
-          <p:nvPr/>
-        </p:nvSpPr>
-        <p:spPr>
-          <a:xfrm>
-            <a:off x="4533900" y="3733800"/>
-            <a:ext cx="3124200" cy="1511300"/>
-          </a:xfrm>
-          <a:prstGeom prst="rect">
-            <a:avLst/>
-          </a:prstGeom>
-          <a:noFill/>
-        </p:spPr>
-        <p:txBody>
-          <a:bodyPr wrap="none" lIns="0" rIns="0" tIns="0" bIns="0">
-            <a:spAutoFit/>
-          </a:bodyPr>
-          <a:lstStyle/>
-          <a:p>
-            <a:pPr>
-              <a:lnSpc>
-                <a:spcPts val="1689"/>
-              </a:lnSpc>
-              <a:spcAft>
-                <a:spcPts val="0"/>
-              </a:spcAft>
-              <a:defRPr sz="1420" b="0">
-                <a:solidFill>
-                  <a:srgbClr val="181817"/>
-                </a:solidFill>
-                <a:latin typeface="Arial"/>
-              </a:defRPr>
-            </a:pPr>
-            <a:r>
-              <a:t>Fanoušek zná část názvu,</a:t>
-            </a:r>
-          </a:p>
-          <a:p>
-            <a:pPr>
-              <a:lnSpc>
-                <a:spcPts val="1689"/>
-              </a:lnSpc>
-              <a:spcAft>
-                <a:spcPts val="0"/>
-              </a:spcAft>
-              <a:defRPr sz="1420" b="0">
-                <a:solidFill>
-                  <a:srgbClr val="181817"/>
-                </a:solidFill>
-                <a:latin typeface="Arial"/>
-              </a:defRPr>
-            </a:pPr>
-            <a:r>
-              <a:t>potřebuje zjistit, kdy kapela hraje.</a:t>
-            </a:r>
-          </a:p>
-          <a:p>
-            <a:pPr>
-              <a:lnSpc>
-                <a:spcPts val="1689"/>
-              </a:lnSpc>
-              <a:spcAft>
-                <a:spcPts val="0"/>
-              </a:spcAft>
-              <a:defRPr sz="1420" b="0">
-                <a:solidFill>
-                  <a:srgbClr val="181817"/>
-                </a:solidFill>
-                <a:latin typeface="Arial"/>
-              </a:defRPr>
-            </a:pPr>
-          </a:p>
-          <a:p>
-            <a:pPr>
-              <a:lnSpc>
-                <a:spcPts val="1689"/>
-              </a:lnSpc>
-              <a:spcAft>
-                <a:spcPts val="0"/>
-              </a:spcAft>
-              <a:defRPr sz="1420" b="0">
-                <a:solidFill>
-                  <a:srgbClr val="181817"/>
-                </a:solidFill>
-                <a:latin typeface="Arial"/>
-              </a:defRPr>
-            </a:pPr>
-            <a:r>
-              <a:t>Hledání, detail a související</a:t>
-            </a:r>
-          </a:p>
-          <a:p>
-            <a:pPr>
-              <a:lnSpc>
-                <a:spcPts val="1689"/>
-              </a:lnSpc>
-              <a:spcAft>
-                <a:spcPts val="0"/>
-              </a:spcAft>
-              <a:defRPr sz="1420" b="0">
-                <a:solidFill>
-                  <a:srgbClr val="181817"/>
-                </a:solidFill>
-                <a:latin typeface="Arial"/>
-              </a:defRPr>
-            </a:pPr>
-            <a:r>
-              <a:t>koncert.</a:t>
-            </a:r>
-          </a:p>
-        </p:txBody>
-      </p:sp>
-      <p:sp>
-        <p:nvSpPr>
           <p:cNvPr id="18" name="Rectangle 17"/>
           <p:cNvSpPr/>
           <p:nvPr/>
@@ -6476,13 +6390,13 @@
         <p:spPr>
           <a:xfrm>
             <a:off x="8102600" y="2768600"/>
-            <a:ext cx="3556000" cy="2603500"/>
+            <a:ext cx="3556000" cy="76200"/>
           </a:xfrm>
           <a:prstGeom prst="rect">
             <a:avLst/>
           </a:prstGeom>
           <a:solidFill>
-            <a:srgbClr val="E7E0D5"/>
+            <a:srgbClr val="F45E2B"/>
           </a:solidFill>
           <a:ln>
             <a:noFill/>
@@ -6512,50 +6426,7 @@
       </p:sp>
       <p:sp>
         <p:nvSpPr>
-          <p:cNvPr id="19" name="Rectangle 18"/>
-          <p:cNvSpPr/>
-          <p:nvPr/>
-        </p:nvSpPr>
-        <p:spPr>
-          <a:xfrm>
-            <a:off x="8102600" y="2768600"/>
-            <a:ext cx="3556000" cy="76200"/>
-          </a:xfrm>
-          <a:prstGeom prst="rect">
-            <a:avLst/>
-          </a:prstGeom>
-          <a:solidFill>
-            <a:srgbClr val="F45E2B"/>
-          </a:solidFill>
-          <a:ln>
-            <a:noFill/>
-          </a:ln>
-        </p:spPr>
-        <p:style>
-          <a:lnRef idx="1">
-            <a:schemeClr val="accent1"/>
-          </a:lnRef>
-          <a:fillRef idx="3">
-            <a:schemeClr val="accent1"/>
-          </a:fillRef>
-          <a:effectRef idx="2">
-            <a:schemeClr val="accent1"/>
-          </a:effectRef>
-          <a:fontRef idx="minor">
-            <a:schemeClr val="lt1"/>
-          </a:fontRef>
-        </p:style>
-        <p:txBody>
-          <a:bodyPr rtlCol="0" anchor="ctr"/>
-          <a:lstStyle/>
-          <a:p>
-            <a:pPr algn="ctr"/>
-          </a:p>
-        </p:txBody>
-      </p:sp>
-      <p:sp>
-        <p:nvSpPr>
-          <p:cNvPr id="20" name="TextBox 19"/>
+          <p:cNvPr id="19" name="TextBox 18"/>
           <p:cNvSpPr txBox="1"/>
           <p:nvPr/>
         </p:nvSpPr>
@@ -6597,7 +6468,7 @@
       </p:sp>
       <p:sp>
         <p:nvSpPr>
-          <p:cNvPr id="21" name="TextBox 20"/>
+          <p:cNvPr id="20" name="TextBox 19"/>
           <p:cNvSpPr txBox="1"/>
           <p:nvPr/>
         </p:nvSpPr>
@@ -6693,7 +6564,7 @@
       </p:sp>
       <p:sp>
         <p:nvSpPr>
-          <p:cNvPr id="22" name="TextBox 21"/>
+          <p:cNvPr id="21" name="TextBox 20"/>
           <p:cNvSpPr txBox="1"/>
           <p:nvPr/>
         </p:nvSpPr>
@@ -6735,7 +6606,7 @@
       </p:sp>
       <p:sp>
         <p:nvSpPr>
-          <p:cNvPr id="23" name="TextBox 22"/>
+          <p:cNvPr id="22" name="TextBox 21"/>
           <p:cNvSpPr txBox="1"/>
           <p:nvPr/>
         </p:nvSpPr>
@@ -6964,20 +6835,62 @@
       </p:sp>
       <p:sp>
         <p:nvSpPr>
-          <p:cNvPr id="6" name="Rectangle 5"/>
+          <p:cNvPr id="6" name="TextBox 5"/>
+          <p:cNvSpPr txBox="1"/>
+          <p:nvPr/>
+        </p:nvSpPr>
+        <p:spPr>
+          <a:xfrm>
+            <a:off x="5588000" y="533400"/>
+            <a:ext cx="6070600" cy="220979"/>
+          </a:xfrm>
+          <a:prstGeom prst="rect">
+            <a:avLst/>
+          </a:prstGeom>
+          <a:noFill/>
+        </p:spPr>
+        <p:txBody>
+          <a:bodyPr wrap="none" lIns="0" rIns="0" tIns="0" bIns="0">
+            <a:spAutoFit/>
+          </a:bodyPr>
+          <a:lstStyle/>
+          <a:p>
+            <a:pPr>
+              <a:lnSpc>
+                <a:spcPts val="1240"/>
+              </a:lnSpc>
+              <a:spcAft>
+                <a:spcPts val="0"/>
+              </a:spcAft>
+              <a:defRPr sz="1000" b="1">
+                <a:solidFill>
+                  <a:srgbClr val="68635B"/>
+                </a:solidFill>
+                <a:latin typeface="Arial"/>
+              </a:defRPr>
+            </a:pPr>
+            <a:r>
+              <a:t>INFORMAČNÍ ARCHITEKTURA</a:t>
+            </a:r>
+          </a:p>
+        </p:txBody>
+      </p:sp>
+      <p:sp>
+        <p:nvSpPr>
+          <p:cNvPr id="7" name="Rectangle 6"/>
           <p:cNvSpPr/>
           <p:nvPr/>
         </p:nvSpPr>
         <p:spPr>
           <a:xfrm>
-            <a:off x="1866900" y="368300"/>
-            <a:ext cx="88900" cy="431800"/>
+            <a:off x="533400" y="1155700"/>
+            <a:ext cx="11125200" cy="25400"/>
           </a:xfrm>
           <a:prstGeom prst="rect">
             <a:avLst/>
           </a:prstGeom>
           <a:solidFill>
-            <a:srgbClr val="F45E2B"/>
+            <a:srgbClr val="181817"/>
           </a:solidFill>
           <a:ln>
             <a:noFill/>
@@ -7007,14 +6920,14 @@
       </p:sp>
       <p:sp>
         <p:nvSpPr>
-          <p:cNvPr id="7" name="TextBox 6"/>
+          <p:cNvPr id="8" name="TextBox 7"/>
           <p:cNvSpPr txBox="1"/>
           <p:nvPr/>
         </p:nvSpPr>
         <p:spPr>
           <a:xfrm>
-            <a:off x="5588000" y="533400"/>
-            <a:ext cx="6070600" cy="220979"/>
+            <a:off x="508000" y="1422400"/>
+            <a:ext cx="11176000" cy="1079500"/>
           </a:xfrm>
           <a:prstGeom prst="rect">
             <a:avLst/>
@@ -7029,34 +6942,34 @@
           <a:p>
             <a:pPr>
               <a:lnSpc>
-                <a:spcPts val="1240"/>
-              </a:lnSpc>
-              <a:spcAft>
-                <a:spcPts val="0"/>
-              </a:spcAft>
-              <a:defRPr sz="1000" b="1">
-                <a:solidFill>
-                  <a:srgbClr val="68635B"/>
-                </a:solidFill>
-                <a:latin typeface="Arial"/>
-              </a:defRPr>
-            </a:pPr>
-            <a:r>
-              <a:t>INFORMAČNÍ ARCHITEKTURA</a:t>
-            </a:r>
-          </a:p>
-        </p:txBody>
-      </p:sp>
-      <p:sp>
-        <p:nvSpPr>
-          <p:cNvPr id="8" name="Rectangle 7"/>
+                <a:spcPts val="3740"/>
+              </a:lnSpc>
+              <a:spcAft>
+                <a:spcPts val="0"/>
+              </a:spcAft>
+              <a:defRPr sz="3400" b="1">
+                <a:solidFill>
+                  <a:srgbClr val="181817"/>
+                </a:solidFill>
+                <a:latin typeface="Arial"/>
+              </a:defRPr>
+            </a:pPr>
+            <a:r>
+              <a:t>Obsah má konkrétní vazby.</a:t>
+            </a:r>
+          </a:p>
+        </p:txBody>
+      </p:sp>
+      <p:sp>
+        <p:nvSpPr>
+          <p:cNvPr id="9" name="Rectangle 8"/>
           <p:cNvSpPr/>
           <p:nvPr/>
         </p:nvSpPr>
         <p:spPr>
           <a:xfrm>
-            <a:off x="533400" y="1155700"/>
-            <a:ext cx="11125200" cy="25400"/>
+            <a:off x="533400" y="2946400"/>
+            <a:ext cx="2552700" cy="1765300"/>
           </a:xfrm>
           <a:prstGeom prst="rect">
             <a:avLst/>
@@ -7092,14 +7005,14 @@
       </p:sp>
       <p:sp>
         <p:nvSpPr>
-          <p:cNvPr id="9" name="TextBox 8"/>
+          <p:cNvPr id="10" name="TextBox 9"/>
           <p:cNvSpPr txBox="1"/>
           <p:nvPr/>
         </p:nvSpPr>
         <p:spPr>
           <a:xfrm>
-            <a:off x="508000" y="1422400"/>
-            <a:ext cx="11176000" cy="1079500"/>
+            <a:off x="723900" y="3162300"/>
+            <a:ext cx="2133600" cy="236728"/>
           </a:xfrm>
           <a:prstGeom prst="rect">
             <a:avLst/>
@@ -7114,12 +7027,138 @@
           <a:p>
             <a:pPr>
               <a:lnSpc>
-                <a:spcPts val="3740"/>
-              </a:lnSpc>
-              <a:spcAft>
-                <a:spcPts val="0"/>
-              </a:spcAft>
-              <a:defRPr sz="3400" b="1">
+                <a:spcPts val="1364"/>
+              </a:lnSpc>
+              <a:spcAft>
+                <a:spcPts val="0"/>
+              </a:spcAft>
+              <a:defRPr sz="1100" b="1">
+                <a:solidFill>
+                  <a:srgbClr val="F45E2B"/>
+                </a:solidFill>
+                <a:latin typeface="Arial"/>
+              </a:defRPr>
+            </a:pPr>
+            <a:r>
+              <a:t>01</a:t>
+            </a:r>
+          </a:p>
+        </p:txBody>
+      </p:sp>
+      <p:sp>
+        <p:nvSpPr>
+          <p:cNvPr id="11" name="TextBox 10"/>
+          <p:cNvSpPr txBox="1"/>
+          <p:nvPr/>
+        </p:nvSpPr>
+        <p:spPr>
+          <a:xfrm>
+            <a:off x="723900" y="3568700"/>
+            <a:ext cx="2133600" cy="444500"/>
+          </a:xfrm>
+          <a:prstGeom prst="rect">
+            <a:avLst/>
+          </a:prstGeom>
+          <a:noFill/>
+        </p:spPr>
+        <p:txBody>
+          <a:bodyPr wrap="none" lIns="0" rIns="0" tIns="0" bIns="0">
+            <a:spAutoFit/>
+          </a:bodyPr>
+          <a:lstStyle/>
+          <a:p>
+            <a:pPr>
+              <a:lnSpc>
+                <a:spcPts val="2728"/>
+              </a:lnSpc>
+              <a:spcAft>
+                <a:spcPts val="0"/>
+              </a:spcAft>
+              <a:defRPr sz="2200" b="1">
+                <a:solidFill>
+                  <a:srgbClr val="F4F0E7"/>
+                </a:solidFill>
+                <a:latin typeface="Arial"/>
+              </a:defRPr>
+            </a:pPr>
+            <a:r>
+              <a:t>Úvod</a:t>
+            </a:r>
+          </a:p>
+        </p:txBody>
+      </p:sp>
+      <p:sp>
+        <p:nvSpPr>
+          <p:cNvPr id="12" name="TextBox 11"/>
+          <p:cNvSpPr txBox="1"/>
+          <p:nvPr/>
+        </p:nvSpPr>
+        <p:spPr>
+          <a:xfrm>
+            <a:off x="723900" y="4140200"/>
+            <a:ext cx="2133600" cy="406400"/>
+          </a:xfrm>
+          <a:prstGeom prst="rect">
+            <a:avLst/>
+          </a:prstGeom>
+          <a:noFill/>
+        </p:spPr>
+        <p:txBody>
+          <a:bodyPr wrap="none" lIns="0" rIns="0" tIns="0" bIns="0">
+            <a:spAutoFit/>
+          </a:bodyPr>
+          <a:lstStyle/>
+          <a:p>
+            <a:pPr>
+              <a:lnSpc>
+                <a:spcPts val="1488"/>
+              </a:lnSpc>
+              <a:spcAft>
+                <a:spcPts val="0"/>
+              </a:spcAft>
+              <a:defRPr sz="1200" b="0">
+                <a:solidFill>
+                  <a:srgbClr val="F4F0E7"/>
+                </a:solidFill>
+                <a:latin typeface="Arial"/>
+              </a:defRPr>
+            </a:pPr>
+            <a:r>
+              <a:t>Identita + datum</a:t>
+            </a:r>
+          </a:p>
+        </p:txBody>
+      </p:sp>
+      <p:sp>
+        <p:nvSpPr>
+          <p:cNvPr id="13" name="TextBox 12"/>
+          <p:cNvSpPr txBox="1"/>
+          <p:nvPr/>
+        </p:nvSpPr>
+        <p:spPr>
+          <a:xfrm>
+            <a:off x="3098800" y="3657600"/>
+            <a:ext cx="292100" cy="394208"/>
+          </a:xfrm>
+          <a:prstGeom prst="rect">
+            <a:avLst/>
+          </a:prstGeom>
+          <a:noFill/>
+        </p:spPr>
+        <p:txBody>
+          <a:bodyPr wrap="none" lIns="0" rIns="0" tIns="0" bIns="0">
+            <a:spAutoFit/>
+          </a:bodyPr>
+          <a:lstStyle/>
+          <a:p>
+            <a:pPr>
+              <a:lnSpc>
+                <a:spcPts val="2604"/>
+              </a:lnSpc>
+              <a:spcAft>
+                <a:spcPts val="0"/>
+              </a:spcAft>
+              <a:defRPr sz="2100" b="1">
                 <a:solidFill>
                   <a:srgbClr val="181817"/>
                 </a:solidFill>
@@ -7127,27 +7166,27 @@
               </a:defRPr>
             </a:pPr>
             <a:r>
-              <a:t>Obsah má konkrétní vazby.</a:t>
-            </a:r>
-          </a:p>
-        </p:txBody>
-      </p:sp>
-      <p:sp>
-        <p:nvSpPr>
-          <p:cNvPr id="10" name="Rectangle 9"/>
+              <a:t>›</a:t>
+            </a:r>
+          </a:p>
+        </p:txBody>
+      </p:sp>
+      <p:sp>
+        <p:nvSpPr>
+          <p:cNvPr id="14" name="Rectangle 13"/>
           <p:cNvSpPr/>
           <p:nvPr/>
         </p:nvSpPr>
         <p:spPr>
           <a:xfrm>
-            <a:off x="533400" y="2946400"/>
+            <a:off x="3390900" y="2946400"/>
             <a:ext cx="2552700" cy="1765300"/>
           </a:xfrm>
           <a:prstGeom prst="rect">
             <a:avLst/>
           </a:prstGeom>
           <a:solidFill>
-            <a:srgbClr val="181817"/>
+            <a:srgbClr val="E7E0D5"/>
           </a:solidFill>
           <a:ln>
             <a:noFill/>
@@ -7177,13 +7216,13 @@
       </p:sp>
       <p:sp>
         <p:nvSpPr>
-          <p:cNvPr id="11" name="TextBox 10"/>
+          <p:cNvPr id="15" name="TextBox 14"/>
           <p:cNvSpPr txBox="1"/>
           <p:nvPr/>
         </p:nvSpPr>
         <p:spPr>
           <a:xfrm>
-            <a:off x="723900" y="3162300"/>
+            <a:off x="3581400" y="3162300"/>
             <a:ext cx="2133600" cy="236728"/>
           </a:xfrm>
           <a:prstGeom prst="rect">
@@ -7212,20 +7251,20 @@
               </a:defRPr>
             </a:pPr>
             <a:r>
-              <a:t>01</a:t>
-            </a:r>
-          </a:p>
-        </p:txBody>
-      </p:sp>
-      <p:sp>
-        <p:nvSpPr>
-          <p:cNvPr id="12" name="TextBox 11"/>
+              <a:t>02</a:t>
+            </a:r>
+          </a:p>
+        </p:txBody>
+      </p:sp>
+      <p:sp>
+        <p:nvSpPr>
+          <p:cNvPr id="16" name="TextBox 15"/>
           <p:cNvSpPr txBox="1"/>
           <p:nvPr/>
         </p:nvSpPr>
         <p:spPr>
           <a:xfrm>
-            <a:off x="723900" y="3568700"/>
+            <a:off x="3581400" y="3568700"/>
             <a:ext cx="2133600" cy="444500"/>
           </a:xfrm>
           <a:prstGeom prst="rect">
@@ -7248,26 +7287,26 @@
               </a:spcAft>
               <a:defRPr sz="2200" b="1">
                 <a:solidFill>
-                  <a:srgbClr val="F4F0E7"/>
-                </a:solidFill>
-                <a:latin typeface="Arial"/>
-              </a:defRPr>
-            </a:pPr>
-            <a:r>
-              <a:t>Úvod</a:t>
-            </a:r>
-          </a:p>
-        </p:txBody>
-      </p:sp>
-      <p:sp>
-        <p:nvSpPr>
-          <p:cNvPr id="13" name="TextBox 12"/>
+                  <a:srgbClr val="181817"/>
+                </a:solidFill>
+                <a:latin typeface="Arial"/>
+              </a:defRPr>
+            </a:pPr>
+            <a:r>
+              <a:t>Program</a:t>
+            </a:r>
+          </a:p>
+        </p:txBody>
+      </p:sp>
+      <p:sp>
+        <p:nvSpPr>
+          <p:cNvPr id="17" name="TextBox 16"/>
           <p:cNvSpPr txBox="1"/>
           <p:nvPr/>
         </p:nvSpPr>
         <p:spPr>
           <a:xfrm>
-            <a:off x="723900" y="4140200"/>
+            <a:off x="3581400" y="4140200"/>
             <a:ext cx="2133600" cy="406400"/>
           </a:xfrm>
           <a:prstGeom prst="rect">
@@ -7290,26 +7329,26 @@
               </a:spcAft>
               <a:defRPr sz="1200" b="0">
                 <a:solidFill>
-                  <a:srgbClr val="F4F0E7"/>
-                </a:solidFill>
-                <a:latin typeface="Arial"/>
-              </a:defRPr>
-            </a:pPr>
-            <a:r>
-              <a:t>Identita + datum</a:t>
-            </a:r>
-          </a:p>
-        </p:txBody>
-      </p:sp>
-      <p:sp>
-        <p:nvSpPr>
-          <p:cNvPr id="14" name="TextBox 13"/>
+                  <a:srgbClr val="181817"/>
+                </a:solidFill>
+                <a:latin typeface="Arial"/>
+              </a:defRPr>
+            </a:pPr>
+            <a:r>
+              <a:t>Den / scéna</a:t>
+            </a:r>
+          </a:p>
+        </p:txBody>
+      </p:sp>
+      <p:sp>
+        <p:nvSpPr>
+          <p:cNvPr id="18" name="TextBox 17"/>
           <p:cNvSpPr txBox="1"/>
           <p:nvPr/>
         </p:nvSpPr>
         <p:spPr>
           <a:xfrm>
-            <a:off x="3098800" y="3657600"/>
+            <a:off x="5956300" y="3657600"/>
             <a:ext cx="292100" cy="394208"/>
           </a:xfrm>
           <a:prstGeom prst="rect">
@@ -7345,13 +7384,13 @@
       </p:sp>
       <p:sp>
         <p:nvSpPr>
-          <p:cNvPr id="15" name="Rectangle 14"/>
+          <p:cNvPr id="19" name="Rectangle 18"/>
           <p:cNvSpPr/>
           <p:nvPr/>
         </p:nvSpPr>
         <p:spPr>
           <a:xfrm>
-            <a:off x="3390900" y="2946400"/>
+            <a:off x="6248400" y="2946400"/>
             <a:ext cx="2552700" cy="1765300"/>
           </a:xfrm>
           <a:prstGeom prst="rect">
@@ -7388,13 +7427,13 @@
       </p:sp>
       <p:sp>
         <p:nvSpPr>
-          <p:cNvPr id="16" name="TextBox 15"/>
+          <p:cNvPr id="20" name="TextBox 19"/>
           <p:cNvSpPr txBox="1"/>
           <p:nvPr/>
         </p:nvSpPr>
         <p:spPr>
           <a:xfrm>
-            <a:off x="3581400" y="3162300"/>
+            <a:off x="6438900" y="3162300"/>
             <a:ext cx="2133600" cy="236728"/>
           </a:xfrm>
           <a:prstGeom prst="rect">
@@ -7423,20 +7462,20 @@
               </a:defRPr>
             </a:pPr>
             <a:r>
-              <a:t>02</a:t>
-            </a:r>
-          </a:p>
-        </p:txBody>
-      </p:sp>
-      <p:sp>
-        <p:nvSpPr>
-          <p:cNvPr id="17" name="TextBox 16"/>
+              <a:t>03</a:t>
+            </a:r>
+          </a:p>
+        </p:txBody>
+      </p:sp>
+      <p:sp>
+        <p:nvSpPr>
+          <p:cNvPr id="21" name="TextBox 20"/>
           <p:cNvSpPr txBox="1"/>
           <p:nvPr/>
         </p:nvSpPr>
         <p:spPr>
           <a:xfrm>
-            <a:off x="3581400" y="3568700"/>
+            <a:off x="6438900" y="3568700"/>
             <a:ext cx="2133600" cy="444500"/>
           </a:xfrm>
           <a:prstGeom prst="rect">
@@ -7465,20 +7504,20 @@
               </a:defRPr>
             </a:pPr>
             <a:r>
-              <a:t>Program</a:t>
-            </a:r>
-          </a:p>
-        </p:txBody>
-      </p:sp>
-      <p:sp>
-        <p:nvSpPr>
-          <p:cNvPr id="18" name="TextBox 17"/>
+              <a:t>Účinkující</a:t>
+            </a:r>
+          </a:p>
+        </p:txBody>
+      </p:sp>
+      <p:sp>
+        <p:nvSpPr>
+          <p:cNvPr id="22" name="TextBox 21"/>
           <p:cNvSpPr txBox="1"/>
           <p:nvPr/>
         </p:nvSpPr>
         <p:spPr>
           <a:xfrm>
-            <a:off x="3581400" y="4140200"/>
+            <a:off x="6438900" y="4140200"/>
             <a:ext cx="2133600" cy="406400"/>
           </a:xfrm>
           <a:prstGeom prst="rect">
@@ -7507,20 +7546,20 @@
               </a:defRPr>
             </a:pPr>
             <a:r>
-              <a:t>Den / scéna</a:t>
-            </a:r>
-          </a:p>
-        </p:txBody>
-      </p:sp>
-      <p:sp>
-        <p:nvSpPr>
-          <p:cNvPr id="19" name="TextBox 18"/>
+              <a:t>Detail + koncert</a:t>
+            </a:r>
+          </a:p>
+        </p:txBody>
+      </p:sp>
+      <p:sp>
+        <p:nvSpPr>
+          <p:cNvPr id="23" name="TextBox 22"/>
           <p:cNvSpPr txBox="1"/>
           <p:nvPr/>
         </p:nvSpPr>
         <p:spPr>
           <a:xfrm>
-            <a:off x="5956300" y="3657600"/>
+            <a:off x="8813800" y="3657600"/>
             <a:ext cx="292100" cy="394208"/>
           </a:xfrm>
           <a:prstGeom prst="rect">
@@ -7556,13 +7595,13 @@
       </p:sp>
       <p:sp>
         <p:nvSpPr>
-          <p:cNvPr id="20" name="Rectangle 19"/>
+          <p:cNvPr id="24" name="Rectangle 23"/>
           <p:cNvSpPr/>
           <p:nvPr/>
         </p:nvSpPr>
         <p:spPr>
           <a:xfrm>
-            <a:off x="6248400" y="2946400"/>
+            <a:off x="9105900" y="2946400"/>
             <a:ext cx="2552700" cy="1765300"/>
           </a:xfrm>
           <a:prstGeom prst="rect">
@@ -7599,13 +7638,13 @@
       </p:sp>
       <p:sp>
         <p:nvSpPr>
-          <p:cNvPr id="21" name="TextBox 20"/>
+          <p:cNvPr id="25" name="TextBox 24"/>
           <p:cNvSpPr txBox="1"/>
           <p:nvPr/>
         </p:nvSpPr>
         <p:spPr>
           <a:xfrm>
-            <a:off x="6438900" y="3162300"/>
+            <a:off x="9296400" y="3162300"/>
             <a:ext cx="2133600" cy="236728"/>
           </a:xfrm>
           <a:prstGeom prst="rect">
@@ -7634,20 +7673,20 @@
               </a:defRPr>
             </a:pPr>
             <a:r>
-              <a:t>03</a:t>
-            </a:r>
-          </a:p>
-        </p:txBody>
-      </p:sp>
-      <p:sp>
-        <p:nvSpPr>
-          <p:cNvPr id="22" name="TextBox 21"/>
+              <a:t>04</a:t>
+            </a:r>
+          </a:p>
+        </p:txBody>
+      </p:sp>
+      <p:sp>
+        <p:nvSpPr>
+          <p:cNvPr id="26" name="TextBox 25"/>
           <p:cNvSpPr txBox="1"/>
           <p:nvPr/>
         </p:nvSpPr>
         <p:spPr>
           <a:xfrm>
-            <a:off x="6438900" y="3568700"/>
+            <a:off x="9296400" y="3568700"/>
             <a:ext cx="2133600" cy="444500"/>
           </a:xfrm>
           <a:prstGeom prst="rect">
@@ -7676,20 +7715,20 @@
               </a:defRPr>
             </a:pPr>
             <a:r>
-              <a:t>Účinkující</a:t>
-            </a:r>
-          </a:p>
-        </p:txBody>
-      </p:sp>
-      <p:sp>
-        <p:nvSpPr>
-          <p:cNvPr id="23" name="TextBox 22"/>
+              <a:t>Info</a:t>
+            </a:r>
+          </a:p>
+        </p:txBody>
+      </p:sp>
+      <p:sp>
+        <p:nvSpPr>
+          <p:cNvPr id="27" name="TextBox 26"/>
           <p:cNvSpPr txBox="1"/>
           <p:nvPr/>
         </p:nvSpPr>
         <p:spPr>
           <a:xfrm>
-            <a:off x="6438900" y="4140200"/>
+            <a:off x="9296400" y="4140200"/>
             <a:ext cx="2133600" cy="406400"/>
           </a:xfrm>
           <a:prstGeom prst="rect">
@@ -7718,21 +7757,21 @@
               </a:defRPr>
             </a:pPr>
             <a:r>
-              <a:t>Detail + koncert</a:t>
-            </a:r>
-          </a:p>
-        </p:txBody>
-      </p:sp>
-      <p:sp>
-        <p:nvSpPr>
-          <p:cNvPr id="24" name="TextBox 23"/>
+              <a:t>Doprava + místo</a:t>
+            </a:r>
+          </a:p>
+        </p:txBody>
+      </p:sp>
+      <p:sp>
+        <p:nvSpPr>
+          <p:cNvPr id="28" name="TextBox 27"/>
           <p:cNvSpPr txBox="1"/>
           <p:nvPr/>
         </p:nvSpPr>
         <p:spPr>
           <a:xfrm>
-            <a:off x="8813800" y="3657600"/>
-            <a:ext cx="292100" cy="394208"/>
+            <a:off x="533400" y="5207000"/>
+            <a:ext cx="11125200" cy="1016000"/>
           </a:xfrm>
           <a:prstGeom prst="rect">
             <a:avLst/>
@@ -7747,12 +7786,12 @@
           <a:p>
             <a:pPr>
               <a:lnSpc>
-                <a:spcPts val="2604"/>
-              </a:lnSpc>
-              <a:spcAft>
-                <a:spcPts val="0"/>
-              </a:spcAft>
-              <a:defRPr sz="2100" b="1">
+                <a:spcPts val="2108"/>
+              </a:lnSpc>
+              <a:spcAft>
+                <a:spcPts val="0"/>
+              </a:spcAft>
+              <a:defRPr sz="1700" b="0">
                 <a:solidFill>
                   <a:srgbClr val="181817"/>
                 </a:solidFill>
@@ -7760,64 +7799,40 @@
               </a:defRPr>
             </a:pPr>
             <a:r>
-              <a:t>›</a:t>
-            </a:r>
-          </a:p>
-        </p:txBody>
-      </p:sp>
-      <p:sp>
-        <p:nvSpPr>
-          <p:cNvPr id="25" name="Rectangle 24"/>
-          <p:cNvSpPr/>
-          <p:nvPr/>
-        </p:nvSpPr>
-        <p:spPr>
-          <a:xfrm>
-            <a:off x="9105900" y="2946400"/>
-            <a:ext cx="2552700" cy="1765300"/>
-          </a:xfrm>
-          <a:prstGeom prst="rect">
-            <a:avLst/>
-          </a:prstGeom>
-          <a:solidFill>
-            <a:srgbClr val="E7E0D5"/>
-          </a:solidFill>
-          <a:ln>
-            <a:noFill/>
-          </a:ln>
-        </p:spPr>
-        <p:style>
-          <a:lnRef idx="1">
-            <a:schemeClr val="accent1"/>
-          </a:lnRef>
-          <a:fillRef idx="3">
-            <a:schemeClr val="accent1"/>
-          </a:fillRef>
-          <a:effectRef idx="2">
-            <a:schemeClr val="accent1"/>
-          </a:effectRef>
-          <a:fontRef idx="minor">
-            <a:schemeClr val="lt1"/>
-          </a:fontRef>
-        </p:style>
-        <p:txBody>
-          <a:bodyPr rtlCol="0" anchor="ctr"/>
-          <a:lstStyle/>
-          <a:p>
-            <a:pPr algn="ctr"/>
-          </a:p>
-        </p:txBody>
-      </p:sp>
-      <p:sp>
-        <p:nvSpPr>
-          <p:cNvPr id="26" name="TextBox 25"/>
+              <a:t>Hledání vede na odpovídající objekt.</a:t>
+            </a:r>
+          </a:p>
+          <a:p>
+            <a:pPr>
+              <a:lnSpc>
+                <a:spcPts val="2108"/>
+              </a:lnSpc>
+              <a:spcAft>
+                <a:spcPts val="0"/>
+              </a:spcAft>
+              <a:defRPr sz="1700" b="0">
+                <a:solidFill>
+                  <a:srgbClr val="181817"/>
+                </a:solidFill>
+                <a:latin typeface="Arial"/>
+              </a:defRPr>
+            </a:pPr>
+            <a:r>
+              <a:t>Vstupenky → košík → dokončení → PDF; účet je doplňková cesta.</a:t>
+            </a:r>
+          </a:p>
+        </p:txBody>
+      </p:sp>
+      <p:sp>
+        <p:nvSpPr>
+          <p:cNvPr id="29" name="TextBox 28"/>
           <p:cNvSpPr txBox="1"/>
           <p:nvPr/>
         </p:nvSpPr>
         <p:spPr>
           <a:xfrm>
-            <a:off x="9296400" y="3162300"/>
-            <a:ext cx="2133600" cy="236728"/>
+            <a:off x="533400" y="6413500"/>
+            <a:ext cx="10033000" cy="181610"/>
           </a:xfrm>
           <a:prstGeom prst="rect">
             <a:avLst/>
@@ -7832,165 +7847,20 @@
           <a:p>
             <a:pPr>
               <a:lnSpc>
-                <a:spcPts val="1364"/>
-              </a:lnSpc>
-              <a:spcAft>
-                <a:spcPts val="0"/>
-              </a:spcAft>
-              <a:defRPr sz="1100" b="1">
-                <a:solidFill>
-                  <a:srgbClr val="F45E2B"/>
-                </a:solidFill>
-                <a:latin typeface="Arial"/>
-              </a:defRPr>
-            </a:pPr>
-            <a:r>
-              <a:t>04</a:t>
-            </a:r>
-          </a:p>
-        </p:txBody>
-      </p:sp>
-      <p:sp>
-        <p:nvSpPr>
-          <p:cNvPr id="27" name="TextBox 26"/>
-          <p:cNvSpPr txBox="1"/>
-          <p:nvPr/>
-        </p:nvSpPr>
-        <p:spPr>
-          <a:xfrm>
-            <a:off x="9296400" y="3568700"/>
-            <a:ext cx="2133600" cy="444500"/>
-          </a:xfrm>
-          <a:prstGeom prst="rect">
-            <a:avLst/>
-          </a:prstGeom>
-          <a:noFill/>
-        </p:spPr>
-        <p:txBody>
-          <a:bodyPr wrap="none" lIns="0" rIns="0" tIns="0" bIns="0">
-            <a:spAutoFit/>
-          </a:bodyPr>
-          <a:lstStyle/>
-          <a:p>
-            <a:pPr>
-              <a:lnSpc>
-                <a:spcPts val="2728"/>
-              </a:lnSpc>
-              <a:spcAft>
-                <a:spcPts val="0"/>
-              </a:spcAft>
-              <a:defRPr sz="2200" b="1">
-                <a:solidFill>
-                  <a:srgbClr val="181817"/>
-                </a:solidFill>
-                <a:latin typeface="Arial"/>
-              </a:defRPr>
-            </a:pPr>
-            <a:r>
-              <a:t>Info</a:t>
-            </a:r>
-          </a:p>
-        </p:txBody>
-      </p:sp>
-      <p:sp>
-        <p:nvSpPr>
-          <p:cNvPr id="28" name="TextBox 27"/>
-          <p:cNvSpPr txBox="1"/>
-          <p:nvPr/>
-        </p:nvSpPr>
-        <p:spPr>
-          <a:xfrm>
-            <a:off x="9296400" y="4140200"/>
-            <a:ext cx="2133600" cy="406400"/>
-          </a:xfrm>
-          <a:prstGeom prst="rect">
-            <a:avLst/>
-          </a:prstGeom>
-          <a:noFill/>
-        </p:spPr>
-        <p:txBody>
-          <a:bodyPr wrap="none" lIns="0" rIns="0" tIns="0" bIns="0">
-            <a:spAutoFit/>
-          </a:bodyPr>
-          <a:lstStyle/>
-          <a:p>
-            <a:pPr>
-              <a:lnSpc>
-                <a:spcPts val="1488"/>
-              </a:lnSpc>
-              <a:spcAft>
-                <a:spcPts val="0"/>
-              </a:spcAft>
-              <a:defRPr sz="1200" b="0">
-                <a:solidFill>
-                  <a:srgbClr val="181817"/>
-                </a:solidFill>
-                <a:latin typeface="Arial"/>
-              </a:defRPr>
-            </a:pPr>
-            <a:r>
-              <a:t>Doprava + místo</a:t>
-            </a:r>
-          </a:p>
-        </p:txBody>
-      </p:sp>
-      <p:sp>
-        <p:nvSpPr>
-          <p:cNvPr id="29" name="TextBox 28"/>
-          <p:cNvSpPr txBox="1"/>
-          <p:nvPr/>
-        </p:nvSpPr>
-        <p:spPr>
-          <a:xfrm>
-            <a:off x="533400" y="5207000"/>
-            <a:ext cx="11125200" cy="1016000"/>
-          </a:xfrm>
-          <a:prstGeom prst="rect">
-            <a:avLst/>
-          </a:prstGeom>
-          <a:noFill/>
-        </p:spPr>
-        <p:txBody>
-          <a:bodyPr wrap="none" lIns="0" rIns="0" tIns="0" bIns="0">
-            <a:spAutoFit/>
-          </a:bodyPr>
-          <a:lstStyle/>
-          <a:p>
-            <a:pPr>
-              <a:lnSpc>
-                <a:spcPts val="2108"/>
-              </a:lnSpc>
-              <a:spcAft>
-                <a:spcPts val="0"/>
-              </a:spcAft>
-              <a:defRPr sz="1700" b="0">
-                <a:solidFill>
-                  <a:srgbClr val="181817"/>
-                </a:solidFill>
-                <a:latin typeface="Arial"/>
-              </a:defRPr>
-            </a:pPr>
-            <a:r>
-              <a:t>Hledání vede na odpovídající objekt.</a:t>
-            </a:r>
-          </a:p>
-          <a:p>
-            <a:pPr>
-              <a:lnSpc>
-                <a:spcPts val="2108"/>
-              </a:lnSpc>
-              <a:spcAft>
-                <a:spcPts val="0"/>
-              </a:spcAft>
-              <a:defRPr sz="1700" b="0">
-                <a:solidFill>
-                  <a:srgbClr val="181817"/>
-                </a:solidFill>
-                <a:latin typeface="Arial"/>
-              </a:defRPr>
-            </a:pPr>
-            <a:r>
-              <a:t>Vstupenky → košík → dokončení → PDF; účet je doplňková cesta.</a:t>
+                <a:spcPts val="930"/>
+              </a:lnSpc>
+              <a:spcAft>
+                <a:spcPts val="0"/>
+              </a:spcAft>
+              <a:defRPr sz="750" b="0">
+                <a:solidFill>
+                  <a:srgbClr val="68635B"/>
+                </a:solidFill>
+                <a:latin typeface="Arial"/>
+              </a:defRPr>
+            </a:pPr>
+            <a:r>
+              <a:t>DODATEČNĚ PŘIPRAVENÝ PODKLAD K MILNÍKU</a:t>
             </a:r>
           </a:p>
         </p:txBody>
@@ -7998,48 +7868,6 @@
       <p:sp>
         <p:nvSpPr>
           <p:cNvPr id="30" name="TextBox 29"/>
-          <p:cNvSpPr txBox="1"/>
-          <p:nvPr/>
-        </p:nvSpPr>
-        <p:spPr>
-          <a:xfrm>
-            <a:off x="533400" y="6413500"/>
-            <a:ext cx="10033000" cy="181610"/>
-          </a:xfrm>
-          <a:prstGeom prst="rect">
-            <a:avLst/>
-          </a:prstGeom>
-          <a:noFill/>
-        </p:spPr>
-        <p:txBody>
-          <a:bodyPr wrap="none" lIns="0" rIns="0" tIns="0" bIns="0">
-            <a:spAutoFit/>
-          </a:bodyPr>
-          <a:lstStyle/>
-          <a:p>
-            <a:pPr>
-              <a:lnSpc>
-                <a:spcPts val="930"/>
-              </a:lnSpc>
-              <a:spcAft>
-                <a:spcPts val="0"/>
-              </a:spcAft>
-              <a:defRPr sz="750" b="0">
-                <a:solidFill>
-                  <a:srgbClr val="68635B"/>
-                </a:solidFill>
-                <a:latin typeface="Arial"/>
-              </a:defRPr>
-            </a:pPr>
-            <a:r>
-              <a:t>DODATEČNĚ PŘIPRAVENÝ PODKLAD K MILNÍKU</a:t>
-            </a:r>
-          </a:p>
-        </p:txBody>
-      </p:sp>
-      <p:sp>
-        <p:nvSpPr>
-          <p:cNvPr id="31" name="TextBox 30"/>
           <p:cNvSpPr txBox="1"/>
           <p:nvPr/>
         </p:nvSpPr>
@@ -8268,20 +8096,62 @@
       </p:sp>
       <p:sp>
         <p:nvSpPr>
-          <p:cNvPr id="6" name="Rectangle 5"/>
+          <p:cNvPr id="6" name="TextBox 5"/>
+          <p:cNvSpPr txBox="1"/>
+          <p:nvPr/>
+        </p:nvSpPr>
+        <p:spPr>
+          <a:xfrm>
+            <a:off x="5588000" y="533400"/>
+            <a:ext cx="6070600" cy="220979"/>
+          </a:xfrm>
+          <a:prstGeom prst="rect">
+            <a:avLst/>
+          </a:prstGeom>
+          <a:noFill/>
+        </p:spPr>
+        <p:txBody>
+          <a:bodyPr wrap="none" lIns="0" rIns="0" tIns="0" bIns="0">
+            <a:spAutoFit/>
+          </a:bodyPr>
+          <a:lstStyle/>
+          <a:p>
+            <a:pPr>
+              <a:lnSpc>
+                <a:spcPts val="1240"/>
+              </a:lnSpc>
+              <a:spcAft>
+                <a:spcPts val="0"/>
+              </a:spcAft>
+              <a:defRPr sz="1000" b="1">
+                <a:solidFill>
+                  <a:srgbClr val="68635B"/>
+                </a:solidFill>
+                <a:latin typeface="Arial"/>
+              </a:defRPr>
+            </a:pPr>
+            <a:r>
+              <a:t>KLÍČOVÉ SCÉNÁŘE</a:t>
+            </a:r>
+          </a:p>
+        </p:txBody>
+      </p:sp>
+      <p:sp>
+        <p:nvSpPr>
+          <p:cNvPr id="7" name="Rectangle 6"/>
           <p:cNvSpPr/>
           <p:nvPr/>
         </p:nvSpPr>
         <p:spPr>
           <a:xfrm>
-            <a:off x="1866900" y="368300"/>
-            <a:ext cx="88900" cy="431800"/>
+            <a:off x="533400" y="1155700"/>
+            <a:ext cx="11125200" cy="25400"/>
           </a:xfrm>
           <a:prstGeom prst="rect">
             <a:avLst/>
           </a:prstGeom>
           <a:solidFill>
-            <a:srgbClr val="F45E2B"/>
+            <a:srgbClr val="181817"/>
           </a:solidFill>
           <a:ln>
             <a:noFill/>
@@ -8311,14 +8181,14 @@
       </p:sp>
       <p:sp>
         <p:nvSpPr>
-          <p:cNvPr id="7" name="TextBox 6"/>
+          <p:cNvPr id="8" name="TextBox 7"/>
           <p:cNvSpPr txBox="1"/>
           <p:nvPr/>
         </p:nvSpPr>
         <p:spPr>
           <a:xfrm>
-            <a:off x="5588000" y="533400"/>
-            <a:ext cx="6070600" cy="220979"/>
+            <a:off x="508000" y="1422400"/>
+            <a:ext cx="11176000" cy="1079500"/>
           </a:xfrm>
           <a:prstGeom prst="rect">
             <a:avLst/>
@@ -8333,34 +8203,34 @@
           <a:p>
             <a:pPr>
               <a:lnSpc>
-                <a:spcPts val="1240"/>
-              </a:lnSpc>
-              <a:spcAft>
-                <a:spcPts val="0"/>
-              </a:spcAft>
-              <a:defRPr sz="1000" b="1">
-                <a:solidFill>
-                  <a:srgbClr val="68635B"/>
-                </a:solidFill>
-                <a:latin typeface="Arial"/>
-              </a:defRPr>
-            </a:pPr>
-            <a:r>
-              <a:t>KLÍČOVÉ SCÉNÁŘE</a:t>
-            </a:r>
-          </a:p>
-        </p:txBody>
-      </p:sp>
-      <p:sp>
-        <p:nvSpPr>
-          <p:cNvPr id="8" name="Rectangle 7"/>
+                <a:spcPts val="3740"/>
+              </a:lnSpc>
+              <a:spcAft>
+                <a:spcPts val="0"/>
+              </a:spcAft>
+              <a:defRPr sz="3400" b="1">
+                <a:solidFill>
+                  <a:srgbClr val="181817"/>
+                </a:solidFill>
+                <a:latin typeface="Arial"/>
+              </a:defRPr>
+            </a:pPr>
+            <a:r>
+              <a:t>Dva průchody, jasný výsledek.</a:t>
+            </a:r>
+          </a:p>
+        </p:txBody>
+      </p:sp>
+      <p:sp>
+        <p:nvSpPr>
+          <p:cNvPr id="9" name="Rectangle 8"/>
           <p:cNvSpPr/>
           <p:nvPr/>
         </p:nvSpPr>
         <p:spPr>
           <a:xfrm>
-            <a:off x="533400" y="1155700"/>
-            <a:ext cx="11125200" cy="25400"/>
+            <a:off x="533400" y="2768600"/>
+            <a:ext cx="5448300" cy="2603500"/>
           </a:xfrm>
           <a:prstGeom prst="rect">
             <a:avLst/>
@@ -8396,48 +8266,6 @@
       </p:sp>
       <p:sp>
         <p:nvSpPr>
-          <p:cNvPr id="9" name="TextBox 8"/>
-          <p:cNvSpPr txBox="1"/>
-          <p:nvPr/>
-        </p:nvSpPr>
-        <p:spPr>
-          <a:xfrm>
-            <a:off x="508000" y="1422400"/>
-            <a:ext cx="11176000" cy="1079500"/>
-          </a:xfrm>
-          <a:prstGeom prst="rect">
-            <a:avLst/>
-          </a:prstGeom>
-          <a:noFill/>
-        </p:spPr>
-        <p:txBody>
-          <a:bodyPr wrap="none" lIns="0" rIns="0" tIns="0" bIns="0">
-            <a:spAutoFit/>
-          </a:bodyPr>
-          <a:lstStyle/>
-          <a:p>
-            <a:pPr>
-              <a:lnSpc>
-                <a:spcPts val="3740"/>
-              </a:lnSpc>
-              <a:spcAft>
-                <a:spcPts val="0"/>
-              </a:spcAft>
-              <a:defRPr sz="3400" b="1">
-                <a:solidFill>
-                  <a:srgbClr val="181817"/>
-                </a:solidFill>
-                <a:latin typeface="Arial"/>
-              </a:defRPr>
-            </a:pPr>
-            <a:r>
-              <a:t>Dva průchody, jasný výsledek.</a:t>
-            </a:r>
-          </a:p>
-        </p:txBody>
-      </p:sp>
-      <p:sp>
-        <p:nvSpPr>
           <p:cNvPr id="10" name="Rectangle 9"/>
           <p:cNvSpPr/>
           <p:nvPr/>
@@ -8445,13 +8273,13 @@
         <p:spPr>
           <a:xfrm>
             <a:off x="533400" y="2768600"/>
-            <a:ext cx="5448300" cy="2603500"/>
+            <a:ext cx="5448300" cy="76200"/>
           </a:xfrm>
           <a:prstGeom prst="rect">
             <a:avLst/>
           </a:prstGeom>
           <a:solidFill>
-            <a:srgbClr val="181817"/>
+            <a:srgbClr val="F45E2B"/>
           </a:solidFill>
           <a:ln>
             <a:noFill/>
@@ -8481,20 +8309,158 @@
       </p:sp>
       <p:sp>
         <p:nvSpPr>
-          <p:cNvPr id="11" name="Rectangle 10"/>
+          <p:cNvPr id="11" name="TextBox 10"/>
+          <p:cNvSpPr txBox="1"/>
+          <p:nvPr/>
+        </p:nvSpPr>
+        <p:spPr>
+          <a:xfrm>
+            <a:off x="749300" y="3035300"/>
+            <a:ext cx="5016500" cy="685800"/>
+          </a:xfrm>
+          <a:prstGeom prst="rect">
+            <a:avLst/>
+          </a:prstGeom>
+          <a:noFill/>
+        </p:spPr>
+        <p:txBody>
+          <a:bodyPr wrap="none" lIns="0" rIns="0" tIns="0" bIns="0">
+            <a:spAutoFit/>
+          </a:bodyPr>
+          <a:lstStyle/>
+          <a:p>
+            <a:pPr>
+              <a:lnSpc>
+                <a:spcPts val="2200"/>
+              </a:lnSpc>
+              <a:spcAft>
+                <a:spcPts val="0"/>
+              </a:spcAft>
+              <a:defRPr sz="2000" b="1">
+                <a:solidFill>
+                  <a:srgbClr val="F4F0E7"/>
+                </a:solidFill>
+                <a:latin typeface="Arial"/>
+              </a:defRPr>
+            </a:pPr>
+            <a:r>
+              <a:t>S1 / Vybrat program</a:t>
+            </a:r>
+          </a:p>
+        </p:txBody>
+      </p:sp>
+      <p:sp>
+        <p:nvSpPr>
+          <p:cNvPr id="12" name="TextBox 11"/>
+          <p:cNvSpPr txBox="1"/>
+          <p:nvPr/>
+        </p:nvSpPr>
+        <p:spPr>
+          <a:xfrm>
+            <a:off x="749300" y="3733800"/>
+            <a:ext cx="5016500" cy="1511300"/>
+          </a:xfrm>
+          <a:prstGeom prst="rect">
+            <a:avLst/>
+          </a:prstGeom>
+          <a:noFill/>
+        </p:spPr>
+        <p:txBody>
+          <a:bodyPr wrap="none" lIns="0" rIns="0" tIns="0" bIns="0">
+            <a:spAutoFit/>
+          </a:bodyPr>
+          <a:lstStyle/>
+          <a:p>
+            <a:pPr>
+              <a:lnSpc>
+                <a:spcPts val="1689"/>
+              </a:lnSpc>
+              <a:spcAft>
+                <a:spcPts val="0"/>
+              </a:spcAft>
+              <a:defRPr sz="1420" b="0">
+                <a:solidFill>
+                  <a:srgbClr val="F4F0E7"/>
+                </a:solidFill>
+                <a:latin typeface="Arial"/>
+              </a:defRPr>
+            </a:pPr>
+            <a:r>
+              <a:t>Telefon → den 1 → River Stage → uložit koncert →</a:t>
+            </a:r>
+          </a:p>
+          <a:p>
+            <a:pPr>
+              <a:lnSpc>
+                <a:spcPts val="1689"/>
+              </a:lnSpc>
+              <a:spcAft>
+                <a:spcPts val="0"/>
+              </a:spcAft>
+              <a:defRPr sz="1420" b="0">
+                <a:solidFill>
+                  <a:srgbClr val="F4F0E7"/>
+                </a:solidFill>
+                <a:latin typeface="Arial"/>
+              </a:defRPr>
+            </a:pPr>
+            <a:r>
+              <a:t>osobní program.</a:t>
+            </a:r>
+          </a:p>
+          <a:p>
+            <a:pPr>
+              <a:lnSpc>
+                <a:spcPts val="1689"/>
+              </a:lnSpc>
+              <a:spcAft>
+                <a:spcPts val="0"/>
+              </a:spcAft>
+              <a:defRPr sz="1420" b="0">
+                <a:solidFill>
+                  <a:srgbClr val="F4F0E7"/>
+                </a:solidFill>
+                <a:latin typeface="Arial"/>
+              </a:defRPr>
+            </a:pPr>
+          </a:p>
+          <a:p>
+            <a:pPr>
+              <a:lnSpc>
+                <a:spcPts val="1689"/>
+              </a:lnSpc>
+              <a:spcAft>
+                <a:spcPts val="0"/>
+              </a:spcAft>
+              <a:defRPr sz="1420" b="0">
+                <a:solidFill>
+                  <a:srgbClr val="F4F0E7"/>
+                </a:solidFill>
+                <a:latin typeface="Arial"/>
+              </a:defRPr>
+            </a:pPr>
+            <a:r>
+              <a:t>Výsledek: správný výběr přetrvá po obnovení.</a:t>
+            </a:r>
+          </a:p>
+        </p:txBody>
+      </p:sp>
+      <p:sp>
+        <p:nvSpPr>
+          <p:cNvPr id="13" name="Rectangle 12"/>
           <p:cNvSpPr/>
           <p:nvPr/>
         </p:nvSpPr>
         <p:spPr>
           <a:xfrm>
-            <a:off x="533400" y="2768600"/>
-            <a:ext cx="5448300" cy="76200"/>
+            <a:off x="6210300" y="2768600"/>
+            <a:ext cx="5448300" cy="2603500"/>
           </a:xfrm>
           <a:prstGeom prst="rect">
             <a:avLst/>
           </a:prstGeom>
           <a:solidFill>
-            <a:srgbClr val="F45E2B"/>
+            <a:srgbClr val="E7E0D5"/>
           </a:solidFill>
           <a:ln>
             <a:noFill/>
@@ -8524,144 +8490,6 @@
       </p:sp>
       <p:sp>
         <p:nvSpPr>
-          <p:cNvPr id="12" name="TextBox 11"/>
-          <p:cNvSpPr txBox="1"/>
-          <p:nvPr/>
-        </p:nvSpPr>
-        <p:spPr>
-          <a:xfrm>
-            <a:off x="749300" y="3035300"/>
-            <a:ext cx="5016500" cy="685800"/>
-          </a:xfrm>
-          <a:prstGeom prst="rect">
-            <a:avLst/>
-          </a:prstGeom>
-          <a:noFill/>
-        </p:spPr>
-        <p:txBody>
-          <a:bodyPr wrap="none" lIns="0" rIns="0" tIns="0" bIns="0">
-            <a:spAutoFit/>
-          </a:bodyPr>
-          <a:lstStyle/>
-          <a:p>
-            <a:pPr>
-              <a:lnSpc>
-                <a:spcPts val="2200"/>
-              </a:lnSpc>
-              <a:spcAft>
-                <a:spcPts val="0"/>
-              </a:spcAft>
-              <a:defRPr sz="2000" b="1">
-                <a:solidFill>
-                  <a:srgbClr val="F4F0E7"/>
-                </a:solidFill>
-                <a:latin typeface="Arial"/>
-              </a:defRPr>
-            </a:pPr>
-            <a:r>
-              <a:t>S1 / Vybrat program</a:t>
-            </a:r>
-          </a:p>
-        </p:txBody>
-      </p:sp>
-      <p:sp>
-        <p:nvSpPr>
-          <p:cNvPr id="13" name="TextBox 12"/>
-          <p:cNvSpPr txBox="1"/>
-          <p:nvPr/>
-        </p:nvSpPr>
-        <p:spPr>
-          <a:xfrm>
-            <a:off x="749300" y="3733800"/>
-            <a:ext cx="5016500" cy="1511300"/>
-          </a:xfrm>
-          <a:prstGeom prst="rect">
-            <a:avLst/>
-          </a:prstGeom>
-          <a:noFill/>
-        </p:spPr>
-        <p:txBody>
-          <a:bodyPr wrap="none" lIns="0" rIns="0" tIns="0" bIns="0">
-            <a:spAutoFit/>
-          </a:bodyPr>
-          <a:lstStyle/>
-          <a:p>
-            <a:pPr>
-              <a:lnSpc>
-                <a:spcPts val="1689"/>
-              </a:lnSpc>
-              <a:spcAft>
-                <a:spcPts val="0"/>
-              </a:spcAft>
-              <a:defRPr sz="1420" b="0">
-                <a:solidFill>
-                  <a:srgbClr val="F4F0E7"/>
-                </a:solidFill>
-                <a:latin typeface="Arial"/>
-              </a:defRPr>
-            </a:pPr>
-            <a:r>
-              <a:t>Telefon → den 1 → River Stage → uložit koncert →</a:t>
-            </a:r>
-          </a:p>
-          <a:p>
-            <a:pPr>
-              <a:lnSpc>
-                <a:spcPts val="1689"/>
-              </a:lnSpc>
-              <a:spcAft>
-                <a:spcPts val="0"/>
-              </a:spcAft>
-              <a:defRPr sz="1420" b="0">
-                <a:solidFill>
-                  <a:srgbClr val="F4F0E7"/>
-                </a:solidFill>
-                <a:latin typeface="Arial"/>
-              </a:defRPr>
-            </a:pPr>
-            <a:r>
-              <a:t>osobní program.</a:t>
-            </a:r>
-          </a:p>
-          <a:p>
-            <a:pPr>
-              <a:lnSpc>
-                <a:spcPts val="1689"/>
-              </a:lnSpc>
-              <a:spcAft>
-                <a:spcPts val="0"/>
-              </a:spcAft>
-              <a:defRPr sz="1420" b="0">
-                <a:solidFill>
-                  <a:srgbClr val="F4F0E7"/>
-                </a:solidFill>
-                <a:latin typeface="Arial"/>
-              </a:defRPr>
-            </a:pPr>
-          </a:p>
-          <a:p>
-            <a:pPr>
-              <a:lnSpc>
-                <a:spcPts val="1689"/>
-              </a:lnSpc>
-              <a:spcAft>
-                <a:spcPts val="0"/>
-              </a:spcAft>
-              <a:defRPr sz="1420" b="0">
-                <a:solidFill>
-                  <a:srgbClr val="F4F0E7"/>
-                </a:solidFill>
-                <a:latin typeface="Arial"/>
-              </a:defRPr>
-            </a:pPr>
-            <a:r>
-              <a:t>Výsledek: správný výběr přetrvá po obnovení.</a:t>
-            </a:r>
-          </a:p>
-        </p:txBody>
-      </p:sp>
-      <p:sp>
-        <p:nvSpPr>
           <p:cNvPr id="14" name="Rectangle 13"/>
           <p:cNvSpPr/>
           <p:nvPr/>
@@ -8669,13 +8497,13 @@
         <p:spPr>
           <a:xfrm>
             <a:off x="6210300" y="2768600"/>
-            <a:ext cx="5448300" cy="2603500"/>
+            <a:ext cx="5448300" cy="76200"/>
           </a:xfrm>
           <a:prstGeom prst="rect">
             <a:avLst/>
           </a:prstGeom>
           <a:solidFill>
-            <a:srgbClr val="E7E0D5"/>
+            <a:srgbClr val="F45E2B"/>
           </a:solidFill>
           <a:ln>
             <a:noFill/>
@@ -8705,50 +8533,7 @@
       </p:sp>
       <p:sp>
         <p:nvSpPr>
-          <p:cNvPr id="15" name="Rectangle 14"/>
-          <p:cNvSpPr/>
-          <p:nvPr/>
-        </p:nvSpPr>
-        <p:spPr>
-          <a:xfrm>
-            <a:off x="6210300" y="2768600"/>
-            <a:ext cx="5448300" cy="76200"/>
-          </a:xfrm>
-          <a:prstGeom prst="rect">
-            <a:avLst/>
-          </a:prstGeom>
-          <a:solidFill>
-            <a:srgbClr val="F45E2B"/>
-          </a:solidFill>
-          <a:ln>
-            <a:noFill/>
-          </a:ln>
-        </p:spPr>
-        <p:style>
-          <a:lnRef idx="1">
-            <a:schemeClr val="accent1"/>
-          </a:lnRef>
-          <a:fillRef idx="3">
-            <a:schemeClr val="accent1"/>
-          </a:fillRef>
-          <a:effectRef idx="2">
-            <a:schemeClr val="accent1"/>
-          </a:effectRef>
-          <a:fontRef idx="minor">
-            <a:schemeClr val="lt1"/>
-          </a:fontRef>
-        </p:style>
-        <p:txBody>
-          <a:bodyPr rtlCol="0" anchor="ctr"/>
-          <a:lstStyle/>
-          <a:p>
-            <a:pPr algn="ctr"/>
-          </a:p>
-        </p:txBody>
-      </p:sp>
-      <p:sp>
-        <p:nvSpPr>
-          <p:cNvPr id="16" name="TextBox 15"/>
+          <p:cNvPr id="15" name="TextBox 14"/>
           <p:cNvSpPr txBox="1"/>
           <p:nvPr/>
         </p:nvSpPr>
@@ -8790,7 +8575,7 @@
       </p:sp>
       <p:sp>
         <p:nvSpPr>
-          <p:cNvPr id="17" name="TextBox 16"/>
+          <p:cNvPr id="16" name="TextBox 15"/>
           <p:cNvSpPr txBox="1"/>
           <p:nvPr/>
         </p:nvSpPr>
@@ -8825,7 +8610,7 @@
               </a:defRPr>
             </a:pPr>
             <a:r>
-              <a:t>Dotaz „Atlas“ → Atlas Motel → detail → vystoupení.</a:t>
+              <a:t>Dotaz „DARKZY“ → DARKZY → detail → vystoupení.</a:t>
             </a:r>
           </a:p>
           <a:p>
@@ -8867,7 +8652,7 @@
       </p:sp>
       <p:sp>
         <p:nvSpPr>
-          <p:cNvPr id="18" name="TextBox 17"/>
+          <p:cNvPr id="17" name="TextBox 16"/>
           <p:cNvSpPr txBox="1"/>
           <p:nvPr/>
         </p:nvSpPr>
@@ -8909,7 +8694,7 @@
       </p:sp>
       <p:sp>
         <p:nvSpPr>
-          <p:cNvPr id="19" name="TextBox 18"/>
+          <p:cNvPr id="18" name="TextBox 17"/>
           <p:cNvSpPr txBox="1"/>
           <p:nvPr/>
         </p:nvSpPr>
@@ -8951,7 +8736,7 @@
       </p:sp>
       <p:sp>
         <p:nvSpPr>
-          <p:cNvPr id="20" name="TextBox 19"/>
+          <p:cNvPr id="19" name="TextBox 18"/>
           <p:cNvSpPr txBox="1"/>
           <p:nvPr/>
         </p:nvSpPr>
@@ -9180,20 +8965,62 @@
       </p:sp>
       <p:sp>
         <p:nvSpPr>
-          <p:cNvPr id="6" name="Rectangle 5"/>
+          <p:cNvPr id="6" name="TextBox 5"/>
+          <p:cNvSpPr txBox="1"/>
+          <p:nvPr/>
+        </p:nvSpPr>
+        <p:spPr>
+          <a:xfrm>
+            <a:off x="5588000" y="533400"/>
+            <a:ext cx="6070600" cy="220979"/>
+          </a:xfrm>
+          <a:prstGeom prst="rect">
+            <a:avLst/>
+          </a:prstGeom>
+          <a:noFill/>
+        </p:spPr>
+        <p:txBody>
+          <a:bodyPr wrap="none" lIns="0" rIns="0" tIns="0" bIns="0">
+            <a:spAutoFit/>
+          </a:bodyPr>
+          <a:lstStyle/>
+          <a:p>
+            <a:pPr>
+              <a:lnSpc>
+                <a:spcPts val="1240"/>
+              </a:lnSpc>
+              <a:spcAft>
+                <a:spcPts val="0"/>
+              </a:spcAft>
+              <a:defRPr sz="1000" b="1">
+                <a:solidFill>
+                  <a:srgbClr val="68635B"/>
+                </a:solidFill>
+                <a:latin typeface="Arial"/>
+              </a:defRPr>
+            </a:pPr>
+            <a:r>
+              <a:t>POUŽITÍ AI A KONTROLA</a:t>
+            </a:r>
+          </a:p>
+        </p:txBody>
+      </p:sp>
+      <p:sp>
+        <p:nvSpPr>
+          <p:cNvPr id="7" name="Rectangle 6"/>
           <p:cNvSpPr/>
           <p:nvPr/>
         </p:nvSpPr>
         <p:spPr>
           <a:xfrm>
-            <a:off x="1866900" y="368300"/>
-            <a:ext cx="88900" cy="431800"/>
+            <a:off x="533400" y="1155700"/>
+            <a:ext cx="11125200" cy="25400"/>
           </a:xfrm>
           <a:prstGeom prst="rect">
             <a:avLst/>
           </a:prstGeom>
           <a:solidFill>
-            <a:srgbClr val="F45E2B"/>
+            <a:srgbClr val="181817"/>
           </a:solidFill>
           <a:ln>
             <a:noFill/>
@@ -9223,14 +9050,14 @@
       </p:sp>
       <p:sp>
         <p:nvSpPr>
-          <p:cNvPr id="7" name="TextBox 6"/>
+          <p:cNvPr id="8" name="TextBox 7"/>
           <p:cNvSpPr txBox="1"/>
           <p:nvPr/>
         </p:nvSpPr>
         <p:spPr>
           <a:xfrm>
-            <a:off x="5588000" y="533400"/>
-            <a:ext cx="6070600" cy="220979"/>
+            <a:off x="508000" y="1422400"/>
+            <a:ext cx="11176000" cy="1079500"/>
           </a:xfrm>
           <a:prstGeom prst="rect">
             <a:avLst/>
@@ -9245,34 +9072,34 @@
           <a:p>
             <a:pPr>
               <a:lnSpc>
-                <a:spcPts val="1240"/>
-              </a:lnSpc>
-              <a:spcAft>
-                <a:spcPts val="0"/>
-              </a:spcAft>
-              <a:defRPr sz="1000" b="1">
-                <a:solidFill>
-                  <a:srgbClr val="68635B"/>
-                </a:solidFill>
-                <a:latin typeface="Arial"/>
-              </a:defRPr>
-            </a:pPr>
-            <a:r>
-              <a:t>POUŽITÍ AI A KONTROLA</a:t>
-            </a:r>
-          </a:p>
-        </p:txBody>
-      </p:sp>
-      <p:sp>
-        <p:nvSpPr>
-          <p:cNvPr id="8" name="Rectangle 7"/>
+                <a:spcPts val="3740"/>
+              </a:lnSpc>
+              <a:spcAft>
+                <a:spcPts val="0"/>
+              </a:spcAft>
+              <a:defRPr sz="3400" b="1">
+                <a:solidFill>
+                  <a:srgbClr val="181817"/>
+                </a:solidFill>
+                <a:latin typeface="Arial"/>
+              </a:defRPr>
+            </a:pPr>
+            <a:r>
+              <a:t>AI návrh potřebuje důkaz.</a:t>
+            </a:r>
+          </a:p>
+        </p:txBody>
+      </p:sp>
+      <p:sp>
+        <p:nvSpPr>
+          <p:cNvPr id="9" name="Rectangle 8"/>
           <p:cNvSpPr/>
           <p:nvPr/>
         </p:nvSpPr>
         <p:spPr>
           <a:xfrm>
-            <a:off x="533400" y="1155700"/>
-            <a:ext cx="11125200" cy="25400"/>
+            <a:off x="533400" y="2768600"/>
+            <a:ext cx="5448300" cy="2603500"/>
           </a:xfrm>
           <a:prstGeom prst="rect">
             <a:avLst/>
@@ -9308,48 +9135,6 @@
       </p:sp>
       <p:sp>
         <p:nvSpPr>
-          <p:cNvPr id="9" name="TextBox 8"/>
-          <p:cNvSpPr txBox="1"/>
-          <p:nvPr/>
-        </p:nvSpPr>
-        <p:spPr>
-          <a:xfrm>
-            <a:off x="508000" y="1422400"/>
-            <a:ext cx="11176000" cy="1079500"/>
-          </a:xfrm>
-          <a:prstGeom prst="rect">
-            <a:avLst/>
-          </a:prstGeom>
-          <a:noFill/>
-        </p:spPr>
-        <p:txBody>
-          <a:bodyPr wrap="none" lIns="0" rIns="0" tIns="0" bIns="0">
-            <a:spAutoFit/>
-          </a:bodyPr>
-          <a:lstStyle/>
-          <a:p>
-            <a:pPr>
-              <a:lnSpc>
-                <a:spcPts val="3740"/>
-              </a:lnSpc>
-              <a:spcAft>
-                <a:spcPts val="0"/>
-              </a:spcAft>
-              <a:defRPr sz="3400" b="1">
-                <a:solidFill>
-                  <a:srgbClr val="181817"/>
-                </a:solidFill>
-                <a:latin typeface="Arial"/>
-              </a:defRPr>
-            </a:pPr>
-            <a:r>
-              <a:t>AI návrh potřebuje důkaz.</a:t>
-            </a:r>
-          </a:p>
-        </p:txBody>
-      </p:sp>
-      <p:sp>
-        <p:nvSpPr>
           <p:cNvPr id="10" name="Rectangle 9"/>
           <p:cNvSpPr/>
           <p:nvPr/>
@@ -9357,13 +9142,13 @@
         <p:spPr>
           <a:xfrm>
             <a:off x="533400" y="2768600"/>
-            <a:ext cx="5448300" cy="2603500"/>
+            <a:ext cx="5448300" cy="76200"/>
           </a:xfrm>
           <a:prstGeom prst="rect">
             <a:avLst/>
           </a:prstGeom>
           <a:solidFill>
-            <a:srgbClr val="181817"/>
+            <a:srgbClr val="F45E2B"/>
           </a:solidFill>
           <a:ln>
             <a:noFill/>
@@ -9393,20 +9178,139 @@
       </p:sp>
       <p:sp>
         <p:nvSpPr>
-          <p:cNvPr id="11" name="Rectangle 10"/>
+          <p:cNvPr id="11" name="TextBox 10"/>
+          <p:cNvSpPr txBox="1"/>
+          <p:nvPr/>
+        </p:nvSpPr>
+        <p:spPr>
+          <a:xfrm>
+            <a:off x="749300" y="3035300"/>
+            <a:ext cx="5016500" cy="685800"/>
+          </a:xfrm>
+          <a:prstGeom prst="rect">
+            <a:avLst/>
+          </a:prstGeom>
+          <a:noFill/>
+        </p:spPr>
+        <p:txBody>
+          <a:bodyPr wrap="none" lIns="0" rIns="0" tIns="0" bIns="0">
+            <a:spAutoFit/>
+          </a:bodyPr>
+          <a:lstStyle/>
+          <a:p>
+            <a:pPr>
+              <a:lnSpc>
+                <a:spcPts val="2200"/>
+              </a:lnSpc>
+              <a:spcAft>
+                <a:spcPts val="0"/>
+              </a:spcAft>
+              <a:defRPr sz="2000" b="1">
+                <a:solidFill>
+                  <a:srgbClr val="F4F0E7"/>
+                </a:solidFill>
+                <a:latin typeface="Arial"/>
+              </a:defRPr>
+            </a:pPr>
+            <a:r>
+              <a:t>Přijato / upraveno</a:t>
+            </a:r>
+          </a:p>
+        </p:txBody>
+      </p:sp>
+      <p:sp>
+        <p:nvSpPr>
+          <p:cNvPr id="12" name="TextBox 11"/>
+          <p:cNvSpPr txBox="1"/>
+          <p:nvPr/>
+        </p:nvSpPr>
+        <p:spPr>
+          <a:xfrm>
+            <a:off x="749300" y="3733800"/>
+            <a:ext cx="5016500" cy="1511300"/>
+          </a:xfrm>
+          <a:prstGeom prst="rect">
+            <a:avLst/>
+          </a:prstGeom>
+          <a:noFill/>
+        </p:spPr>
+        <p:txBody>
+          <a:bodyPr wrap="none" lIns="0" rIns="0" tIns="0" bIns="0">
+            <a:spAutoFit/>
+          </a:bodyPr>
+          <a:lstStyle/>
+          <a:p>
+            <a:pPr>
+              <a:lnSpc>
+                <a:spcPts val="1689"/>
+              </a:lnSpc>
+              <a:spcAft>
+                <a:spcPts val="0"/>
+              </a:spcAft>
+              <a:defRPr sz="1420" b="0">
+                <a:solidFill>
+                  <a:srgbClr val="F4F0E7"/>
+                </a:solidFill>
+                <a:latin typeface="Arial"/>
+              </a:defRPr>
+            </a:pPr>
+            <a:r>
+              <a:t>AI: struktura, texty, propojení dat a vizuální návrh.</a:t>
+            </a:r>
+          </a:p>
+          <a:p>
+            <a:pPr>
+              <a:lnSpc>
+                <a:spcPts val="1689"/>
+              </a:lnSpc>
+              <a:spcAft>
+                <a:spcPts val="0"/>
+              </a:spcAft>
+              <a:defRPr sz="1420" b="0">
+                <a:solidFill>
+                  <a:srgbClr val="F4F0E7"/>
+                </a:solidFill>
+                <a:latin typeface="Arial"/>
+              </a:defRPr>
+            </a:pPr>
+          </a:p>
+          <a:p>
+            <a:pPr>
+              <a:lnSpc>
+                <a:spcPts val="1689"/>
+              </a:lnSpc>
+              <a:spcAft>
+                <a:spcPts val="0"/>
+              </a:spcAft>
+              <a:defRPr sz="1420" b="0">
+                <a:solidFill>
+                  <a:srgbClr val="F4F0E7"/>
+                </a:solidFill>
+                <a:latin typeface="Arial"/>
+              </a:defRPr>
+            </a:pPr>
+            <a:r>
+              <a:t>Vlastní identita festivalu; žádná kopie cizího loga.</a:t>
+            </a:r>
+          </a:p>
+        </p:txBody>
+      </p:sp>
+      <p:sp>
+        <p:nvSpPr>
+          <p:cNvPr id="13" name="Rectangle 12"/>
           <p:cNvSpPr/>
           <p:nvPr/>
         </p:nvSpPr>
         <p:spPr>
           <a:xfrm>
-            <a:off x="533400" y="2768600"/>
-            <a:ext cx="5448300" cy="76200"/>
+            <a:off x="6210300" y="2768600"/>
+            <a:ext cx="5448300" cy="2603500"/>
           </a:xfrm>
           <a:prstGeom prst="rect">
             <a:avLst/>
           </a:prstGeom>
           <a:solidFill>
-            <a:srgbClr val="F45E2B"/>
+            <a:srgbClr val="E7E0D5"/>
           </a:solidFill>
           <a:ln>
             <a:noFill/>
@@ -9436,125 +9340,6 @@
       </p:sp>
       <p:sp>
         <p:nvSpPr>
-          <p:cNvPr id="12" name="TextBox 11"/>
-          <p:cNvSpPr txBox="1"/>
-          <p:nvPr/>
-        </p:nvSpPr>
-        <p:spPr>
-          <a:xfrm>
-            <a:off x="749300" y="3035300"/>
-            <a:ext cx="5016500" cy="685800"/>
-          </a:xfrm>
-          <a:prstGeom prst="rect">
-            <a:avLst/>
-          </a:prstGeom>
-          <a:noFill/>
-        </p:spPr>
-        <p:txBody>
-          <a:bodyPr wrap="none" lIns="0" rIns="0" tIns="0" bIns="0">
-            <a:spAutoFit/>
-          </a:bodyPr>
-          <a:lstStyle/>
-          <a:p>
-            <a:pPr>
-              <a:lnSpc>
-                <a:spcPts val="2200"/>
-              </a:lnSpc>
-              <a:spcAft>
-                <a:spcPts val="0"/>
-              </a:spcAft>
-              <a:defRPr sz="2000" b="1">
-                <a:solidFill>
-                  <a:srgbClr val="F4F0E7"/>
-                </a:solidFill>
-                <a:latin typeface="Arial"/>
-              </a:defRPr>
-            </a:pPr>
-            <a:r>
-              <a:t>Přijato / upraveno</a:t>
-            </a:r>
-          </a:p>
-        </p:txBody>
-      </p:sp>
-      <p:sp>
-        <p:nvSpPr>
-          <p:cNvPr id="13" name="TextBox 12"/>
-          <p:cNvSpPr txBox="1"/>
-          <p:nvPr/>
-        </p:nvSpPr>
-        <p:spPr>
-          <a:xfrm>
-            <a:off x="749300" y="3733800"/>
-            <a:ext cx="5016500" cy="1511300"/>
-          </a:xfrm>
-          <a:prstGeom prst="rect">
-            <a:avLst/>
-          </a:prstGeom>
-          <a:noFill/>
-        </p:spPr>
-        <p:txBody>
-          <a:bodyPr wrap="none" lIns="0" rIns="0" tIns="0" bIns="0">
-            <a:spAutoFit/>
-          </a:bodyPr>
-          <a:lstStyle/>
-          <a:p>
-            <a:pPr>
-              <a:lnSpc>
-                <a:spcPts val="1689"/>
-              </a:lnSpc>
-              <a:spcAft>
-                <a:spcPts val="0"/>
-              </a:spcAft>
-              <a:defRPr sz="1420" b="0">
-                <a:solidFill>
-                  <a:srgbClr val="F4F0E7"/>
-                </a:solidFill>
-                <a:latin typeface="Arial"/>
-              </a:defRPr>
-            </a:pPr>
-            <a:r>
-              <a:t>AI: struktura, texty, propojení dat a vizuální návrh.</a:t>
-            </a:r>
-          </a:p>
-          <a:p>
-            <a:pPr>
-              <a:lnSpc>
-                <a:spcPts val="1689"/>
-              </a:lnSpc>
-              <a:spcAft>
-                <a:spcPts val="0"/>
-              </a:spcAft>
-              <a:defRPr sz="1420" b="0">
-                <a:solidFill>
-                  <a:srgbClr val="F4F0E7"/>
-                </a:solidFill>
-                <a:latin typeface="Arial"/>
-              </a:defRPr>
-            </a:pPr>
-          </a:p>
-          <a:p>
-            <a:pPr>
-              <a:lnSpc>
-                <a:spcPts val="1689"/>
-              </a:lnSpc>
-              <a:spcAft>
-                <a:spcPts val="0"/>
-              </a:spcAft>
-              <a:defRPr sz="1420" b="0">
-                <a:solidFill>
-                  <a:srgbClr val="F4F0E7"/>
-                </a:solidFill>
-                <a:latin typeface="Arial"/>
-              </a:defRPr>
-            </a:pPr>
-            <a:r>
-              <a:t>Vlastní identita festivalu; žádná kopie cizího loga.</a:t>
-            </a:r>
-          </a:p>
-        </p:txBody>
-      </p:sp>
-      <p:sp>
-        <p:nvSpPr>
           <p:cNvPr id="14" name="Rectangle 13"/>
           <p:cNvSpPr/>
           <p:nvPr/>
@@ -9562,13 +9347,13 @@
         <p:spPr>
           <a:xfrm>
             <a:off x="6210300" y="2768600"/>
-            <a:ext cx="5448300" cy="2603500"/>
+            <a:ext cx="5448300" cy="76200"/>
           </a:xfrm>
           <a:prstGeom prst="rect">
             <a:avLst/>
           </a:prstGeom>
           <a:solidFill>
-            <a:srgbClr val="E7E0D5"/>
+            <a:srgbClr val="F45E2B"/>
           </a:solidFill>
           <a:ln>
             <a:noFill/>
@@ -9598,50 +9383,7 @@
       </p:sp>
       <p:sp>
         <p:nvSpPr>
-          <p:cNvPr id="15" name="Rectangle 14"/>
-          <p:cNvSpPr/>
-          <p:nvPr/>
-        </p:nvSpPr>
-        <p:spPr>
-          <a:xfrm>
-            <a:off x="6210300" y="2768600"/>
-            <a:ext cx="5448300" cy="76200"/>
-          </a:xfrm>
-          <a:prstGeom prst="rect">
-            <a:avLst/>
-          </a:prstGeom>
-          <a:solidFill>
-            <a:srgbClr val="F45E2B"/>
-          </a:solidFill>
-          <a:ln>
-            <a:noFill/>
-          </a:ln>
-        </p:spPr>
-        <p:style>
-          <a:lnRef idx="1">
-            <a:schemeClr val="accent1"/>
-          </a:lnRef>
-          <a:fillRef idx="3">
-            <a:schemeClr val="accent1"/>
-          </a:fillRef>
-          <a:effectRef idx="2">
-            <a:schemeClr val="accent1"/>
-          </a:effectRef>
-          <a:fontRef idx="minor">
-            <a:schemeClr val="lt1"/>
-          </a:fontRef>
-        </p:style>
-        <p:txBody>
-          <a:bodyPr rtlCol="0" anchor="ctr"/>
-          <a:lstStyle/>
-          <a:p>
-            <a:pPr algn="ctr"/>
-          </a:p>
-        </p:txBody>
-      </p:sp>
-      <p:sp>
-        <p:nvSpPr>
-          <p:cNvPr id="16" name="TextBox 15"/>
+          <p:cNvPr id="15" name="TextBox 14"/>
           <p:cNvSpPr txBox="1"/>
           <p:nvPr/>
         </p:nvSpPr>
@@ -9683,7 +9425,7 @@
       </p:sp>
       <p:sp>
         <p:nvSpPr>
-          <p:cNvPr id="17" name="TextBox 16"/>
+          <p:cNvPr id="16" name="TextBox 15"/>
           <p:cNvSpPr txBox="1"/>
           <p:nvPr/>
         </p:nvSpPr>
@@ -9779,7 +9521,7 @@
       </p:sp>
       <p:sp>
         <p:nvSpPr>
-          <p:cNvPr id="18" name="TextBox 17"/>
+          <p:cNvPr id="17" name="TextBox 16"/>
           <p:cNvSpPr txBox="1"/>
           <p:nvPr/>
         </p:nvSpPr>
@@ -9821,7 +9563,7 @@
       </p:sp>
       <p:sp>
         <p:nvSpPr>
-          <p:cNvPr id="19" name="TextBox 18"/>
+          <p:cNvPr id="18" name="TextBox 17"/>
           <p:cNvSpPr txBox="1"/>
           <p:nvPr/>
         </p:nvSpPr>
@@ -9863,7 +9605,7 @@
       </p:sp>
       <p:sp>
         <p:nvSpPr>
-          <p:cNvPr id="20" name="TextBox 19"/>
+          <p:cNvPr id="19" name="TextBox 18"/>
           <p:cNvSpPr txBox="1"/>
           <p:nvPr/>
         </p:nvSpPr>

</xml_diff>

<commit_message>
Refine festival booking, camping and visitor experience
</commit_message>
<xml_diff>
--- a/odevzdani/cviceni-02-specifikace/prezentace.pptx
+++ b/odevzdani/cviceni-02-specifikace/prezentace.pptx
@@ -507,7 +507,7 @@
           <a:lstStyle/>
           <a:p>
             <a:r>
-              <a:t>Představujeme Prague Pulse Fest, fiktivní třídenní hudební festival v Praze. Cílem webu je umožnit návštěvníkovi rychle zjistit, kdy a kde hrají oblíbené kapely, a připravit si vlastní program. Jde o aktuálně připravený podklad k milníku, ne doklad historického odevzdání. Základem je specifikace a XML datová základna. Zachováváme tři dny, tři scény a šedesát účinkujících; původní název, posun termínu na srpen 2027 a výraznější grafický směr vznikly z požadavku zadavatele. Současná datová základna obsahuje skutečné interprety jako navržený line-up; nejde o potvrzení jejich účasti. Noisia je pouze archivní poslechový blok.</a:t>
+              <a:t>Představujeme Prague Pulse Fest, fiktivní třídenní hudební festival v Praze. Cílem webu je umožnit návštěvníkovi rychle zjistit, kdy a kde hrají oblíbené kapely, a připravit si vlastní program. Jde o aktuálně připravený podklad k milníku, ne doklad historického odevzdání. Základem je specifikace a XML datová základna. Zachováváme tři dny, tři scény a šedesát účinkujících; původní název, posun termínu na srpen 2027 a výraznější grafický směr vznikly z požadavku zadavatele. Současná datová základna obsahuje skutečné interprety jako navržený line-up; nejde o potvrzení jejich účasti.</a:t>
             </a:r>
           </a:p>
         </p:txBody>
@@ -577,7 +577,7 @@
           <a:lstStyle/>
           <a:p>
             <a:r>
-              <a:t>Festival propojuje několik současných žánrů. První ročník se odehrává od prvního do třetího srpna 2027 ve fiktivně uspořádaném areálu Vltava Park u reálného Výstaviště Praha. XML obsahuje identitu festivalu, tři dny, tři scény, šedesát interpretů a šedesát programových položek. Každé vystoupení má odkaz na existující den, scénu a interpreta. Nejde tedy o čtyři nezávislé seznamy; vztahy lze zkontrolovat a použít pro program i detail kapely.</a:t>
+              <a:t>Festival trvá od prvního do třetího srpna 2027 ve fiktivně uspořádaném areálu u reálného Výstaviště Praha. XML obsahuje tři dny, tři scény, šedesát skutečných interpretů a šedesát vystoupení. Každá scéna má dvacet jmen a jasné zaměření: Main Hall velká mezinárodní jména, River Stage českou scénu a Club Stage klubovou elektroniku. Každý interpret má jedno vystoupení, program je chronologický a scény nemají kolize. Skutečná jména ale neznamenají potvrzenou účast. Vztahy kontrolujeme podle jednoznačných ID.</a:t>
             </a:r>
           </a:p>
         </p:txBody>
@@ -787,7 +787,7 @@
           <a:lstStyle/>
           <a:p>
             <a:r>
-              <a:t>První scénář řeší návštěvníka na telefonu, který zná den a scénu. Filtrovaný seznam mu umožní uložit koncert a později se vrátit k vlastnímu programu. Ve druhém scénáři návštěvník zadá jen název DARKZY, otevře DARKZY a zjistí čas i scénu koncertu. Očekávané výsledky jsou měřitelné: filtry nesmějí vracet jiné dny a oblíbené musí vydržet obnovení. Třetím scénářem ve specifikaci je objednávka hosta s výstupem PDF.</a:t>
+              <a:t>První scénář řeší návštěvníka na telefonu, který zná den a scénu. Filtrovaný seznam mu umožní uložit koncert a později se vrátit k vlastnímu programu. Ve druhém scénáři návštěvník zadá jen název DARKZY, otevře DARKZY a zjistí čas i scénu koncertu. Očekávané výsledky jsou měřitelné: filtry nesmějí vracet jiné dny a oblíbené musí vydržet obnovení. Třetím scénářem ve specifikaci je objednávka hosta s výstupem PDF. Třetí scénář nově dovoluje dva libovolné dny včetně prvního a třetího, vlastní sedadlo a kemp. Není nutné kupovat celý festival.</a:t>
             </a:r>
           </a:p>
         </p:txBody>
@@ -5449,7 +5449,7 @@
               </a:defRPr>
             </a:pPr>
             <a:r>
-              <a:t>Rock, indie, pop, elektronika, hip-hop, jazz a folk.</a:t>
+              <a:t>Main Hall / mezinárodní · River Stage / CZ · Club Stage / elektronika</a:t>
             </a:r>
           </a:p>
         </p:txBody>
@@ -8687,7 +8687,7 @@
               </a:defRPr>
             </a:pPr>
             <a:r>
-              <a:t>S3 navazuje: porovnat vstupenky, objednat jako host a stáhnout PDF.</a:t>
+              <a:t>S3: vlastní dny a sedadlo, volitelný kemp, cena včetně modelové DPH.</a:t>
             </a:r>
           </a:p>
         </p:txBody>

</xml_diff>

<commit_message>
feat: streamline contextual ticket purchases and data delivery
</commit_message>
<xml_diff>
--- a/odevzdani/cviceni-02-specifikace/prezentace.pptx
+++ b/odevzdani/cviceni-02-specifikace/prezentace.pptx
@@ -507,7 +507,7 @@
           <a:lstStyle/>
           <a:p>
             <a:r>
-              <a:t>[30 s] Prague Pulse Fest je návrh fiktivního třídenního festivalu v Praze. První výstup tvoří projektová specifikace a XML datová základna. Od výchozího námětu jsme přešli k identitě, cílovým skupinám, struktuře webu a pěti scénářům. Hlavní úkol návštěvníka je zjistit kdo, kdy a kde vystupuje, uložit si vlastní program a naplánovat návštěvu. Autoři jsou Michal Ladra, Matěj Mlejnek a Jan Martínek. Skuteční interpreti jsou návrhem line-upu, jejich účast nepotvrzujeme. Tyto podklady popisují současný návrh, nikoli nedoloženou historii odevzdání.</a:t>
+              <a:t>[35 s] Prague Pulse Fest je fiktivní třídenní hudební festival. Navrhujeme web, který návštěvníka provede od otázky kdo hraje až k odpovídající vstupence. Někdo přijde na jednoho interpreta, jiný na celou scénu a další na všechny tři dny. Web má těmto lidem nabídnout správný rozsah vstupu a srozumitelnou cenu. Prvním výstupem je specifikace s cílovými skupinami, strukturou a scénáři a datová základna v XML. Autory projektu jsou Michal Ladra, Matěj Mlejnek a Jan Martínek.</a:t>
             </a:r>
           </a:p>
         </p:txBody>
@@ -577,7 +577,7 @@
           <a:lstStyle/>
           <a:p>
             <a:r>
-              <a:t>[35 s] Cílové skupiny rozlišujeme podle úkolu. Návštěvník v areálu potřebuje rychlý program v telefonu. Fanoušek hledá známé jméno a jeho koncert. Přijíždějící návštěvník potřebuje dopravu, mapu a případně angličtinu. Každé potřebě odpovídá konkrétní obsah nebo funkce, ne pouze propagační text. Samostatně počítáme i s vracejícím se uživatelem a historií objednávek. Účet není podmínkou nákupu. Tato návaznost potřeb a funkcí je hlavní rozhodnutí návrhu.</a:t>
+              <a:t>[40 s] Cílové skupiny rozlišujeme podle cíle návštěvy. Fanoušek jednoho interpreta potřebuje najít jeho koncert a přejít na vstup pro daný den a scénu. Návštěvník více koncertů kombinuje filtry a osobní program a vybere si například první a třetí den. Návštěvník celého festivalu potřebuje jasně vidět, co společná vstupenka obsahuje a kde ještě zbývá kapacita. Všichni mají mít možnost zvolit jiný rozsah, vidět aktuální cenu a nakoupit bez povinného účtu. Mobilní ovládání a čeština s angličtinou podporují všechny tyto skupiny.</a:t>
             </a:r>
           </a:p>
         </p:txBody>
@@ -647,7 +647,7 @@
           <a:lstStyle/>
           <a:p>
             <a:r>
-              <a:t>[40 s] XML obsahuje tři dny, tři scény, šedesát interpretů a šedesát vystoupení. Každé vystoupení jednoznačně odkazuje na existující den, scénu a interpreta. Názvy nejsou spojovací klíč. Main Hall má návrhovou kapacitu pět tisíc osob: šestnáct VIP sedadel, třicet dva Regular a čtyři tisíce devět set padesát dva stojících. River a Club jsou pouze na stání, s kapacitami tři tisíce a patnáct set. Vstup jde zvolit na jednu scénu nebo společně. Společný vstup spotřebuje kapacitu na všech scénách, proto zaručený přístup omezuje i nejmenší Club. Nejde o oficiální kapacity Výstaviště. Program zachovává plné sety, po sobě jdou tři závěrečné koncerty denně; ostatní sety se mohou překrývat.</a:t>
+              <a:t>[45 s] Základ obsahuje tři dny, tři scény, šedesát interpretů a šedesát vystoupení. Vystoupení odkazuje na interpreta, den a scénu pomocí ID, nikoli podle podobnosti názvu. Proto stejný objekt používá seznam, detail i nákup. Filtr dne a scény porovná ID, textové hledání porovná část názvu či popisu bez diakritiky a velikosti písmen. Kapacita scény pochází z dat; prodané vstupy se odvodí z objednávek pro daný den. XML je hlavní zdroj. Nástroj autora z něj připraví čtyři JSON exporty a stejná data přibalí do JavaScriptu. Při otevření webu už není potřebný server.</a:t>
             </a:r>
           </a:p>
         </p:txBody>
@@ -717,7 +717,7 @@
           <a:lstStyle/>
           <a:p>
             <a:r>
-              <a:t>[35 s] Úvod představí festival a hlavní navigace vede k programu, účinkujícím, scénám a praktickým informacím. Hledání má vlastní stránku s výsledky napříč obsahem. Detail interpreta vede ke koncertu a scéna do svého filtrovaného programu. Návštěvník tak nemusí stále začínat od úvodu. Nákup má samostatnou cestu od výběru ke košíku a PDF. Účet a historie jsou volitelné. Novinky, soukromí, podmínky a kredity jsou doplňkové části v patičce; úplný sitemap je ve specifikaci.</a:t>
+              <a:t>[35 s] Hlavní navigace propojuje program, účinkující, scény a praktické informace. Hledání má vlastní stránku s výsledky. Detail interpreta vede ke konkrétnímu koncertu a vstupence; scéna vede do svého programu a ukazuje dostupnost. Návštěvník tak navazuje na svůj výběr, nemusí stále začínat od úvodu. V nákupu upraví dny, scénu a kategorii a přejde do košíku. Po dokončení stáhne PDF. Účet nabídne profil a historii, ale objednávka funguje i pro hosta. Novinky, podmínky, soukromí a zdroje doplňují hlavní strukturu.</a:t>
             </a:r>
           </a:p>
         </p:txBody>
@@ -787,7 +787,7 @@
           <a:lstStyle/>
           <a:p>
             <a:r>
-              <a:t>[45 s] Scénář S1 má konkrétního uživatele, cíl, výchozí situaci a očekávaný výsledek. Na mobilu vybereme první srpen a River Stage, uložíme koncert a otevřeme osobní program. Po obnovení musí výběr zůstat. V S2 fanoušek zná DARKZY, ale ne jeho termín. Přes hledání a detail najde konkrétní vystoupení v Club Stage. Při ověření porovnáme datum, čas a scénu s XML. První dva průchody podporuje také samostatný wireframe. Třetí klíčový scénář specifikace je nákup hosta na první a třetí srpen s ručním sedadlem a PDF. Nevyžaduje účet.</a:t>
+              <a:t>[45 s] S1 začíná v programu. Návštěvník vybere den a River Stage, uloží si koncerty a otevře osobní výběr. Očekáváme správné výsledky obou filtrů, zachování výběru po obnovení a upozornění na časové kolize. V S2 fanoušek vyhledá DARKZY, otevře jeho detail a přejde k odpovídajícímu vstupu. Předvolí se skutečný den koncertu a Club Stage, nikoli obecný třídenní vstup na všechny scény. Výběr může upravit. Třetí scénář ověřuje dva výslovně vybrané dny, automatický počet osob podle sedadel a shodnou cenu ve výběru, košíku i PDF.</a:t>
             </a:r>
           </a:p>
         </p:txBody>
@@ -857,7 +857,7 @@
           <a:lstStyle/>
           <a:p>
             <a:r>
-              <a:t>[40 s] Codex a ChatGPT pomohly s rozborem zadání, návrhem struktury, texty a datovým modelem. Přijali jsme stabilní ID, upravili scénáře, kapacity a program podle účelu návštěvy. Odmítli jsme vlastní backend, protože zadání požaduje čistě klientský web. Konkrétní ověření tvoří XML/XSD validace, počty entit, jedinečná ID a reference a porovnání exportu pro prohlížeč s XML. Výsledek je reprodukovatelný validátorem a uložený ve validačním reportu. Testy nenahrazují použitelnost s návštěvníky, nepotvrzují účast interpretů ani oficiální kapacity. Skutečné fotografie mají zdroje a licence; odchylku od požadavku na AI obrázky uvádíme v dokumentaci. Za odevzdání a vysvětlení odpovídá tým.</a:t>
+              <a:t>[40 s] Codex a ChatGPT pomohly rozebrat zadání, navrhnout strukturu webu, texty a práci s daty. Přijali jsme stabilní ID a propojení seznamu s detaily. Upravili jsme příliš obecné scénáře a nákup tak, aby vycházel z konkrétního dne a scény. Rozhodli jsme se pro klientský web a jednu datovou základnu. Ověření začíná XML proti XSD, počty a referencemi. Dále porovnáváme filtrované výsledky s daty a projdeme interpreta až ke vstupence a ceně v košíku. Chybu nelze omluvit tím, že ji vytvořila AI; tým musí umět postup vysvětlit a výsledek zkontrolovat.</a:t>
             </a:r>
           </a:p>
         </p:txBody>
@@ -4175,26 +4175,7 @@
               </a:defRPr>
             </a:pPr>
             <a:r>
-              <a:t>Projektová</a:t>
-            </a:r>
-          </a:p>
-          <a:p>
-            <a:pPr>
-              <a:lnSpc>
-                <a:spcPts val="4028"/>
-              </a:lnSpc>
-              <a:spcAft>
-                <a:spcPts val="0"/>
-              </a:spcAft>
-              <a:defRPr sz="3800" b="1">
-                <a:solidFill>
-                  <a:srgbClr val="FF885D"/>
-                </a:solidFill>
-                <a:latin typeface="Arial"/>
-              </a:defRPr>
-            </a:pPr>
-            <a:r>
-              <a:t>specifikace a data</a:t>
+              <a:t>Festival podle návštěvníka</a:t>
             </a:r>
           </a:p>
         </p:txBody>
@@ -4236,7 +4217,7 @@
               </a:defRPr>
             </a:pPr>
             <a:r>
-              <a:t>1.–3. srpna 2027 · Výstaviště Praha</a:t>
+              <a:t>Projektová specifikace a datová základna</a:t>
             </a:r>
           </a:p>
           <a:p>
@@ -4255,7 +4236,7 @@
               </a:defRPr>
             </a:pPr>
             <a:r>
-              <a:t>Rock · pop · rap · klubová elektronika</a:t>
+              <a:t>1.–3. srpna 2027 · Výstaviště Praha</a:t>
             </a:r>
           </a:p>
         </p:txBody>
@@ -4655,7 +4636,7 @@
               </a:defRPr>
             </a:pPr>
             <a:r>
-              <a:t>Od otázky k hotovému plánu</a:t>
+              <a:t>Každý chce jiný rozsah návštěvy</a:t>
             </a:r>
           </a:p>
         </p:txBody>
@@ -4825,9 +4806,263 @@
               </a:defRPr>
             </a:pPr>
             <a:r>
-              <a:t>Návštěvník na</a:t>
-            </a:r>
-          </a:p>
+              <a:t>Jeden interpret</a:t>
+            </a:r>
+          </a:p>
+        </p:txBody>
+      </p:sp>
+      <p:sp>
+        <p:nvSpPr>
+          <p:cNvPr id="11" name="TextBox 10"/>
+          <p:cNvSpPr txBox="1"/>
+          <p:nvPr/>
+        </p:nvSpPr>
+        <p:spPr>
+          <a:xfrm>
+            <a:off x="838200" y="3746500"/>
+            <a:ext cx="3048000" cy="711200"/>
+          </a:xfrm>
+          <a:prstGeom prst="rect">
+            <a:avLst/>
+          </a:prstGeom>
+          <a:noFill/>
+        </p:spPr>
+        <p:txBody>
+          <a:bodyPr wrap="none" lIns="0" rIns="0" tIns="0" bIns="0">
+            <a:noAutofit/>
+          </a:bodyPr>
+          <a:lstStyle/>
+          <a:p>
+            <a:pPr>
+              <a:lnSpc>
+                <a:spcPts val="2360"/>
+              </a:lnSpc>
+              <a:spcAft>
+                <a:spcPts val="0"/>
+              </a:spcAft>
+              <a:defRPr sz="2000" b="0">
+                <a:solidFill>
+                  <a:srgbClr val="ADE6D5"/>
+                </a:solidFill>
+                <a:latin typeface="Arial"/>
+              </a:defRPr>
+            </a:pPr>
+            <a:r>
+              <a:t>Kdy a kde vystoupí?</a:t>
+            </a:r>
+          </a:p>
+        </p:txBody>
+      </p:sp>
+      <p:sp>
+        <p:nvSpPr>
+          <p:cNvPr id="12" name="TextBox 11"/>
+          <p:cNvSpPr txBox="1"/>
+          <p:nvPr/>
+        </p:nvSpPr>
+        <p:spPr>
+          <a:xfrm>
+            <a:off x="838200" y="4546600"/>
+            <a:ext cx="3048000" cy="711200"/>
+          </a:xfrm>
+          <a:prstGeom prst="rect">
+            <a:avLst/>
+          </a:prstGeom>
+          <a:noFill/>
+        </p:spPr>
+        <p:txBody>
+          <a:bodyPr wrap="none" lIns="0" rIns="0" tIns="0" bIns="0">
+            <a:noAutofit/>
+          </a:bodyPr>
+          <a:lstStyle/>
+          <a:p>
+            <a:pPr>
+              <a:lnSpc>
+                <a:spcPts val="2242"/>
+              </a:lnSpc>
+              <a:spcAft>
+                <a:spcPts val="0"/>
+              </a:spcAft>
+              <a:defRPr sz="1900" b="0">
+                <a:solidFill>
+                  <a:srgbClr val="B7BFCC"/>
+                </a:solidFill>
+                <a:latin typeface="Arial"/>
+              </a:defRPr>
+            </a:pPr>
+            <a:r>
+              <a:t>Detail → den a scéna</a:t>
+            </a:r>
+          </a:p>
+          <a:p>
+            <a:pPr>
+              <a:lnSpc>
+                <a:spcPts val="2242"/>
+              </a:lnSpc>
+              <a:spcAft>
+                <a:spcPts val="0"/>
+              </a:spcAft>
+              <a:defRPr sz="1900" b="0">
+                <a:solidFill>
+                  <a:srgbClr val="B7BFCC"/>
+                </a:solidFill>
+                <a:latin typeface="Arial"/>
+              </a:defRPr>
+            </a:pPr>
+            <a:r>
+              <a:t>→ odpovídající vstup</a:t>
+            </a:r>
+          </a:p>
+        </p:txBody>
+      </p:sp>
+      <p:sp>
+        <p:nvSpPr>
+          <p:cNvPr id="13" name="Rectangle 12"/>
+          <p:cNvSpPr/>
+          <p:nvPr/>
+        </p:nvSpPr>
+        <p:spPr>
+          <a:xfrm>
+            <a:off x="4343400" y="2209800"/>
+            <a:ext cx="3505200" cy="3162300"/>
+          </a:xfrm>
+          <a:prstGeom prst="rect">
+            <a:avLst/>
+          </a:prstGeom>
+          <a:solidFill>
+            <a:srgbClr val="1D222C"/>
+          </a:solidFill>
+          <a:ln>
+            <a:noFill/>
+          </a:ln>
+        </p:spPr>
+        <p:style>
+          <a:lnRef idx="1">
+            <a:schemeClr val="accent1"/>
+          </a:lnRef>
+          <a:fillRef idx="3">
+            <a:schemeClr val="accent1"/>
+          </a:fillRef>
+          <a:effectRef idx="2">
+            <a:schemeClr val="accent1"/>
+          </a:effectRef>
+          <a:fontRef idx="minor">
+            <a:schemeClr val="lt1"/>
+          </a:fontRef>
+        </p:style>
+        <p:txBody>
+          <a:bodyPr rtlCol="0" anchor="ctr"/>
+          <a:lstStyle/>
+          <a:p>
+            <a:pPr algn="ctr"/>
+          </a:p>
+        </p:txBody>
+      </p:sp>
+      <p:sp>
+        <p:nvSpPr>
+          <p:cNvPr id="14" name="Rectangle 13"/>
+          <p:cNvSpPr/>
+          <p:nvPr/>
+        </p:nvSpPr>
+        <p:spPr>
+          <a:xfrm>
+            <a:off x="4343400" y="2209800"/>
+            <a:ext cx="3505200" cy="50800"/>
+          </a:xfrm>
+          <a:prstGeom prst="rect">
+            <a:avLst/>
+          </a:prstGeom>
+          <a:solidFill>
+            <a:srgbClr val="ADE6D5"/>
+          </a:solidFill>
+          <a:ln>
+            <a:noFill/>
+          </a:ln>
+        </p:spPr>
+        <p:style>
+          <a:lnRef idx="1">
+            <a:schemeClr val="accent1"/>
+          </a:lnRef>
+          <a:fillRef idx="3">
+            <a:schemeClr val="accent1"/>
+          </a:fillRef>
+          <a:effectRef idx="2">
+            <a:schemeClr val="accent1"/>
+          </a:effectRef>
+          <a:fontRef idx="minor">
+            <a:schemeClr val="lt1"/>
+          </a:fontRef>
+        </p:style>
+        <p:txBody>
+          <a:bodyPr rtlCol="0" anchor="ctr"/>
+          <a:lstStyle/>
+          <a:p>
+            <a:pPr algn="ctr"/>
+          </a:p>
+        </p:txBody>
+      </p:sp>
+      <p:sp>
+        <p:nvSpPr>
+          <p:cNvPr id="15" name="TextBox 14"/>
+          <p:cNvSpPr txBox="1"/>
+          <p:nvPr/>
+        </p:nvSpPr>
+        <p:spPr>
+          <a:xfrm>
+            <a:off x="4572000" y="2438400"/>
+            <a:ext cx="3048000" cy="254000"/>
+          </a:xfrm>
+          <a:prstGeom prst="rect">
+            <a:avLst/>
+          </a:prstGeom>
+          <a:noFill/>
+        </p:spPr>
+        <p:txBody>
+          <a:bodyPr wrap="none" lIns="0" rIns="0" tIns="0" bIns="0">
+            <a:noAutofit/>
+          </a:bodyPr>
+          <a:lstStyle/>
+          <a:p>
+            <a:pPr>
+              <a:lnSpc>
+                <a:spcPts val="1770"/>
+              </a:lnSpc>
+              <a:spcAft>
+                <a:spcPts val="0"/>
+              </a:spcAft>
+              <a:defRPr sz="1500" b="1">
+                <a:solidFill>
+                  <a:srgbClr val="FF885D"/>
+                </a:solidFill>
+                <a:latin typeface="Arial"/>
+              </a:defRPr>
+            </a:pPr>
+            <a:r>
+              <a:t>02</a:t>
+            </a:r>
+          </a:p>
+        </p:txBody>
+      </p:sp>
+      <p:sp>
+        <p:nvSpPr>
+          <p:cNvPr id="16" name="TextBox 15"/>
+          <p:cNvSpPr txBox="1"/>
+          <p:nvPr/>
+        </p:nvSpPr>
+        <p:spPr>
+          <a:xfrm>
+            <a:off x="4572000" y="2844800"/>
+            <a:ext cx="3048000" cy="774700"/>
+          </a:xfrm>
+          <a:prstGeom prst="rect">
+            <a:avLst/>
+          </a:prstGeom>
+          <a:noFill/>
+        </p:spPr>
+        <p:txBody>
+          <a:bodyPr wrap="none" lIns="0" rIns="0" tIns="0" bIns="0">
+            <a:noAutofit/>
+          </a:bodyPr>
+          <a:lstStyle/>
           <a:p>
             <a:pPr>
               <a:lnSpc>
@@ -4844,20 +5079,20 @@
               </a:defRPr>
             </a:pPr>
             <a:r>
-              <a:t>mobilu</a:t>
-            </a:r>
-          </a:p>
-        </p:txBody>
-      </p:sp>
-      <p:sp>
-        <p:nvSpPr>
-          <p:cNvPr id="11" name="TextBox 10"/>
+              <a:t>Více koncertů</a:t>
+            </a:r>
+          </a:p>
+        </p:txBody>
+      </p:sp>
+      <p:sp>
+        <p:nvSpPr>
+          <p:cNvPr id="17" name="TextBox 16"/>
           <p:cNvSpPr txBox="1"/>
           <p:nvPr/>
         </p:nvSpPr>
         <p:spPr>
           <a:xfrm>
-            <a:off x="838200" y="3746500"/>
+            <a:off x="4572000" y="3746500"/>
             <a:ext cx="3048000" cy="711200"/>
           </a:xfrm>
           <a:prstGeom prst="rect">
@@ -4886,20 +5121,20 @@
               </a:defRPr>
             </a:pPr>
             <a:r>
-              <a:t>Co hraje dnes a kde?</a:t>
-            </a:r>
-          </a:p>
-        </p:txBody>
-      </p:sp>
-      <p:sp>
-        <p:nvSpPr>
-          <p:cNvPr id="12" name="TextBox 11"/>
+              <a:t>Co chci stihnout?</a:t>
+            </a:r>
+          </a:p>
+        </p:txBody>
+      </p:sp>
+      <p:sp>
+        <p:nvSpPr>
+          <p:cNvPr id="18" name="TextBox 17"/>
           <p:cNvSpPr txBox="1"/>
           <p:nvPr/>
         </p:nvSpPr>
         <p:spPr>
           <a:xfrm>
-            <a:off x="838200" y="4546600"/>
+            <a:off x="4572000" y="4546600"/>
             <a:ext cx="3048000" cy="711200"/>
           </a:xfrm>
           <a:prstGeom prst="rect">
@@ -4928,7 +5163,7 @@
               </a:defRPr>
             </a:pPr>
             <a:r>
-              <a:t>Filtr dne a scény</a:t>
+              <a:t>Filtry a osobní program</a:t>
             </a:r>
           </a:p>
           <a:p>
@@ -4947,20 +5182,20 @@
               </a:defRPr>
             </a:pPr>
             <a:r>
-              <a:t>Uložený osobní program</a:t>
-            </a:r>
-          </a:p>
-        </p:txBody>
-      </p:sp>
-      <p:sp>
-        <p:nvSpPr>
-          <p:cNvPr id="13" name="Rectangle 12"/>
+              <a:t>→ vybrané dny</a:t>
+            </a:r>
+          </a:p>
+        </p:txBody>
+      </p:sp>
+      <p:sp>
+        <p:nvSpPr>
+          <p:cNvPr id="19" name="Rectangle 18"/>
           <p:cNvSpPr/>
           <p:nvPr/>
         </p:nvSpPr>
         <p:spPr>
           <a:xfrm>
-            <a:off x="4343400" y="2209800"/>
+            <a:off x="8077200" y="2209800"/>
             <a:ext cx="3505200" cy="3162300"/>
           </a:xfrm>
           <a:prstGeom prst="rect">
@@ -4997,20 +5232,20 @@
       </p:sp>
       <p:sp>
         <p:nvSpPr>
-          <p:cNvPr id="14" name="Rectangle 13"/>
+          <p:cNvPr id="20" name="Rectangle 19"/>
           <p:cNvSpPr/>
           <p:nvPr/>
         </p:nvSpPr>
         <p:spPr>
           <a:xfrm>
-            <a:off x="4343400" y="2209800"/>
+            <a:off x="8077200" y="2209800"/>
             <a:ext cx="3505200" cy="50800"/>
           </a:xfrm>
           <a:prstGeom prst="rect">
             <a:avLst/>
           </a:prstGeom>
           <a:solidFill>
-            <a:srgbClr val="ADE6D5"/>
+            <a:srgbClr val="FF885D"/>
           </a:solidFill>
           <a:ln>
             <a:noFill/>
@@ -5040,13 +5275,13 @@
       </p:sp>
       <p:sp>
         <p:nvSpPr>
-          <p:cNvPr id="15" name="TextBox 14"/>
+          <p:cNvPr id="21" name="TextBox 20"/>
           <p:cNvSpPr txBox="1"/>
           <p:nvPr/>
         </p:nvSpPr>
         <p:spPr>
           <a:xfrm>
-            <a:off x="4572000" y="2438400"/>
+            <a:off x="8305800" y="2438400"/>
             <a:ext cx="3048000" cy="254000"/>
           </a:xfrm>
           <a:prstGeom prst="rect">
@@ -5075,20 +5310,20 @@
               </a:defRPr>
             </a:pPr>
             <a:r>
-              <a:t>02</a:t>
-            </a:r>
-          </a:p>
-        </p:txBody>
-      </p:sp>
-      <p:sp>
-        <p:nvSpPr>
-          <p:cNvPr id="16" name="TextBox 15"/>
+              <a:t>03</a:t>
+            </a:r>
+          </a:p>
+        </p:txBody>
+      </p:sp>
+      <p:sp>
+        <p:nvSpPr>
+          <p:cNvPr id="22" name="TextBox 21"/>
           <p:cNvSpPr txBox="1"/>
           <p:nvPr/>
         </p:nvSpPr>
         <p:spPr>
           <a:xfrm>
-            <a:off x="4572000" y="2844800"/>
+            <a:off x="8305800" y="2844800"/>
             <a:ext cx="3048000" cy="774700"/>
           </a:xfrm>
           <a:prstGeom prst="rect">
@@ -5117,20 +5352,20 @@
               </a:defRPr>
             </a:pPr>
             <a:r>
-              <a:t>Fanoušek interpreta</a:t>
-            </a:r>
-          </a:p>
-        </p:txBody>
-      </p:sp>
-      <p:sp>
-        <p:nvSpPr>
-          <p:cNvPr id="17" name="TextBox 16"/>
+              <a:t>Celý festival</a:t>
+            </a:r>
+          </a:p>
+        </p:txBody>
+      </p:sp>
+      <p:sp>
+        <p:nvSpPr>
+          <p:cNvPr id="23" name="TextBox 22"/>
           <p:cNvSpPr txBox="1"/>
           <p:nvPr/>
         </p:nvSpPr>
         <p:spPr>
           <a:xfrm>
-            <a:off x="4572000" y="3746500"/>
+            <a:off x="8305800" y="3746500"/>
             <a:ext cx="3048000" cy="711200"/>
           </a:xfrm>
           <a:prstGeom prst="rect">
@@ -5159,20 +5394,20 @@
               </a:defRPr>
             </a:pPr>
             <a:r>
-              <a:t>Kdy vystoupí moje jméno?</a:t>
-            </a:r>
-          </a:p>
-        </p:txBody>
-      </p:sp>
-      <p:sp>
-        <p:nvSpPr>
-          <p:cNvPr id="18" name="TextBox 17"/>
+              <a:t>Co zahrnuje celý vstup?</a:t>
+            </a:r>
+          </a:p>
+        </p:txBody>
+      </p:sp>
+      <p:sp>
+        <p:nvSpPr>
+          <p:cNvPr id="24" name="TextBox 23"/>
           <p:cNvSpPr txBox="1"/>
           <p:nvPr/>
         </p:nvSpPr>
         <p:spPr>
           <a:xfrm>
-            <a:off x="4572000" y="4546600"/>
+            <a:off x="8305800" y="4546600"/>
             <a:ext cx="3048000" cy="711200"/>
           </a:xfrm>
           <a:prstGeom prst="rect">
@@ -5201,7 +5436,7 @@
               </a:defRPr>
             </a:pPr>
             <a:r>
-              <a:t>Hledání → detail</a:t>
+              <a:t>Tři dny, všechny scény</a:t>
             </a:r>
           </a:p>
           <a:p>
@@ -5220,280 +5455,7 @@
               </a:defRPr>
             </a:pPr>
             <a:r>
-              <a:t>Koncert a hudební odkazy</a:t>
-            </a:r>
-          </a:p>
-        </p:txBody>
-      </p:sp>
-      <p:sp>
-        <p:nvSpPr>
-          <p:cNvPr id="19" name="Rectangle 18"/>
-          <p:cNvSpPr/>
-          <p:nvPr/>
-        </p:nvSpPr>
-        <p:spPr>
-          <a:xfrm>
-            <a:off x="8077200" y="2209800"/>
-            <a:ext cx="3505200" cy="3162300"/>
-          </a:xfrm>
-          <a:prstGeom prst="rect">
-            <a:avLst/>
-          </a:prstGeom>
-          <a:solidFill>
-            <a:srgbClr val="1D222C"/>
-          </a:solidFill>
-          <a:ln>
-            <a:noFill/>
-          </a:ln>
-        </p:spPr>
-        <p:style>
-          <a:lnRef idx="1">
-            <a:schemeClr val="accent1"/>
-          </a:lnRef>
-          <a:fillRef idx="3">
-            <a:schemeClr val="accent1"/>
-          </a:fillRef>
-          <a:effectRef idx="2">
-            <a:schemeClr val="accent1"/>
-          </a:effectRef>
-          <a:fontRef idx="minor">
-            <a:schemeClr val="lt1"/>
-          </a:fontRef>
-        </p:style>
-        <p:txBody>
-          <a:bodyPr rtlCol="0" anchor="ctr"/>
-          <a:lstStyle/>
-          <a:p>
-            <a:pPr algn="ctr"/>
-          </a:p>
-        </p:txBody>
-      </p:sp>
-      <p:sp>
-        <p:nvSpPr>
-          <p:cNvPr id="20" name="Rectangle 19"/>
-          <p:cNvSpPr/>
-          <p:nvPr/>
-        </p:nvSpPr>
-        <p:spPr>
-          <a:xfrm>
-            <a:off x="8077200" y="2209800"/>
-            <a:ext cx="3505200" cy="50800"/>
-          </a:xfrm>
-          <a:prstGeom prst="rect">
-            <a:avLst/>
-          </a:prstGeom>
-          <a:solidFill>
-            <a:srgbClr val="FF885D"/>
-          </a:solidFill>
-          <a:ln>
-            <a:noFill/>
-          </a:ln>
-        </p:spPr>
-        <p:style>
-          <a:lnRef idx="1">
-            <a:schemeClr val="accent1"/>
-          </a:lnRef>
-          <a:fillRef idx="3">
-            <a:schemeClr val="accent1"/>
-          </a:fillRef>
-          <a:effectRef idx="2">
-            <a:schemeClr val="accent1"/>
-          </a:effectRef>
-          <a:fontRef idx="minor">
-            <a:schemeClr val="lt1"/>
-          </a:fontRef>
-        </p:style>
-        <p:txBody>
-          <a:bodyPr rtlCol="0" anchor="ctr"/>
-          <a:lstStyle/>
-          <a:p>
-            <a:pPr algn="ctr"/>
-          </a:p>
-        </p:txBody>
-      </p:sp>
-      <p:sp>
-        <p:nvSpPr>
-          <p:cNvPr id="21" name="TextBox 20"/>
-          <p:cNvSpPr txBox="1"/>
-          <p:nvPr/>
-        </p:nvSpPr>
-        <p:spPr>
-          <a:xfrm>
-            <a:off x="8305800" y="2438400"/>
-            <a:ext cx="3048000" cy="254000"/>
-          </a:xfrm>
-          <a:prstGeom prst="rect">
-            <a:avLst/>
-          </a:prstGeom>
-          <a:noFill/>
-        </p:spPr>
-        <p:txBody>
-          <a:bodyPr wrap="none" lIns="0" rIns="0" tIns="0" bIns="0">
-            <a:noAutofit/>
-          </a:bodyPr>
-          <a:lstStyle/>
-          <a:p>
-            <a:pPr>
-              <a:lnSpc>
-                <a:spcPts val="1770"/>
-              </a:lnSpc>
-              <a:spcAft>
-                <a:spcPts val="0"/>
-              </a:spcAft>
-              <a:defRPr sz="1500" b="1">
-                <a:solidFill>
-                  <a:srgbClr val="FF885D"/>
-                </a:solidFill>
-                <a:latin typeface="Arial"/>
-              </a:defRPr>
-            </a:pPr>
-            <a:r>
-              <a:t>03</a:t>
-            </a:r>
-          </a:p>
-        </p:txBody>
-      </p:sp>
-      <p:sp>
-        <p:nvSpPr>
-          <p:cNvPr id="22" name="TextBox 21"/>
-          <p:cNvSpPr txBox="1"/>
-          <p:nvPr/>
-        </p:nvSpPr>
-        <p:spPr>
-          <a:xfrm>
-            <a:off x="8305800" y="2844800"/>
-            <a:ext cx="3048000" cy="774700"/>
-          </a:xfrm>
-          <a:prstGeom prst="rect">
-            <a:avLst/>
-          </a:prstGeom>
-          <a:noFill/>
-        </p:spPr>
-        <p:txBody>
-          <a:bodyPr wrap="none" lIns="0" rIns="0" tIns="0" bIns="0">
-            <a:noAutofit/>
-          </a:bodyPr>
-          <a:lstStyle/>
-          <a:p>
-            <a:pPr>
-              <a:lnSpc>
-                <a:spcPts val="2832"/>
-              </a:lnSpc>
-              <a:spcAft>
-                <a:spcPts val="0"/>
-              </a:spcAft>
-              <a:defRPr sz="2400" b="1">
-                <a:solidFill>
-                  <a:srgbClr val="F5F6FA"/>
-                </a:solidFill>
-                <a:latin typeface="Arial"/>
-              </a:defRPr>
-            </a:pPr>
-            <a:r>
-              <a:t>Návštěvník Prahy</a:t>
-            </a:r>
-          </a:p>
-        </p:txBody>
-      </p:sp>
-      <p:sp>
-        <p:nvSpPr>
-          <p:cNvPr id="23" name="TextBox 22"/>
-          <p:cNvSpPr txBox="1"/>
-          <p:nvPr/>
-        </p:nvSpPr>
-        <p:spPr>
-          <a:xfrm>
-            <a:off x="8305800" y="3746500"/>
-            <a:ext cx="3048000" cy="711200"/>
-          </a:xfrm>
-          <a:prstGeom prst="rect">
-            <a:avLst/>
-          </a:prstGeom>
-          <a:noFill/>
-        </p:spPr>
-        <p:txBody>
-          <a:bodyPr wrap="none" lIns="0" rIns="0" tIns="0" bIns="0">
-            <a:noAutofit/>
-          </a:bodyPr>
-          <a:lstStyle/>
-          <a:p>
-            <a:pPr>
-              <a:lnSpc>
-                <a:spcPts val="2360"/>
-              </a:lnSpc>
-              <a:spcAft>
-                <a:spcPts val="0"/>
-              </a:spcAft>
-              <a:defRPr sz="2000" b="0">
-                <a:solidFill>
-                  <a:srgbClr val="ADE6D5"/>
-                </a:solidFill>
-                <a:latin typeface="Arial"/>
-              </a:defRPr>
-            </a:pPr>
-            <a:r>
-              <a:t>Jak se dostanu do areálu?</a:t>
-            </a:r>
-          </a:p>
-        </p:txBody>
-      </p:sp>
-      <p:sp>
-        <p:nvSpPr>
-          <p:cNvPr id="24" name="TextBox 23"/>
-          <p:cNvSpPr txBox="1"/>
-          <p:nvPr/>
-        </p:nvSpPr>
-        <p:spPr>
-          <a:xfrm>
-            <a:off x="8305800" y="4546600"/>
-            <a:ext cx="3048000" cy="711200"/>
-          </a:xfrm>
-          <a:prstGeom prst="rect">
-            <a:avLst/>
-          </a:prstGeom>
-          <a:noFill/>
-        </p:spPr>
-        <p:txBody>
-          <a:bodyPr wrap="none" lIns="0" rIns="0" tIns="0" bIns="0">
-            <a:noAutofit/>
-          </a:bodyPr>
-          <a:lstStyle/>
-          <a:p>
-            <a:pPr>
-              <a:lnSpc>
-                <a:spcPts val="2242"/>
-              </a:lnSpc>
-              <a:spcAft>
-                <a:spcPts val="0"/>
-              </a:spcAft>
-              <a:defRPr sz="1900" b="0">
-                <a:solidFill>
-                  <a:srgbClr val="B7BFCC"/>
-                </a:solidFill>
-                <a:latin typeface="Arial"/>
-              </a:defRPr>
-            </a:pPr>
-            <a:r>
-              <a:t>Doprava a plánek</a:t>
-            </a:r>
-          </a:p>
-          <a:p>
-            <a:pPr>
-              <a:lnSpc>
-                <a:spcPts val="2242"/>
-              </a:lnSpc>
-              <a:spcAft>
-                <a:spcPts val="0"/>
-              </a:spcAft>
-              <a:defRPr sz="1900" b="0">
-                <a:solidFill>
-                  <a:srgbClr val="B7BFCC"/>
-                </a:solidFill>
-                <a:latin typeface="Arial"/>
-              </a:defRPr>
-            </a:pPr>
-            <a:r>
-              <a:t>Čeština / angličtina</a:t>
+              <a:t>→ cena a dostupnost</a:t>
             </a:r>
           </a:p>
         </p:txBody>
@@ -5535,7 +5497,7 @@
               </a:defRPr>
             </a:pPr>
             <a:r>
-              <a:t>Hlavní akce: najít koncert → uložit program → vybrat vstupenku.</a:t>
+              <a:t>Cíl: přehledně nabídnout to, co chce návštěvník opravdu navštívit.</a:t>
             </a:r>
           </a:p>
         </p:txBody>
@@ -5808,7 +5770,7 @@
               </a:defRPr>
             </a:pPr>
             <a:r>
-              <a:t>XML · ENTITY · KAPACITY</a:t>
+              <a:t>DATOVÁ ZÁKLADNA A JEJÍ VYUŽITÍ</a:t>
             </a:r>
           </a:p>
         </p:txBody>
@@ -5893,7 +5855,7 @@
               </a:defRPr>
             </a:pPr>
             <a:r>
-              <a:t>Jedna datová základna, tři scény</a:t>
+              <a:t>Stejná data pro program i nákup</a:t>
             </a:r>
           </a:p>
         </p:txBody>
@@ -5906,8 +5868,8 @@
         </p:nvSpPr>
         <p:spPr>
           <a:xfrm>
-            <a:off x="609600" y="2209800"/>
-            <a:ext cx="2540000" cy="863600"/>
+            <a:off x="609600" y="2171700"/>
+            <a:ext cx="2540000" cy="698500"/>
           </a:xfrm>
           <a:prstGeom prst="rect">
             <a:avLst/>
@@ -5922,12 +5884,12 @@
           <a:p>
             <a:pPr>
               <a:lnSpc>
-                <a:spcPts val="6725"/>
+                <a:spcPts val="5309"/>
               </a:lnSpc>
               <a:spcAft>
                 <a:spcPts val="0"/>
               </a:spcAft>
-              <a:defRPr sz="5700" b="1">
+              <a:defRPr sz="4500" b="1">
                 <a:solidFill>
                   <a:srgbClr val="FF885D"/>
                 </a:solidFill>
@@ -5948,938 +5910,8 @@
         </p:nvSpPr>
         <p:spPr>
           <a:xfrm>
-            <a:off x="609600" y="3048000"/>
-            <a:ext cx="2540000" cy="368300"/>
-          </a:xfrm>
-          <a:prstGeom prst="rect">
-            <a:avLst/>
-          </a:prstGeom>
-          <a:noFill/>
-        </p:spPr>
-        <p:txBody>
-          <a:bodyPr wrap="none" lIns="0" rIns="0" tIns="0" bIns="0">
-            <a:noAutofit/>
-          </a:bodyPr>
-          <a:lstStyle/>
-          <a:p>
-            <a:pPr>
-              <a:lnSpc>
-                <a:spcPts val="2477"/>
-              </a:lnSpc>
-              <a:spcAft>
-                <a:spcPts val="0"/>
-              </a:spcAft>
-              <a:defRPr sz="2100" b="0">
-                <a:solidFill>
-                  <a:srgbClr val="F5F6FA"/>
-                </a:solidFill>
-                <a:latin typeface="Arial"/>
-              </a:defRPr>
-            </a:pPr>
-            <a:r>
-              <a:t>dny</a:t>
-            </a:r>
-          </a:p>
-        </p:txBody>
-      </p:sp>
-      <p:sp>
-        <p:nvSpPr>
-          <p:cNvPr id="9" name="TextBox 8"/>
-          <p:cNvSpPr txBox="1"/>
-          <p:nvPr/>
-        </p:nvSpPr>
-        <p:spPr>
-          <a:xfrm>
-            <a:off x="3416300" y="2209800"/>
-            <a:ext cx="2540000" cy="863600"/>
-          </a:xfrm>
-          <a:prstGeom prst="rect">
-            <a:avLst/>
-          </a:prstGeom>
-          <a:noFill/>
-        </p:spPr>
-        <p:txBody>
-          <a:bodyPr wrap="none" lIns="0" rIns="0" tIns="0" bIns="0">
-            <a:noAutofit/>
-          </a:bodyPr>
-          <a:lstStyle/>
-          <a:p>
-            <a:pPr>
-              <a:lnSpc>
-                <a:spcPts val="6725"/>
-              </a:lnSpc>
-              <a:spcAft>
-                <a:spcPts val="0"/>
-              </a:spcAft>
-              <a:defRPr sz="5700" b="1">
-                <a:solidFill>
-                  <a:srgbClr val="FF885D"/>
-                </a:solidFill>
-                <a:latin typeface="Arial"/>
-              </a:defRPr>
-            </a:pPr>
-            <a:r>
-              <a:t>3</a:t>
-            </a:r>
-          </a:p>
-        </p:txBody>
-      </p:sp>
-      <p:sp>
-        <p:nvSpPr>
-          <p:cNvPr id="10" name="TextBox 9"/>
-          <p:cNvSpPr txBox="1"/>
-          <p:nvPr/>
-        </p:nvSpPr>
-        <p:spPr>
-          <a:xfrm>
-            <a:off x="3416300" y="3048000"/>
-            <a:ext cx="2540000" cy="368300"/>
-          </a:xfrm>
-          <a:prstGeom prst="rect">
-            <a:avLst/>
-          </a:prstGeom>
-          <a:noFill/>
-        </p:spPr>
-        <p:txBody>
-          <a:bodyPr wrap="none" lIns="0" rIns="0" tIns="0" bIns="0">
-            <a:noAutofit/>
-          </a:bodyPr>
-          <a:lstStyle/>
-          <a:p>
-            <a:pPr>
-              <a:lnSpc>
-                <a:spcPts val="2477"/>
-              </a:lnSpc>
-              <a:spcAft>
-                <a:spcPts val="0"/>
-              </a:spcAft>
-              <a:defRPr sz="2100" b="0">
-                <a:solidFill>
-                  <a:srgbClr val="F5F6FA"/>
-                </a:solidFill>
-                <a:latin typeface="Arial"/>
-              </a:defRPr>
-            </a:pPr>
-            <a:r>
-              <a:t>scény</a:t>
-            </a:r>
-          </a:p>
-        </p:txBody>
-      </p:sp>
-      <p:sp>
-        <p:nvSpPr>
-          <p:cNvPr id="11" name="TextBox 10"/>
-          <p:cNvSpPr txBox="1"/>
-          <p:nvPr/>
-        </p:nvSpPr>
-        <p:spPr>
-          <a:xfrm>
-            <a:off x="6223000" y="2209800"/>
-            <a:ext cx="2540000" cy="863600"/>
-          </a:xfrm>
-          <a:prstGeom prst="rect">
-            <a:avLst/>
-          </a:prstGeom>
-          <a:noFill/>
-        </p:spPr>
-        <p:txBody>
-          <a:bodyPr wrap="none" lIns="0" rIns="0" tIns="0" bIns="0">
-            <a:noAutofit/>
-          </a:bodyPr>
-          <a:lstStyle/>
-          <a:p>
-            <a:pPr>
-              <a:lnSpc>
-                <a:spcPts val="6725"/>
-              </a:lnSpc>
-              <a:spcAft>
-                <a:spcPts val="0"/>
-              </a:spcAft>
-              <a:defRPr sz="5700" b="1">
-                <a:solidFill>
-                  <a:srgbClr val="FF885D"/>
-                </a:solidFill>
-                <a:latin typeface="Arial"/>
-              </a:defRPr>
-            </a:pPr>
-            <a:r>
-              <a:t>60</a:t>
-            </a:r>
-          </a:p>
-        </p:txBody>
-      </p:sp>
-      <p:sp>
-        <p:nvSpPr>
-          <p:cNvPr id="12" name="TextBox 11"/>
-          <p:cNvSpPr txBox="1"/>
-          <p:nvPr/>
-        </p:nvSpPr>
-        <p:spPr>
-          <a:xfrm>
-            <a:off x="6223000" y="3048000"/>
-            <a:ext cx="2540000" cy="368300"/>
-          </a:xfrm>
-          <a:prstGeom prst="rect">
-            <a:avLst/>
-          </a:prstGeom>
-          <a:noFill/>
-        </p:spPr>
-        <p:txBody>
-          <a:bodyPr wrap="none" lIns="0" rIns="0" tIns="0" bIns="0">
-            <a:noAutofit/>
-          </a:bodyPr>
-          <a:lstStyle/>
-          <a:p>
-            <a:pPr>
-              <a:lnSpc>
-                <a:spcPts val="2477"/>
-              </a:lnSpc>
-              <a:spcAft>
-                <a:spcPts val="0"/>
-              </a:spcAft>
-              <a:defRPr sz="2100" b="0">
-                <a:solidFill>
-                  <a:srgbClr val="F5F6FA"/>
-                </a:solidFill>
-                <a:latin typeface="Arial"/>
-              </a:defRPr>
-            </a:pPr>
-            <a:r>
-              <a:t>účinkujících</a:t>
-            </a:r>
-          </a:p>
-        </p:txBody>
-      </p:sp>
-      <p:sp>
-        <p:nvSpPr>
-          <p:cNvPr id="13" name="TextBox 12"/>
-          <p:cNvSpPr txBox="1"/>
-          <p:nvPr/>
-        </p:nvSpPr>
-        <p:spPr>
-          <a:xfrm>
-            <a:off x="9029700" y="2209800"/>
-            <a:ext cx="2540000" cy="863600"/>
-          </a:xfrm>
-          <a:prstGeom prst="rect">
-            <a:avLst/>
-          </a:prstGeom>
-          <a:noFill/>
-        </p:spPr>
-        <p:txBody>
-          <a:bodyPr wrap="none" lIns="0" rIns="0" tIns="0" bIns="0">
-            <a:noAutofit/>
-          </a:bodyPr>
-          <a:lstStyle/>
-          <a:p>
-            <a:pPr>
-              <a:lnSpc>
-                <a:spcPts val="6725"/>
-              </a:lnSpc>
-              <a:spcAft>
-                <a:spcPts val="0"/>
-              </a:spcAft>
-              <a:defRPr sz="5700" b="1">
-                <a:solidFill>
-                  <a:srgbClr val="FF885D"/>
-                </a:solidFill>
-                <a:latin typeface="Arial"/>
-              </a:defRPr>
-            </a:pPr>
-            <a:r>
-              <a:t>60</a:t>
-            </a:r>
-          </a:p>
-        </p:txBody>
-      </p:sp>
-      <p:sp>
-        <p:nvSpPr>
-          <p:cNvPr id="14" name="TextBox 13"/>
-          <p:cNvSpPr txBox="1"/>
-          <p:nvPr/>
-        </p:nvSpPr>
-        <p:spPr>
-          <a:xfrm>
-            <a:off x="9029700" y="3048000"/>
-            <a:ext cx="2540000" cy="368300"/>
-          </a:xfrm>
-          <a:prstGeom prst="rect">
-            <a:avLst/>
-          </a:prstGeom>
-          <a:noFill/>
-        </p:spPr>
-        <p:txBody>
-          <a:bodyPr wrap="none" lIns="0" rIns="0" tIns="0" bIns="0">
-            <a:noAutofit/>
-          </a:bodyPr>
-          <a:lstStyle/>
-          <a:p>
-            <a:pPr>
-              <a:lnSpc>
-                <a:spcPts val="2477"/>
-              </a:lnSpc>
-              <a:spcAft>
-                <a:spcPts val="0"/>
-              </a:spcAft>
-              <a:defRPr sz="2100" b="0">
-                <a:solidFill>
-                  <a:srgbClr val="F5F6FA"/>
-                </a:solidFill>
-                <a:latin typeface="Arial"/>
-              </a:defRPr>
-            </a:pPr>
-            <a:r>
-              <a:t>vystoupení</a:t>
-            </a:r>
-          </a:p>
-        </p:txBody>
-      </p:sp>
-      <p:sp>
-        <p:nvSpPr>
-          <p:cNvPr id="15" name="Rectangle 14"/>
-          <p:cNvSpPr/>
-          <p:nvPr/>
-        </p:nvSpPr>
-        <p:spPr>
-          <a:xfrm>
-            <a:off x="609600" y="3771900"/>
-            <a:ext cx="3505200" cy="1422400"/>
-          </a:xfrm>
-          <a:prstGeom prst="rect">
-            <a:avLst/>
-          </a:prstGeom>
-          <a:solidFill>
-            <a:srgbClr val="1D222C"/>
-          </a:solidFill>
-          <a:ln>
-            <a:noFill/>
-          </a:ln>
-        </p:spPr>
-        <p:style>
-          <a:lnRef idx="1">
-            <a:schemeClr val="accent1"/>
-          </a:lnRef>
-          <a:fillRef idx="3">
-            <a:schemeClr val="accent1"/>
-          </a:fillRef>
-          <a:effectRef idx="2">
-            <a:schemeClr val="accent1"/>
-          </a:effectRef>
-          <a:fontRef idx="minor">
-            <a:schemeClr val="lt1"/>
-          </a:fontRef>
-        </p:style>
-        <p:txBody>
-          <a:bodyPr rtlCol="0" anchor="ctr"/>
-          <a:lstStyle/>
-          <a:p>
-            <a:pPr algn="ctr"/>
-          </a:p>
-        </p:txBody>
-      </p:sp>
-      <p:sp>
-        <p:nvSpPr>
-          <p:cNvPr id="16" name="Rectangle 15"/>
-          <p:cNvSpPr/>
-          <p:nvPr/>
-        </p:nvSpPr>
-        <p:spPr>
-          <a:xfrm>
-            <a:off x="609600" y="3771900"/>
-            <a:ext cx="50800" cy="1422400"/>
-          </a:xfrm>
-          <a:prstGeom prst="rect">
-            <a:avLst/>
-          </a:prstGeom>
-          <a:solidFill>
-            <a:srgbClr val="FF885D"/>
-          </a:solidFill>
-          <a:ln>
-            <a:noFill/>
-          </a:ln>
-        </p:spPr>
-        <p:style>
-          <a:lnRef idx="1">
-            <a:schemeClr val="accent1"/>
-          </a:lnRef>
-          <a:fillRef idx="3">
-            <a:schemeClr val="accent1"/>
-          </a:fillRef>
-          <a:effectRef idx="2">
-            <a:schemeClr val="accent1"/>
-          </a:effectRef>
-          <a:fontRef idx="minor">
-            <a:schemeClr val="lt1"/>
-          </a:fontRef>
-        </p:style>
-        <p:txBody>
-          <a:bodyPr rtlCol="0" anchor="ctr"/>
-          <a:lstStyle/>
-          <a:p>
-            <a:pPr algn="ctr"/>
-          </a:p>
-        </p:txBody>
-      </p:sp>
-      <p:sp>
-        <p:nvSpPr>
-          <p:cNvPr id="17" name="TextBox 16"/>
-          <p:cNvSpPr txBox="1"/>
-          <p:nvPr/>
-        </p:nvSpPr>
-        <p:spPr>
-          <a:xfrm>
-            <a:off x="838200" y="3949700"/>
-            <a:ext cx="3048000" cy="419100"/>
-          </a:xfrm>
-          <a:prstGeom prst="rect">
-            <a:avLst/>
-          </a:prstGeom>
-          <a:noFill/>
-        </p:spPr>
-        <p:txBody>
-          <a:bodyPr wrap="none" lIns="0" rIns="0" tIns="0" bIns="0">
-            <a:noAutofit/>
-          </a:bodyPr>
-          <a:lstStyle/>
-          <a:p>
-            <a:pPr>
-              <a:lnSpc>
-                <a:spcPts val="2832"/>
-              </a:lnSpc>
-              <a:spcAft>
-                <a:spcPts val="0"/>
-              </a:spcAft>
-              <a:defRPr sz="2400" b="1">
-                <a:solidFill>
-                  <a:srgbClr val="F5F6FA"/>
-                </a:solidFill>
-                <a:latin typeface="Arial"/>
-              </a:defRPr>
-            </a:pPr>
-            <a:r>
-              <a:t>Main Hall</a:t>
-            </a:r>
-          </a:p>
-        </p:txBody>
-      </p:sp>
-      <p:sp>
-        <p:nvSpPr>
-          <p:cNvPr id="18" name="TextBox 17"/>
-          <p:cNvSpPr txBox="1"/>
-          <p:nvPr/>
-        </p:nvSpPr>
-        <p:spPr>
-          <a:xfrm>
-            <a:off x="838200" y="4406900"/>
-            <a:ext cx="3048000" cy="406400"/>
-          </a:xfrm>
-          <a:prstGeom prst="rect">
-            <a:avLst/>
-          </a:prstGeom>
-          <a:noFill/>
-        </p:spPr>
-        <p:txBody>
-          <a:bodyPr wrap="none" lIns="0" rIns="0" tIns="0" bIns="0">
-            <a:noAutofit/>
-          </a:bodyPr>
-          <a:lstStyle/>
-          <a:p>
-            <a:pPr>
-              <a:lnSpc>
-                <a:spcPts val="2832"/>
-              </a:lnSpc>
-              <a:spcAft>
-                <a:spcPts val="0"/>
-              </a:spcAft>
-              <a:defRPr sz="2400" b="1">
-                <a:solidFill>
-                  <a:srgbClr val="ADE6D5"/>
-                </a:solidFill>
-                <a:latin typeface="Arial"/>
-              </a:defRPr>
-            </a:pPr>
-            <a:r>
-              <a:t>5 000 osob</a:t>
-            </a:r>
-          </a:p>
-        </p:txBody>
-      </p:sp>
-      <p:sp>
-        <p:nvSpPr>
-          <p:cNvPr id="19" name="TextBox 18"/>
-          <p:cNvSpPr txBox="1"/>
-          <p:nvPr/>
-        </p:nvSpPr>
-        <p:spPr>
-          <a:xfrm>
-            <a:off x="838200" y="4864100"/>
-            <a:ext cx="3048000" cy="279400"/>
-          </a:xfrm>
-          <a:prstGeom prst="rect">
-            <a:avLst/>
-          </a:prstGeom>
-          <a:noFill/>
-        </p:spPr>
-        <p:txBody>
-          <a:bodyPr wrap="none" lIns="0" rIns="0" tIns="0" bIns="0">
-            <a:noAutofit/>
-          </a:bodyPr>
-          <a:lstStyle/>
-          <a:p>
-            <a:pPr>
-              <a:lnSpc>
-                <a:spcPts val="1770"/>
-              </a:lnSpc>
-              <a:spcAft>
-                <a:spcPts val="0"/>
-              </a:spcAft>
-              <a:defRPr sz="1500" b="0">
-                <a:solidFill>
-                  <a:srgbClr val="B7BFCC"/>
-                </a:solidFill>
-                <a:latin typeface="Arial"/>
-              </a:defRPr>
-            </a:pPr>
-            <a:r>
-              <a:t>VIP / Regular sedadla + stání</a:t>
-            </a:r>
-          </a:p>
-        </p:txBody>
-      </p:sp>
-      <p:sp>
-        <p:nvSpPr>
-          <p:cNvPr id="20" name="Rectangle 19"/>
-          <p:cNvSpPr/>
-          <p:nvPr/>
-        </p:nvSpPr>
-        <p:spPr>
-          <a:xfrm>
-            <a:off x="4343400" y="3771900"/>
-            <a:ext cx="3505200" cy="1422400"/>
-          </a:xfrm>
-          <a:prstGeom prst="rect">
-            <a:avLst/>
-          </a:prstGeom>
-          <a:solidFill>
-            <a:srgbClr val="1D222C"/>
-          </a:solidFill>
-          <a:ln>
-            <a:noFill/>
-          </a:ln>
-        </p:spPr>
-        <p:style>
-          <a:lnRef idx="1">
-            <a:schemeClr val="accent1"/>
-          </a:lnRef>
-          <a:fillRef idx="3">
-            <a:schemeClr val="accent1"/>
-          </a:fillRef>
-          <a:effectRef idx="2">
-            <a:schemeClr val="accent1"/>
-          </a:effectRef>
-          <a:fontRef idx="minor">
-            <a:schemeClr val="lt1"/>
-          </a:fontRef>
-        </p:style>
-        <p:txBody>
-          <a:bodyPr rtlCol="0" anchor="ctr"/>
-          <a:lstStyle/>
-          <a:p>
-            <a:pPr algn="ctr"/>
-          </a:p>
-        </p:txBody>
-      </p:sp>
-      <p:sp>
-        <p:nvSpPr>
-          <p:cNvPr id="21" name="Rectangle 20"/>
-          <p:cNvSpPr/>
-          <p:nvPr/>
-        </p:nvSpPr>
-        <p:spPr>
-          <a:xfrm>
-            <a:off x="4343400" y="3771900"/>
-            <a:ext cx="50800" cy="1422400"/>
-          </a:xfrm>
-          <a:prstGeom prst="rect">
-            <a:avLst/>
-          </a:prstGeom>
-          <a:solidFill>
-            <a:srgbClr val="ADE6D5"/>
-          </a:solidFill>
-          <a:ln>
-            <a:noFill/>
-          </a:ln>
-        </p:spPr>
-        <p:style>
-          <a:lnRef idx="1">
-            <a:schemeClr val="accent1"/>
-          </a:lnRef>
-          <a:fillRef idx="3">
-            <a:schemeClr val="accent1"/>
-          </a:fillRef>
-          <a:effectRef idx="2">
-            <a:schemeClr val="accent1"/>
-          </a:effectRef>
-          <a:fontRef idx="minor">
-            <a:schemeClr val="lt1"/>
-          </a:fontRef>
-        </p:style>
-        <p:txBody>
-          <a:bodyPr rtlCol="0" anchor="ctr"/>
-          <a:lstStyle/>
-          <a:p>
-            <a:pPr algn="ctr"/>
-          </a:p>
-        </p:txBody>
-      </p:sp>
-      <p:sp>
-        <p:nvSpPr>
-          <p:cNvPr id="22" name="TextBox 21"/>
-          <p:cNvSpPr txBox="1"/>
-          <p:nvPr/>
-        </p:nvSpPr>
-        <p:spPr>
-          <a:xfrm>
-            <a:off x="4572000" y="3949700"/>
-            <a:ext cx="3048000" cy="419100"/>
-          </a:xfrm>
-          <a:prstGeom prst="rect">
-            <a:avLst/>
-          </a:prstGeom>
-          <a:noFill/>
-        </p:spPr>
-        <p:txBody>
-          <a:bodyPr wrap="none" lIns="0" rIns="0" tIns="0" bIns="0">
-            <a:noAutofit/>
-          </a:bodyPr>
-          <a:lstStyle/>
-          <a:p>
-            <a:pPr>
-              <a:lnSpc>
-                <a:spcPts val="2832"/>
-              </a:lnSpc>
-              <a:spcAft>
-                <a:spcPts val="0"/>
-              </a:spcAft>
-              <a:defRPr sz="2400" b="1">
-                <a:solidFill>
-                  <a:srgbClr val="F5F6FA"/>
-                </a:solidFill>
-                <a:latin typeface="Arial"/>
-              </a:defRPr>
-            </a:pPr>
-            <a:r>
-              <a:t>River Stage</a:t>
-            </a:r>
-          </a:p>
-        </p:txBody>
-      </p:sp>
-      <p:sp>
-        <p:nvSpPr>
-          <p:cNvPr id="23" name="TextBox 22"/>
-          <p:cNvSpPr txBox="1"/>
-          <p:nvPr/>
-        </p:nvSpPr>
-        <p:spPr>
-          <a:xfrm>
-            <a:off x="4572000" y="4406900"/>
-            <a:ext cx="3048000" cy="406400"/>
-          </a:xfrm>
-          <a:prstGeom prst="rect">
-            <a:avLst/>
-          </a:prstGeom>
-          <a:noFill/>
-        </p:spPr>
-        <p:txBody>
-          <a:bodyPr wrap="none" lIns="0" rIns="0" tIns="0" bIns="0">
-            <a:noAutofit/>
-          </a:bodyPr>
-          <a:lstStyle/>
-          <a:p>
-            <a:pPr>
-              <a:lnSpc>
-                <a:spcPts val="2832"/>
-              </a:lnSpc>
-              <a:spcAft>
-                <a:spcPts val="0"/>
-              </a:spcAft>
-              <a:defRPr sz="2400" b="1">
-                <a:solidFill>
-                  <a:srgbClr val="ADE6D5"/>
-                </a:solidFill>
-                <a:latin typeface="Arial"/>
-              </a:defRPr>
-            </a:pPr>
-            <a:r>
-              <a:t>3 000 osob</a:t>
-            </a:r>
-          </a:p>
-        </p:txBody>
-      </p:sp>
-      <p:sp>
-        <p:nvSpPr>
-          <p:cNvPr id="24" name="TextBox 23"/>
-          <p:cNvSpPr txBox="1"/>
-          <p:nvPr/>
-        </p:nvSpPr>
-        <p:spPr>
-          <a:xfrm>
-            <a:off x="4572000" y="4864100"/>
-            <a:ext cx="3048000" cy="279400"/>
-          </a:xfrm>
-          <a:prstGeom prst="rect">
-            <a:avLst/>
-          </a:prstGeom>
-          <a:noFill/>
-        </p:spPr>
-        <p:txBody>
-          <a:bodyPr wrap="none" lIns="0" rIns="0" tIns="0" bIns="0">
-            <a:noAutofit/>
-          </a:bodyPr>
-          <a:lstStyle/>
-          <a:p>
-            <a:pPr>
-              <a:lnSpc>
-                <a:spcPts val="1770"/>
-              </a:lnSpc>
-              <a:spcAft>
-                <a:spcPts val="0"/>
-              </a:spcAft>
-              <a:defRPr sz="1500" b="0">
-                <a:solidFill>
-                  <a:srgbClr val="B7BFCC"/>
-                </a:solidFill>
-                <a:latin typeface="Arial"/>
-              </a:defRPr>
-            </a:pPr>
-            <a:r>
-              <a:t>Pouze stání</a:t>
-            </a:r>
-          </a:p>
-        </p:txBody>
-      </p:sp>
-      <p:sp>
-        <p:nvSpPr>
-          <p:cNvPr id="25" name="Rectangle 24"/>
-          <p:cNvSpPr/>
-          <p:nvPr/>
-        </p:nvSpPr>
-        <p:spPr>
-          <a:xfrm>
-            <a:off x="8077200" y="3771900"/>
-            <a:ext cx="3505200" cy="1422400"/>
-          </a:xfrm>
-          <a:prstGeom prst="rect">
-            <a:avLst/>
-          </a:prstGeom>
-          <a:solidFill>
-            <a:srgbClr val="1D222C"/>
-          </a:solidFill>
-          <a:ln>
-            <a:noFill/>
-          </a:ln>
-        </p:spPr>
-        <p:style>
-          <a:lnRef idx="1">
-            <a:schemeClr val="accent1"/>
-          </a:lnRef>
-          <a:fillRef idx="3">
-            <a:schemeClr val="accent1"/>
-          </a:fillRef>
-          <a:effectRef idx="2">
-            <a:schemeClr val="accent1"/>
-          </a:effectRef>
-          <a:fontRef idx="minor">
-            <a:schemeClr val="lt1"/>
-          </a:fontRef>
-        </p:style>
-        <p:txBody>
-          <a:bodyPr rtlCol="0" anchor="ctr"/>
-          <a:lstStyle/>
-          <a:p>
-            <a:pPr algn="ctr"/>
-          </a:p>
-        </p:txBody>
-      </p:sp>
-      <p:sp>
-        <p:nvSpPr>
-          <p:cNvPr id="26" name="Rectangle 25"/>
-          <p:cNvSpPr/>
-          <p:nvPr/>
-        </p:nvSpPr>
-        <p:spPr>
-          <a:xfrm>
-            <a:off x="8077200" y="3771900"/>
-            <a:ext cx="50800" cy="1422400"/>
-          </a:xfrm>
-          <a:prstGeom prst="rect">
-            <a:avLst/>
-          </a:prstGeom>
-          <a:solidFill>
-            <a:srgbClr val="FF885D"/>
-          </a:solidFill>
-          <a:ln>
-            <a:noFill/>
-          </a:ln>
-        </p:spPr>
-        <p:style>
-          <a:lnRef idx="1">
-            <a:schemeClr val="accent1"/>
-          </a:lnRef>
-          <a:fillRef idx="3">
-            <a:schemeClr val="accent1"/>
-          </a:fillRef>
-          <a:effectRef idx="2">
-            <a:schemeClr val="accent1"/>
-          </a:effectRef>
-          <a:fontRef idx="minor">
-            <a:schemeClr val="lt1"/>
-          </a:fontRef>
-        </p:style>
-        <p:txBody>
-          <a:bodyPr rtlCol="0" anchor="ctr"/>
-          <a:lstStyle/>
-          <a:p>
-            <a:pPr algn="ctr"/>
-          </a:p>
-        </p:txBody>
-      </p:sp>
-      <p:sp>
-        <p:nvSpPr>
-          <p:cNvPr id="27" name="TextBox 26"/>
-          <p:cNvSpPr txBox="1"/>
-          <p:nvPr/>
-        </p:nvSpPr>
-        <p:spPr>
-          <a:xfrm>
-            <a:off x="8305800" y="3949700"/>
-            <a:ext cx="3048000" cy="419100"/>
-          </a:xfrm>
-          <a:prstGeom prst="rect">
-            <a:avLst/>
-          </a:prstGeom>
-          <a:noFill/>
-        </p:spPr>
-        <p:txBody>
-          <a:bodyPr wrap="none" lIns="0" rIns="0" tIns="0" bIns="0">
-            <a:noAutofit/>
-          </a:bodyPr>
-          <a:lstStyle/>
-          <a:p>
-            <a:pPr>
-              <a:lnSpc>
-                <a:spcPts val="2832"/>
-              </a:lnSpc>
-              <a:spcAft>
-                <a:spcPts val="0"/>
-              </a:spcAft>
-              <a:defRPr sz="2400" b="1">
-                <a:solidFill>
-                  <a:srgbClr val="F5F6FA"/>
-                </a:solidFill>
-                <a:latin typeface="Arial"/>
-              </a:defRPr>
-            </a:pPr>
-            <a:r>
-              <a:t>Club Stage</a:t>
-            </a:r>
-          </a:p>
-        </p:txBody>
-      </p:sp>
-      <p:sp>
-        <p:nvSpPr>
-          <p:cNvPr id="28" name="TextBox 27"/>
-          <p:cNvSpPr txBox="1"/>
-          <p:nvPr/>
-        </p:nvSpPr>
-        <p:spPr>
-          <a:xfrm>
-            <a:off x="8305800" y="4406900"/>
-            <a:ext cx="3048000" cy="406400"/>
-          </a:xfrm>
-          <a:prstGeom prst="rect">
-            <a:avLst/>
-          </a:prstGeom>
-          <a:noFill/>
-        </p:spPr>
-        <p:txBody>
-          <a:bodyPr wrap="none" lIns="0" rIns="0" tIns="0" bIns="0">
-            <a:noAutofit/>
-          </a:bodyPr>
-          <a:lstStyle/>
-          <a:p>
-            <a:pPr>
-              <a:lnSpc>
-                <a:spcPts val="2832"/>
-              </a:lnSpc>
-              <a:spcAft>
-                <a:spcPts val="0"/>
-              </a:spcAft>
-              <a:defRPr sz="2400" b="1">
-                <a:solidFill>
-                  <a:srgbClr val="ADE6D5"/>
-                </a:solidFill>
-                <a:latin typeface="Arial"/>
-              </a:defRPr>
-            </a:pPr>
-            <a:r>
-              <a:t>1 500 osob</a:t>
-            </a:r>
-          </a:p>
-        </p:txBody>
-      </p:sp>
-      <p:sp>
-        <p:nvSpPr>
-          <p:cNvPr id="29" name="TextBox 28"/>
-          <p:cNvSpPr txBox="1"/>
-          <p:nvPr/>
-        </p:nvSpPr>
-        <p:spPr>
-          <a:xfrm>
-            <a:off x="8305800" y="4864100"/>
-            <a:ext cx="3048000" cy="279400"/>
-          </a:xfrm>
-          <a:prstGeom prst="rect">
-            <a:avLst/>
-          </a:prstGeom>
-          <a:noFill/>
-        </p:spPr>
-        <p:txBody>
-          <a:bodyPr wrap="none" lIns="0" rIns="0" tIns="0" bIns="0">
-            <a:noAutofit/>
-          </a:bodyPr>
-          <a:lstStyle/>
-          <a:p>
-            <a:pPr>
-              <a:lnSpc>
-                <a:spcPts val="1770"/>
-              </a:lnSpc>
-              <a:spcAft>
-                <a:spcPts val="0"/>
-              </a:spcAft>
-              <a:defRPr sz="1500" b="0">
-                <a:solidFill>
-                  <a:srgbClr val="B7BFCC"/>
-                </a:solidFill>
-                <a:latin typeface="Arial"/>
-              </a:defRPr>
-            </a:pPr>
-            <a:r>
-              <a:t>Pouze stání</a:t>
-            </a:r>
-          </a:p>
-        </p:txBody>
-      </p:sp>
-      <p:sp>
-        <p:nvSpPr>
-          <p:cNvPr id="30" name="TextBox 29"/>
-          <p:cNvSpPr txBox="1"/>
-          <p:nvPr/>
-        </p:nvSpPr>
-        <p:spPr>
-          <a:xfrm>
-            <a:off x="609600" y="5499100"/>
-            <a:ext cx="10972800" cy="482600"/>
+            <a:off x="609600" y="2794000"/>
+            <a:ext cx="2540000" cy="355600"/>
           </a:xfrm>
           <a:prstGeom prst="rect">
             <a:avLst/>
@@ -6901,20 +5933,1141 @@
               </a:spcAft>
               <a:defRPr sz="1800" b="0">
                 <a:solidFill>
+                  <a:srgbClr val="F5F6FA"/>
+                </a:solidFill>
+                <a:latin typeface="Arial"/>
+              </a:defRPr>
+            </a:pPr>
+            <a:r>
+              <a:t>dny</a:t>
+            </a:r>
+          </a:p>
+        </p:txBody>
+      </p:sp>
+      <p:sp>
+        <p:nvSpPr>
+          <p:cNvPr id="9" name="TextBox 8"/>
+          <p:cNvSpPr txBox="1"/>
+          <p:nvPr/>
+        </p:nvSpPr>
+        <p:spPr>
+          <a:xfrm>
+            <a:off x="3416300" y="2171700"/>
+            <a:ext cx="2540000" cy="698500"/>
+          </a:xfrm>
+          <a:prstGeom prst="rect">
+            <a:avLst/>
+          </a:prstGeom>
+          <a:noFill/>
+        </p:spPr>
+        <p:txBody>
+          <a:bodyPr wrap="none" lIns="0" rIns="0" tIns="0" bIns="0">
+            <a:noAutofit/>
+          </a:bodyPr>
+          <a:lstStyle/>
+          <a:p>
+            <a:pPr>
+              <a:lnSpc>
+                <a:spcPts val="5309"/>
+              </a:lnSpc>
+              <a:spcAft>
+                <a:spcPts val="0"/>
+              </a:spcAft>
+              <a:defRPr sz="4500" b="1">
+                <a:solidFill>
+                  <a:srgbClr val="FF885D"/>
+                </a:solidFill>
+                <a:latin typeface="Arial"/>
+              </a:defRPr>
+            </a:pPr>
+            <a:r>
+              <a:t>3</a:t>
+            </a:r>
+          </a:p>
+        </p:txBody>
+      </p:sp>
+      <p:sp>
+        <p:nvSpPr>
+          <p:cNvPr id="10" name="TextBox 9"/>
+          <p:cNvSpPr txBox="1"/>
+          <p:nvPr/>
+        </p:nvSpPr>
+        <p:spPr>
+          <a:xfrm>
+            <a:off x="3416300" y="2794000"/>
+            <a:ext cx="2540000" cy="355600"/>
+          </a:xfrm>
+          <a:prstGeom prst="rect">
+            <a:avLst/>
+          </a:prstGeom>
+          <a:noFill/>
+        </p:spPr>
+        <p:txBody>
+          <a:bodyPr wrap="none" lIns="0" rIns="0" tIns="0" bIns="0">
+            <a:noAutofit/>
+          </a:bodyPr>
+          <a:lstStyle/>
+          <a:p>
+            <a:pPr>
+              <a:lnSpc>
+                <a:spcPts val="2124"/>
+              </a:lnSpc>
+              <a:spcAft>
+                <a:spcPts val="0"/>
+              </a:spcAft>
+              <a:defRPr sz="1800" b="0">
+                <a:solidFill>
+                  <a:srgbClr val="F5F6FA"/>
+                </a:solidFill>
+                <a:latin typeface="Arial"/>
+              </a:defRPr>
+            </a:pPr>
+            <a:r>
+              <a:t>scény</a:t>
+            </a:r>
+          </a:p>
+        </p:txBody>
+      </p:sp>
+      <p:sp>
+        <p:nvSpPr>
+          <p:cNvPr id="11" name="TextBox 10"/>
+          <p:cNvSpPr txBox="1"/>
+          <p:nvPr/>
+        </p:nvSpPr>
+        <p:spPr>
+          <a:xfrm>
+            <a:off x="6223000" y="2171700"/>
+            <a:ext cx="2540000" cy="698500"/>
+          </a:xfrm>
+          <a:prstGeom prst="rect">
+            <a:avLst/>
+          </a:prstGeom>
+          <a:noFill/>
+        </p:spPr>
+        <p:txBody>
+          <a:bodyPr wrap="none" lIns="0" rIns="0" tIns="0" bIns="0">
+            <a:noAutofit/>
+          </a:bodyPr>
+          <a:lstStyle/>
+          <a:p>
+            <a:pPr>
+              <a:lnSpc>
+                <a:spcPts val="5309"/>
+              </a:lnSpc>
+              <a:spcAft>
+                <a:spcPts val="0"/>
+              </a:spcAft>
+              <a:defRPr sz="4500" b="1">
+                <a:solidFill>
+                  <a:srgbClr val="FF885D"/>
+                </a:solidFill>
+                <a:latin typeface="Arial"/>
+              </a:defRPr>
+            </a:pPr>
+            <a:r>
+              <a:t>60</a:t>
+            </a:r>
+          </a:p>
+        </p:txBody>
+      </p:sp>
+      <p:sp>
+        <p:nvSpPr>
+          <p:cNvPr id="12" name="TextBox 11"/>
+          <p:cNvSpPr txBox="1"/>
+          <p:nvPr/>
+        </p:nvSpPr>
+        <p:spPr>
+          <a:xfrm>
+            <a:off x="6223000" y="2794000"/>
+            <a:ext cx="2540000" cy="355600"/>
+          </a:xfrm>
+          <a:prstGeom prst="rect">
+            <a:avLst/>
+          </a:prstGeom>
+          <a:noFill/>
+        </p:spPr>
+        <p:txBody>
+          <a:bodyPr wrap="none" lIns="0" rIns="0" tIns="0" bIns="0">
+            <a:noAutofit/>
+          </a:bodyPr>
+          <a:lstStyle/>
+          <a:p>
+            <a:pPr>
+              <a:lnSpc>
+                <a:spcPts val="2124"/>
+              </a:lnSpc>
+              <a:spcAft>
+                <a:spcPts val="0"/>
+              </a:spcAft>
+              <a:defRPr sz="1800" b="0">
+                <a:solidFill>
+                  <a:srgbClr val="F5F6FA"/>
+                </a:solidFill>
+                <a:latin typeface="Arial"/>
+              </a:defRPr>
+            </a:pPr>
+            <a:r>
+              <a:t>účinkujících</a:t>
+            </a:r>
+          </a:p>
+        </p:txBody>
+      </p:sp>
+      <p:sp>
+        <p:nvSpPr>
+          <p:cNvPr id="13" name="TextBox 12"/>
+          <p:cNvSpPr txBox="1"/>
+          <p:nvPr/>
+        </p:nvSpPr>
+        <p:spPr>
+          <a:xfrm>
+            <a:off x="9029700" y="2171700"/>
+            <a:ext cx="2540000" cy="698500"/>
+          </a:xfrm>
+          <a:prstGeom prst="rect">
+            <a:avLst/>
+          </a:prstGeom>
+          <a:noFill/>
+        </p:spPr>
+        <p:txBody>
+          <a:bodyPr wrap="none" lIns="0" rIns="0" tIns="0" bIns="0">
+            <a:noAutofit/>
+          </a:bodyPr>
+          <a:lstStyle/>
+          <a:p>
+            <a:pPr>
+              <a:lnSpc>
+                <a:spcPts val="5309"/>
+              </a:lnSpc>
+              <a:spcAft>
+                <a:spcPts val="0"/>
+              </a:spcAft>
+              <a:defRPr sz="4500" b="1">
+                <a:solidFill>
+                  <a:srgbClr val="FF885D"/>
+                </a:solidFill>
+                <a:latin typeface="Arial"/>
+              </a:defRPr>
+            </a:pPr>
+            <a:r>
+              <a:t>60</a:t>
+            </a:r>
+          </a:p>
+        </p:txBody>
+      </p:sp>
+      <p:sp>
+        <p:nvSpPr>
+          <p:cNvPr id="14" name="TextBox 13"/>
+          <p:cNvSpPr txBox="1"/>
+          <p:nvPr/>
+        </p:nvSpPr>
+        <p:spPr>
+          <a:xfrm>
+            <a:off x="9029700" y="2794000"/>
+            <a:ext cx="2540000" cy="355600"/>
+          </a:xfrm>
+          <a:prstGeom prst="rect">
+            <a:avLst/>
+          </a:prstGeom>
+          <a:noFill/>
+        </p:spPr>
+        <p:txBody>
+          <a:bodyPr wrap="none" lIns="0" rIns="0" tIns="0" bIns="0">
+            <a:noAutofit/>
+          </a:bodyPr>
+          <a:lstStyle/>
+          <a:p>
+            <a:pPr>
+              <a:lnSpc>
+                <a:spcPts val="2124"/>
+              </a:lnSpc>
+              <a:spcAft>
+                <a:spcPts val="0"/>
+              </a:spcAft>
+              <a:defRPr sz="1800" b="0">
+                <a:solidFill>
+                  <a:srgbClr val="F5F6FA"/>
+                </a:solidFill>
+                <a:latin typeface="Arial"/>
+              </a:defRPr>
+            </a:pPr>
+            <a:r>
+              <a:t>vystoupení</a:t>
+            </a:r>
+          </a:p>
+        </p:txBody>
+      </p:sp>
+      <p:sp>
+        <p:nvSpPr>
+          <p:cNvPr id="15" name="Rectangle 14"/>
+          <p:cNvSpPr/>
+          <p:nvPr/>
+        </p:nvSpPr>
+        <p:spPr>
+          <a:xfrm>
+            <a:off x="609600" y="3390900"/>
+            <a:ext cx="2552700" cy="1257300"/>
+          </a:xfrm>
+          <a:prstGeom prst="rect">
+            <a:avLst/>
+          </a:prstGeom>
+          <a:solidFill>
+            <a:srgbClr val="1D222C"/>
+          </a:solidFill>
+          <a:ln>
+            <a:noFill/>
+          </a:ln>
+        </p:spPr>
+        <p:style>
+          <a:lnRef idx="1">
+            <a:schemeClr val="accent1"/>
+          </a:lnRef>
+          <a:fillRef idx="3">
+            <a:schemeClr val="accent1"/>
+          </a:fillRef>
+          <a:effectRef idx="2">
+            <a:schemeClr val="accent1"/>
+          </a:effectRef>
+          <a:fontRef idx="minor">
+            <a:schemeClr val="lt1"/>
+          </a:fontRef>
+        </p:style>
+        <p:txBody>
+          <a:bodyPr rtlCol="0" anchor="ctr"/>
+          <a:lstStyle/>
+          <a:p>
+            <a:pPr algn="ctr"/>
+          </a:p>
+        </p:txBody>
+      </p:sp>
+      <p:sp>
+        <p:nvSpPr>
+          <p:cNvPr id="16" name="Rectangle 15"/>
+          <p:cNvSpPr/>
+          <p:nvPr/>
+        </p:nvSpPr>
+        <p:spPr>
+          <a:xfrm>
+            <a:off x="609600" y="3390900"/>
+            <a:ext cx="2552700" cy="38100"/>
+          </a:xfrm>
+          <a:prstGeom prst="rect">
+            <a:avLst/>
+          </a:prstGeom>
+          <a:solidFill>
+            <a:srgbClr val="FF885D"/>
+          </a:solidFill>
+          <a:ln>
+            <a:noFill/>
+          </a:ln>
+        </p:spPr>
+        <p:style>
+          <a:lnRef idx="1">
+            <a:schemeClr val="accent1"/>
+          </a:lnRef>
+          <a:fillRef idx="3">
+            <a:schemeClr val="accent1"/>
+          </a:fillRef>
+          <a:effectRef idx="2">
+            <a:schemeClr val="accent1"/>
+          </a:effectRef>
+          <a:fontRef idx="minor">
+            <a:schemeClr val="lt1"/>
+          </a:fontRef>
+        </p:style>
+        <p:txBody>
+          <a:bodyPr rtlCol="0" anchor="ctr"/>
+          <a:lstStyle/>
+          <a:p>
+            <a:pPr algn="ctr"/>
+          </a:p>
+        </p:txBody>
+      </p:sp>
+      <p:sp>
+        <p:nvSpPr>
+          <p:cNvPr id="17" name="TextBox 16"/>
+          <p:cNvSpPr txBox="1"/>
+          <p:nvPr/>
+        </p:nvSpPr>
+        <p:spPr>
+          <a:xfrm>
+            <a:off x="774700" y="3581400"/>
+            <a:ext cx="2222500" cy="406400"/>
+          </a:xfrm>
+          <a:prstGeom prst="rect">
+            <a:avLst/>
+          </a:prstGeom>
+          <a:noFill/>
+        </p:spPr>
+        <p:txBody>
+          <a:bodyPr wrap="none" lIns="0" rIns="0" tIns="0" bIns="0">
+            <a:noAutofit/>
+          </a:bodyPr>
+          <a:lstStyle/>
+          <a:p>
+            <a:pPr>
+              <a:lnSpc>
+                <a:spcPts val="2713"/>
+              </a:lnSpc>
+              <a:spcAft>
+                <a:spcPts val="0"/>
+              </a:spcAft>
+              <a:defRPr sz="2300" b="1">
+                <a:solidFill>
+                  <a:srgbClr val="F5F6FA"/>
+                </a:solidFill>
+                <a:latin typeface="Arial"/>
+              </a:defRPr>
+            </a:pPr>
+            <a:r>
+              <a:t>Interpret</a:t>
+            </a:r>
+          </a:p>
+        </p:txBody>
+      </p:sp>
+      <p:sp>
+        <p:nvSpPr>
+          <p:cNvPr id="18" name="TextBox 17"/>
+          <p:cNvSpPr txBox="1"/>
+          <p:nvPr/>
+        </p:nvSpPr>
+        <p:spPr>
+          <a:xfrm>
+            <a:off x="774700" y="4102100"/>
+            <a:ext cx="2222500" cy="444500"/>
+          </a:xfrm>
+          <a:prstGeom prst="rect">
+            <a:avLst/>
+          </a:prstGeom>
+          <a:noFill/>
+        </p:spPr>
+        <p:txBody>
+          <a:bodyPr wrap="none" lIns="0" rIns="0" tIns="0" bIns="0">
+            <a:noAutofit/>
+          </a:bodyPr>
+          <a:lstStyle/>
+          <a:p>
+            <a:pPr>
+              <a:lnSpc>
+                <a:spcPts val="1888"/>
+              </a:lnSpc>
+              <a:spcAft>
+                <a:spcPts val="0"/>
+              </a:spcAft>
+              <a:defRPr sz="1600" b="0">
+                <a:solidFill>
                   <a:srgbClr val="B7BFCC"/>
                 </a:solidFill>
                 <a:latin typeface="Arial"/>
               </a:defRPr>
             </a:pPr>
             <a:r>
-              <a:t>Vystoupení → ID dne, scény a interpreta. Kapacity jsou návrhové.</a:t>
-            </a:r>
+              <a:t>ID · jméno · žánr</a:t>
+            </a:r>
+          </a:p>
+        </p:txBody>
+      </p:sp>
+      <p:cxnSp>
+        <p:nvCxnSpPr>
+          <p:cNvPr id="19" name="Connector 18"/>
+          <p:cNvCxnSpPr/>
+          <p:nvPr/>
+        </p:nvCxnSpPr>
+        <p:spPr>
+          <a:xfrm>
+            <a:off x="3238500" y="3860800"/>
+            <a:ext cx="127000" cy="0"/>
+          </a:xfrm>
+          <a:prstGeom prst="line">
+            <a:avLst/>
+          </a:prstGeom>
+          <a:ln w="19050">
+            <a:solidFill>
+              <a:srgbClr val="FF885D"/>
+            </a:solidFill>
+          </a:ln>
+        </p:spPr>
+        <p:style>
+          <a:lnRef idx="2">
+            <a:schemeClr val="accent1"/>
+          </a:lnRef>
+          <a:fillRef idx="0">
+            <a:schemeClr val="accent1"/>
+          </a:fillRef>
+          <a:effectRef idx="1">
+            <a:schemeClr val="accent1"/>
+          </a:effectRef>
+          <a:fontRef idx="minor">
+            <a:schemeClr val="tx1"/>
+          </a:fontRef>
+        </p:style>
+      </p:cxnSp>
+      <p:sp>
+        <p:nvSpPr>
+          <p:cNvPr id="20" name="Rectangle 19"/>
+          <p:cNvSpPr/>
+          <p:nvPr/>
+        </p:nvSpPr>
+        <p:spPr>
+          <a:xfrm>
+            <a:off x="3416300" y="3390900"/>
+            <a:ext cx="2552700" cy="1257300"/>
+          </a:xfrm>
+          <a:prstGeom prst="rect">
+            <a:avLst/>
+          </a:prstGeom>
+          <a:solidFill>
+            <a:srgbClr val="1D222C"/>
+          </a:solidFill>
+          <a:ln>
+            <a:noFill/>
+          </a:ln>
+        </p:spPr>
+        <p:style>
+          <a:lnRef idx="1">
+            <a:schemeClr val="accent1"/>
+          </a:lnRef>
+          <a:fillRef idx="3">
+            <a:schemeClr val="accent1"/>
+          </a:fillRef>
+          <a:effectRef idx="2">
+            <a:schemeClr val="accent1"/>
+          </a:effectRef>
+          <a:fontRef idx="minor">
+            <a:schemeClr val="lt1"/>
+          </a:fontRef>
+        </p:style>
+        <p:txBody>
+          <a:bodyPr rtlCol="0" anchor="ctr"/>
+          <a:lstStyle/>
+          <a:p>
+            <a:pPr algn="ctr"/>
+          </a:p>
+        </p:txBody>
+      </p:sp>
+      <p:sp>
+        <p:nvSpPr>
+          <p:cNvPr id="21" name="Rectangle 20"/>
+          <p:cNvSpPr/>
+          <p:nvPr/>
+        </p:nvSpPr>
+        <p:spPr>
+          <a:xfrm>
+            <a:off x="3416300" y="3390900"/>
+            <a:ext cx="2552700" cy="38100"/>
+          </a:xfrm>
+          <a:prstGeom prst="rect">
+            <a:avLst/>
+          </a:prstGeom>
+          <a:solidFill>
+            <a:srgbClr val="ADE6D5"/>
+          </a:solidFill>
+          <a:ln>
+            <a:noFill/>
+          </a:ln>
+        </p:spPr>
+        <p:style>
+          <a:lnRef idx="1">
+            <a:schemeClr val="accent1"/>
+          </a:lnRef>
+          <a:fillRef idx="3">
+            <a:schemeClr val="accent1"/>
+          </a:fillRef>
+          <a:effectRef idx="2">
+            <a:schemeClr val="accent1"/>
+          </a:effectRef>
+          <a:fontRef idx="minor">
+            <a:schemeClr val="lt1"/>
+          </a:fontRef>
+        </p:style>
+        <p:txBody>
+          <a:bodyPr rtlCol="0" anchor="ctr"/>
+          <a:lstStyle/>
+          <a:p>
+            <a:pPr algn="ctr"/>
+          </a:p>
+        </p:txBody>
+      </p:sp>
+      <p:sp>
+        <p:nvSpPr>
+          <p:cNvPr id="22" name="TextBox 21"/>
+          <p:cNvSpPr txBox="1"/>
+          <p:nvPr/>
+        </p:nvSpPr>
+        <p:spPr>
+          <a:xfrm>
+            <a:off x="3581400" y="3581400"/>
+            <a:ext cx="2222500" cy="406400"/>
+          </a:xfrm>
+          <a:prstGeom prst="rect">
+            <a:avLst/>
+          </a:prstGeom>
+          <a:noFill/>
+        </p:spPr>
+        <p:txBody>
+          <a:bodyPr wrap="none" lIns="0" rIns="0" tIns="0" bIns="0">
+            <a:noAutofit/>
+          </a:bodyPr>
+          <a:lstStyle/>
+          <a:p>
+            <a:pPr>
+              <a:lnSpc>
+                <a:spcPts val="2713"/>
+              </a:lnSpc>
+              <a:spcAft>
+                <a:spcPts val="0"/>
+              </a:spcAft>
+              <a:defRPr sz="2300" b="1">
+                <a:solidFill>
+                  <a:srgbClr val="F5F6FA"/>
+                </a:solidFill>
+                <a:latin typeface="Arial"/>
+              </a:defRPr>
+            </a:pPr>
+            <a:r>
+              <a:t>Vystoupení</a:t>
+            </a:r>
+          </a:p>
+        </p:txBody>
+      </p:sp>
+      <p:sp>
+        <p:nvSpPr>
+          <p:cNvPr id="23" name="TextBox 22"/>
+          <p:cNvSpPr txBox="1"/>
+          <p:nvPr/>
+        </p:nvSpPr>
+        <p:spPr>
+          <a:xfrm>
+            <a:off x="3581400" y="4102100"/>
+            <a:ext cx="2222500" cy="444500"/>
+          </a:xfrm>
+          <a:prstGeom prst="rect">
+            <a:avLst/>
+          </a:prstGeom>
+          <a:noFill/>
+        </p:spPr>
+        <p:txBody>
+          <a:bodyPr wrap="none" lIns="0" rIns="0" tIns="0" bIns="0">
+            <a:noAutofit/>
+          </a:bodyPr>
+          <a:lstStyle/>
+          <a:p>
+            <a:pPr>
+              <a:lnSpc>
+                <a:spcPts val="1888"/>
+              </a:lnSpc>
+              <a:spcAft>
+                <a:spcPts val="0"/>
+              </a:spcAft>
+              <a:defRPr sz="1600" b="0">
+                <a:solidFill>
+                  <a:srgbClr val="B7BFCC"/>
+                </a:solidFill>
+                <a:latin typeface="Arial"/>
+              </a:defRPr>
+            </a:pPr>
+            <a:r>
+              <a:t>Čas a odkazy přes ID</a:t>
+            </a:r>
+          </a:p>
+        </p:txBody>
+      </p:sp>
+      <p:cxnSp>
+        <p:nvCxnSpPr>
+          <p:cNvPr id="24" name="Connector 23"/>
+          <p:cNvCxnSpPr/>
+          <p:nvPr/>
+        </p:nvCxnSpPr>
+        <p:spPr>
+          <a:xfrm>
+            <a:off x="6045200" y="3860800"/>
+            <a:ext cx="127000" cy="0"/>
+          </a:xfrm>
+          <a:prstGeom prst="line">
+            <a:avLst/>
+          </a:prstGeom>
+          <a:ln w="19050">
+            <a:solidFill>
+              <a:srgbClr val="FF885D"/>
+            </a:solidFill>
+          </a:ln>
+        </p:spPr>
+        <p:style>
+          <a:lnRef idx="2">
+            <a:schemeClr val="accent1"/>
+          </a:lnRef>
+          <a:fillRef idx="0">
+            <a:schemeClr val="accent1"/>
+          </a:fillRef>
+          <a:effectRef idx="1">
+            <a:schemeClr val="accent1"/>
+          </a:effectRef>
+          <a:fontRef idx="minor">
+            <a:schemeClr val="tx1"/>
+          </a:fontRef>
+        </p:style>
+      </p:cxnSp>
+      <p:sp>
+        <p:nvSpPr>
+          <p:cNvPr id="25" name="Rectangle 24"/>
+          <p:cNvSpPr/>
+          <p:nvPr/>
+        </p:nvSpPr>
+        <p:spPr>
+          <a:xfrm>
+            <a:off x="6223000" y="3390900"/>
+            <a:ext cx="2552700" cy="1257300"/>
+          </a:xfrm>
+          <a:prstGeom prst="rect">
+            <a:avLst/>
+          </a:prstGeom>
+          <a:solidFill>
+            <a:srgbClr val="1D222C"/>
+          </a:solidFill>
+          <a:ln>
+            <a:noFill/>
+          </a:ln>
+        </p:spPr>
+        <p:style>
+          <a:lnRef idx="1">
+            <a:schemeClr val="accent1"/>
+          </a:lnRef>
+          <a:fillRef idx="3">
+            <a:schemeClr val="accent1"/>
+          </a:fillRef>
+          <a:effectRef idx="2">
+            <a:schemeClr val="accent1"/>
+          </a:effectRef>
+          <a:fontRef idx="minor">
+            <a:schemeClr val="lt1"/>
+          </a:fontRef>
+        </p:style>
+        <p:txBody>
+          <a:bodyPr rtlCol="0" anchor="ctr"/>
+          <a:lstStyle/>
+          <a:p>
+            <a:pPr algn="ctr"/>
+          </a:p>
+        </p:txBody>
+      </p:sp>
+      <p:sp>
+        <p:nvSpPr>
+          <p:cNvPr id="26" name="Rectangle 25"/>
+          <p:cNvSpPr/>
+          <p:nvPr/>
+        </p:nvSpPr>
+        <p:spPr>
+          <a:xfrm>
+            <a:off x="6223000" y="3390900"/>
+            <a:ext cx="2552700" cy="38100"/>
+          </a:xfrm>
+          <a:prstGeom prst="rect">
+            <a:avLst/>
+          </a:prstGeom>
+          <a:solidFill>
+            <a:srgbClr val="FF885D"/>
+          </a:solidFill>
+          <a:ln>
+            <a:noFill/>
+          </a:ln>
+        </p:spPr>
+        <p:style>
+          <a:lnRef idx="1">
+            <a:schemeClr val="accent1"/>
+          </a:lnRef>
+          <a:fillRef idx="3">
+            <a:schemeClr val="accent1"/>
+          </a:fillRef>
+          <a:effectRef idx="2">
+            <a:schemeClr val="accent1"/>
+          </a:effectRef>
+          <a:fontRef idx="minor">
+            <a:schemeClr val="lt1"/>
+          </a:fontRef>
+        </p:style>
+        <p:txBody>
+          <a:bodyPr rtlCol="0" anchor="ctr"/>
+          <a:lstStyle/>
+          <a:p>
+            <a:pPr algn="ctr"/>
+          </a:p>
+        </p:txBody>
+      </p:sp>
+      <p:sp>
+        <p:nvSpPr>
+          <p:cNvPr id="27" name="TextBox 26"/>
+          <p:cNvSpPr txBox="1"/>
+          <p:nvPr/>
+        </p:nvSpPr>
+        <p:spPr>
+          <a:xfrm>
+            <a:off x="6388100" y="3581400"/>
+            <a:ext cx="2222500" cy="406400"/>
+          </a:xfrm>
+          <a:prstGeom prst="rect">
+            <a:avLst/>
+          </a:prstGeom>
+          <a:noFill/>
+        </p:spPr>
+        <p:txBody>
+          <a:bodyPr wrap="none" lIns="0" rIns="0" tIns="0" bIns="0">
+            <a:noAutofit/>
+          </a:bodyPr>
+          <a:lstStyle/>
+          <a:p>
+            <a:pPr>
+              <a:lnSpc>
+                <a:spcPts val="2713"/>
+              </a:lnSpc>
+              <a:spcAft>
+                <a:spcPts val="0"/>
+              </a:spcAft>
+              <a:defRPr sz="2300" b="1">
+                <a:solidFill>
+                  <a:srgbClr val="F5F6FA"/>
+                </a:solidFill>
+                <a:latin typeface="Arial"/>
+              </a:defRPr>
+            </a:pPr>
+            <a:r>
+              <a:t>Den a scéna</a:t>
+            </a:r>
+          </a:p>
+        </p:txBody>
+      </p:sp>
+      <p:sp>
+        <p:nvSpPr>
+          <p:cNvPr id="28" name="TextBox 27"/>
+          <p:cNvSpPr txBox="1"/>
+          <p:nvPr/>
+        </p:nvSpPr>
+        <p:spPr>
+          <a:xfrm>
+            <a:off x="6388100" y="4102100"/>
+            <a:ext cx="2222500" cy="444500"/>
+          </a:xfrm>
+          <a:prstGeom prst="rect">
+            <a:avLst/>
+          </a:prstGeom>
+          <a:noFill/>
+        </p:spPr>
+        <p:txBody>
+          <a:bodyPr wrap="none" lIns="0" rIns="0" tIns="0" bIns="0">
+            <a:noAutofit/>
+          </a:bodyPr>
+          <a:lstStyle/>
+          <a:p>
+            <a:pPr>
+              <a:lnSpc>
+                <a:spcPts val="1888"/>
+              </a:lnSpc>
+              <a:spcAft>
+                <a:spcPts val="0"/>
+              </a:spcAft>
+              <a:defRPr sz="1600" b="0">
+                <a:solidFill>
+                  <a:srgbClr val="B7BFCC"/>
+                </a:solidFill>
+                <a:latin typeface="Arial"/>
+              </a:defRPr>
+            </a:pPr>
+            <a:r>
+              <a:t>Datum · kapacita</a:t>
+            </a:r>
+          </a:p>
+        </p:txBody>
+      </p:sp>
+      <p:cxnSp>
+        <p:nvCxnSpPr>
+          <p:cNvPr id="29" name="Connector 28"/>
+          <p:cNvCxnSpPr/>
+          <p:nvPr/>
+        </p:nvCxnSpPr>
+        <p:spPr>
+          <a:xfrm>
+            <a:off x="8851900" y="3860800"/>
+            <a:ext cx="127000" cy="0"/>
+          </a:xfrm>
+          <a:prstGeom prst="line">
+            <a:avLst/>
+          </a:prstGeom>
+          <a:ln w="19050">
+            <a:solidFill>
+              <a:srgbClr val="FF885D"/>
+            </a:solidFill>
+          </a:ln>
+        </p:spPr>
+        <p:style>
+          <a:lnRef idx="2">
+            <a:schemeClr val="accent1"/>
+          </a:lnRef>
+          <a:fillRef idx="0">
+            <a:schemeClr val="accent1"/>
+          </a:fillRef>
+          <a:effectRef idx="1">
+            <a:schemeClr val="accent1"/>
+          </a:effectRef>
+          <a:fontRef idx="minor">
+            <a:schemeClr val="tx1"/>
+          </a:fontRef>
+        </p:style>
+      </p:cxnSp>
+      <p:sp>
+        <p:nvSpPr>
+          <p:cNvPr id="30" name="Rectangle 29"/>
+          <p:cNvSpPr/>
+          <p:nvPr/>
+        </p:nvSpPr>
+        <p:spPr>
+          <a:xfrm>
+            <a:off x="9029700" y="3390900"/>
+            <a:ext cx="2552700" cy="1257300"/>
+          </a:xfrm>
+          <a:prstGeom prst="rect">
+            <a:avLst/>
+          </a:prstGeom>
+          <a:solidFill>
+            <a:srgbClr val="1D222C"/>
+          </a:solidFill>
+          <a:ln>
+            <a:noFill/>
+          </a:ln>
+        </p:spPr>
+        <p:style>
+          <a:lnRef idx="1">
+            <a:schemeClr val="accent1"/>
+          </a:lnRef>
+          <a:fillRef idx="3">
+            <a:schemeClr val="accent1"/>
+          </a:fillRef>
+          <a:effectRef idx="2">
+            <a:schemeClr val="accent1"/>
+          </a:effectRef>
+          <a:fontRef idx="minor">
+            <a:schemeClr val="lt1"/>
+          </a:fontRef>
+        </p:style>
+        <p:txBody>
+          <a:bodyPr rtlCol="0" anchor="ctr"/>
+          <a:lstStyle/>
+          <a:p>
+            <a:pPr algn="ctr"/>
           </a:p>
         </p:txBody>
       </p:sp>
       <p:sp>
         <p:nvSpPr>
           <p:cNvPr id="31" name="Rectangle 30"/>
+          <p:cNvSpPr/>
+          <p:nvPr/>
+        </p:nvSpPr>
+        <p:spPr>
+          <a:xfrm>
+            <a:off x="9029700" y="3390900"/>
+            <a:ext cx="2552700" cy="38100"/>
+          </a:xfrm>
+          <a:prstGeom prst="rect">
+            <a:avLst/>
+          </a:prstGeom>
+          <a:solidFill>
+            <a:srgbClr val="FF885D"/>
+          </a:solidFill>
+          <a:ln>
+            <a:noFill/>
+          </a:ln>
+        </p:spPr>
+        <p:style>
+          <a:lnRef idx="1">
+            <a:schemeClr val="accent1"/>
+          </a:lnRef>
+          <a:fillRef idx="3">
+            <a:schemeClr val="accent1"/>
+          </a:fillRef>
+          <a:effectRef idx="2">
+            <a:schemeClr val="accent1"/>
+          </a:effectRef>
+          <a:fontRef idx="minor">
+            <a:schemeClr val="lt1"/>
+          </a:fontRef>
+        </p:style>
+        <p:txBody>
+          <a:bodyPr rtlCol="0" anchor="ctr"/>
+          <a:lstStyle/>
+          <a:p>
+            <a:pPr algn="ctr"/>
+          </a:p>
+        </p:txBody>
+      </p:sp>
+      <p:sp>
+        <p:nvSpPr>
+          <p:cNvPr id="32" name="TextBox 31"/>
+          <p:cNvSpPr txBox="1"/>
+          <p:nvPr/>
+        </p:nvSpPr>
+        <p:spPr>
+          <a:xfrm>
+            <a:off x="9194800" y="3581400"/>
+            <a:ext cx="2222500" cy="406400"/>
+          </a:xfrm>
+          <a:prstGeom prst="rect">
+            <a:avLst/>
+          </a:prstGeom>
+          <a:noFill/>
+        </p:spPr>
+        <p:txBody>
+          <a:bodyPr wrap="none" lIns="0" rIns="0" tIns="0" bIns="0">
+            <a:noAutofit/>
+          </a:bodyPr>
+          <a:lstStyle/>
+          <a:p>
+            <a:pPr>
+              <a:lnSpc>
+                <a:spcPts val="2713"/>
+              </a:lnSpc>
+              <a:spcAft>
+                <a:spcPts val="0"/>
+              </a:spcAft>
+              <a:defRPr sz="2300" b="1">
+                <a:solidFill>
+                  <a:srgbClr val="F5F6FA"/>
+                </a:solidFill>
+                <a:latin typeface="Arial"/>
+              </a:defRPr>
+            </a:pPr>
+            <a:r>
+              <a:t>Vstupenka</a:t>
+            </a:r>
+          </a:p>
+        </p:txBody>
+      </p:sp>
+      <p:sp>
+        <p:nvSpPr>
+          <p:cNvPr id="33" name="TextBox 32"/>
+          <p:cNvSpPr txBox="1"/>
+          <p:nvPr/>
+        </p:nvSpPr>
+        <p:spPr>
+          <a:xfrm>
+            <a:off x="9194800" y="4102100"/>
+            <a:ext cx="2222500" cy="444500"/>
+          </a:xfrm>
+          <a:prstGeom prst="rect">
+            <a:avLst/>
+          </a:prstGeom>
+          <a:noFill/>
+        </p:spPr>
+        <p:txBody>
+          <a:bodyPr wrap="none" lIns="0" rIns="0" tIns="0" bIns="0">
+            <a:noAutofit/>
+          </a:bodyPr>
+          <a:lstStyle/>
+          <a:p>
+            <a:pPr>
+              <a:lnSpc>
+                <a:spcPts val="1888"/>
+              </a:lnSpc>
+              <a:spcAft>
+                <a:spcPts val="0"/>
+              </a:spcAft>
+              <a:defRPr sz="1600" b="0">
+                <a:solidFill>
+                  <a:srgbClr val="B7BFCC"/>
+                </a:solidFill>
+                <a:latin typeface="Arial"/>
+              </a:defRPr>
+            </a:pPr>
+            <a:r>
+              <a:t>Platnost · cena</a:t>
+            </a:r>
+          </a:p>
+        </p:txBody>
+      </p:sp>
+      <p:sp>
+        <p:nvSpPr>
+          <p:cNvPr id="34" name="TextBox 33"/>
+          <p:cNvSpPr txBox="1"/>
+          <p:nvPr/>
+        </p:nvSpPr>
+        <p:spPr>
+          <a:xfrm>
+            <a:off x="609600" y="4991100"/>
+            <a:ext cx="10972800" cy="406400"/>
+          </a:xfrm>
+          <a:prstGeom prst="rect">
+            <a:avLst/>
+          </a:prstGeom>
+          <a:noFill/>
+        </p:spPr>
+        <p:txBody>
+          <a:bodyPr wrap="none" lIns="0" rIns="0" tIns="0" bIns="0">
+            <a:noAutofit/>
+          </a:bodyPr>
+          <a:lstStyle/>
+          <a:p>
+            <a:pPr>
+              <a:lnSpc>
+                <a:spcPts val="2360"/>
+              </a:lnSpc>
+              <a:spcAft>
+                <a:spcPts val="0"/>
+              </a:spcAft>
+              <a:defRPr sz="2000" b="1">
+                <a:solidFill>
+                  <a:srgbClr val="ADE6D5"/>
+                </a:solidFill>
+                <a:latin typeface="Arial"/>
+              </a:defRPr>
+            </a:pPr>
+            <a:r>
+              <a:t>XML → generátor → JSON exporty a data webu</a:t>
+            </a:r>
+          </a:p>
+        </p:txBody>
+      </p:sp>
+      <p:sp>
+        <p:nvSpPr>
+          <p:cNvPr id="35" name="TextBox 34"/>
+          <p:cNvSpPr txBox="1"/>
+          <p:nvPr/>
+        </p:nvSpPr>
+        <p:spPr>
+          <a:xfrm>
+            <a:off x="609600" y="5537200"/>
+            <a:ext cx="10972800" cy="495300"/>
+          </a:xfrm>
+          <a:prstGeom prst="rect">
+            <a:avLst/>
+          </a:prstGeom>
+          <a:noFill/>
+        </p:spPr>
+        <p:txBody>
+          <a:bodyPr wrap="none" lIns="0" rIns="0" tIns="0" bIns="0">
+            <a:noAutofit/>
+          </a:bodyPr>
+          <a:lstStyle/>
+          <a:p>
+            <a:pPr>
+              <a:lnSpc>
+                <a:spcPts val="2005"/>
+              </a:lnSpc>
+              <a:spcAft>
+                <a:spcPts val="0"/>
+              </a:spcAft>
+              <a:defRPr sz="1700" b="0">
+                <a:solidFill>
+                  <a:srgbClr val="B7BFCC"/>
+                </a:solidFill>
+                <a:latin typeface="Arial"/>
+              </a:defRPr>
+            </a:pPr>
+            <a:r>
+              <a:t>Filtry vybírají objekty; detail předává den a scénu do nákupu.</a:t>
+            </a:r>
+          </a:p>
+        </p:txBody>
+      </p:sp>
+      <p:sp>
+        <p:nvSpPr>
+          <p:cNvPr id="36" name="Rectangle 35"/>
           <p:cNvSpPr/>
           <p:nvPr/>
         </p:nvSpPr>
@@ -6957,7 +7110,7 @@
       </p:sp>
       <p:sp>
         <p:nvSpPr>
-          <p:cNvPr id="32" name="TextBox 31"/>
+          <p:cNvPr id="37" name="TextBox 36"/>
           <p:cNvSpPr txBox="1"/>
           <p:nvPr/>
         </p:nvSpPr>
@@ -6999,7 +7152,7 @@
       </p:sp>
       <p:sp>
         <p:nvSpPr>
-          <p:cNvPr id="33" name="TextBox 32"/>
+          <p:cNvPr id="38" name="TextBox 37"/>
           <p:cNvSpPr txBox="1"/>
           <p:nvPr/>
         </p:nvSpPr>
@@ -7265,7 +7418,7 @@
               </a:defRPr>
             </a:pPr>
             <a:r>
-              <a:t>Obsah se propojuje podle úkolu</a:t>
+              <a:t>Jasná cesta mezi obsahem a nákupem</a:t>
             </a:r>
           </a:p>
         </p:txBody>
@@ -7687,7 +7840,7 @@
               </a:defRPr>
             </a:pPr>
             <a:r>
-              <a:t>Den · čas · osobní výběr</a:t>
+              <a:t>Filtry → koncert → vstup</a:t>
             </a:r>
           </a:p>
         </p:txBody>
@@ -8011,7 +8164,7 @@
               </a:defRPr>
             </a:pPr>
             <a:r>
-              <a:t>Místo → jeho program</a:t>
+              <a:t>Kapacita → program / vstup</a:t>
             </a:r>
           </a:p>
         </p:txBody>
@@ -8335,7 +8488,7 @@
               </a:defRPr>
             </a:pPr>
             <a:r>
-              <a:t>Dotaz → výsledky → obsah</a:t>
+              <a:t>Dotaz → výsledky → detail</a:t>
             </a:r>
           </a:p>
         </p:txBody>
@@ -8539,7 +8692,7 @@
               </a:defRPr>
             </a:pPr>
             <a:r>
-              <a:t>Koncert ↔ interpret ↔ scéna · Účet a historie jsou volitelné.</a:t>
+              <a:t>Účet a historie doplňují nákup; registrace není podmínkou.</a:t>
             </a:r>
           </a:p>
         </p:txBody>
@@ -8897,7 +9050,7 @@
               </a:defRPr>
             </a:pPr>
             <a:r>
-              <a:t>Dva průchody, které ověříme</a:t>
+              <a:t>Dva konkrétní průchody webem</a:t>
             </a:r>
           </a:p>
         </p:txBody>
@@ -9151,7 +9304,7 @@
               </a:defRPr>
             </a:pPr>
             <a:r>
-              <a:t>Zná den a scénu, hledá koncerty.</a:t>
+              <a:t>Zná den a scénu návštěvy.</a:t>
             </a:r>
           </a:p>
         </p:txBody>
@@ -9193,7 +9346,7 @@
               </a:defRPr>
             </a:pPr>
             <a:r>
-              <a:t>Program → 1. srpna → River</a:t>
+              <a:t>Program → den a scéna</a:t>
             </a:r>
           </a:p>
           <a:p>
@@ -9297,7 +9450,7 @@
               </a:defRPr>
             </a:pPr>
             <a:r>
-              <a:t>Výběr zůstane i po obnovení.</a:t>
+              <a:t>Výběr zůstane, kolize se označí.</a:t>
             </a:r>
           </a:p>
         </p:txBody>
@@ -9467,7 +9620,7 @@
               </a:defRPr>
             </a:pPr>
             <a:r>
-              <a:t>Najít známého interpreta</a:t>
+              <a:t>Vybrat vstup na interpreta</a:t>
             </a:r>
           </a:p>
         </p:txBody>
@@ -9551,7 +9704,7 @@
               </a:defRPr>
             </a:pPr>
             <a:r>
-              <a:t>Zná jméno, nezná čas a scénu.</a:t>
+              <a:t>Zná jméno, nezná den ani scénu.</a:t>
             </a:r>
           </a:p>
         </p:txBody>
@@ -9593,7 +9746,7 @@
               </a:defRPr>
             </a:pPr>
             <a:r>
-              <a:t>Hledání → DARKZY → detail</a:t>
+              <a:t>Hledání → detail → koncert</a:t>
             </a:r>
           </a:p>
           <a:p>
@@ -9612,7 +9765,7 @@
               </a:defRPr>
             </a:pPr>
             <a:r>
-              <a:t>→ související vystoupení</a:t>
+              <a:t>→ předvolený vstup → košík</a:t>
             </a:r>
           </a:p>
         </p:txBody>
@@ -9697,7 +9850,7 @@
               </a:defRPr>
             </a:pPr>
             <a:r>
-              <a:t>Zjistí datum, čas a Club Stage.</a:t>
+              <a:t>Správný den a Club Stage.</a:t>
             </a:r>
           </a:p>
         </p:txBody>
@@ -9739,7 +9892,7 @@
               </a:defRPr>
             </a:pPr>
             <a:r>
-              <a:t>Specifikace dále definuje S3: objednávka hosta se stažením PDF.</a:t>
+              <a:t>S3 ve specifikaci: dva vybrané dny, vlastní sedadla a PDF.</a:t>
             </a:r>
           </a:p>
         </p:txBody>
@@ -10097,7 +10250,7 @@
               </a:defRPr>
             </a:pPr>
             <a:r>
-              <a:t>AI navrhuje. Výsledek ověřujeme.</a:t>
+              <a:t>Návrh od AI ověřujeme na datech</a:t>
             </a:r>
           </a:p>
         </p:txBody>
@@ -10182,7 +10335,7 @@
               </a:defRPr>
             </a:pPr>
             <a:r>
-              <a:t>Přijato</a:t>
+              <a:t>AI pomohla</a:t>
             </a:r>
           </a:p>
         </p:txBody>
@@ -10224,7 +10377,7 @@
               </a:defRPr>
             </a:pPr>
             <a:r>
-              <a:t>Struktura, texty a vazby</a:t>
+              <a:t>Struktura, texty a datové</a:t>
             </a:r>
           </a:p>
           <a:p>
@@ -10243,7 +10396,7 @@
               </a:defRPr>
             </a:pPr>
             <a:r>
-              <a:t>přes ID.</a:t>
+              <a:t>vazby.</a:t>
             </a:r>
           </a:p>
         </p:txBody>
@@ -10328,7 +10481,7 @@
               </a:defRPr>
             </a:pPr>
             <a:r>
-              <a:t>Upraveno</a:t>
+              <a:t>Upravili jsme</a:t>
             </a:r>
           </a:p>
         </p:txBody>
@@ -10370,7 +10523,7 @@
               </a:defRPr>
             </a:pPr>
             <a:r>
-              <a:t>Scénáře, kapacity a</a:t>
+              <a:t>Scénáře a přesný rozsah</a:t>
             </a:r>
           </a:p>
           <a:p>
@@ -10389,7 +10542,7 @@
               </a:defRPr>
             </a:pPr>
             <a:r>
-              <a:t>program.</a:t>
+              <a:t>vstupu.</a:t>
             </a:r>
           </a:p>
         </p:txBody>
@@ -10474,7 +10627,7 @@
               </a:defRPr>
             </a:pPr>
             <a:r>
-              <a:t>Odmítnuto</a:t>
+              <a:t>Rozhodnutí</a:t>
             </a:r>
           </a:p>
         </p:txBody>
@@ -10516,7 +10669,7 @@
               </a:defRPr>
             </a:pPr>
             <a:r>
-              <a:t>Backend mimo klientské</a:t>
+              <a:t>Jedna datová základna</a:t>
             </a:r>
           </a:p>
           <a:p>
@@ -10535,7 +10688,7 @@
               </a:defRPr>
             </a:pPr>
             <a:r>
-              <a:t>zadání.</a:t>
+              <a:t>pro web.</a:t>
             </a:r>
           </a:p>
         </p:txBody>
@@ -10661,7 +10814,7 @@
               </a:defRPr>
             </a:pPr>
             <a:r>
-              <a:t>XML / XSD a počty entit</a:t>
+              <a:t>XML / XSD, počty a ID</a:t>
             </a:r>
           </a:p>
         </p:txBody>
@@ -10745,7 +10898,26 @@
               </a:defRPr>
             </a:pPr>
             <a:r>
-              <a:t>Existující ID a reference</a:t>
+              <a:t>Filtry proti zdrojovým</a:t>
+            </a:r>
+          </a:p>
+          <a:p>
+            <a:pPr>
+              <a:lnSpc>
+                <a:spcPts val="2477"/>
+              </a:lnSpc>
+              <a:spcAft>
+                <a:spcPts val="0"/>
+              </a:spcAft>
+              <a:defRPr sz="2100" b="0">
+                <a:solidFill>
+                  <a:srgbClr val="F5F6FA"/>
+                </a:solidFill>
+                <a:latin typeface="Arial"/>
+              </a:defRPr>
+            </a:pPr>
+            <a:r>
+              <a:t>datům</a:t>
             </a:r>
           </a:p>
         </p:txBody>
@@ -10829,7 +11001,7 @@
               </a:defRPr>
             </a:pPr>
             <a:r>
-              <a:t>Shoda XML → export pro</a:t>
+              <a:t>Den, scéna a cena v</a:t>
             </a:r>
           </a:p>
           <a:p>
@@ -10848,7 +11020,7 @@
               </a:defRPr>
             </a:pPr>
             <a:r>
-              <a:t>web</a:t>
+              <a:t>nákupu</a:t>
             </a:r>
           </a:p>
         </p:txBody>
@@ -10890,7 +11062,7 @@
               </a:defRPr>
             </a:pPr>
             <a:r>
-              <a:t>Limit: datová validace nenahrazuje test s návštěvníky.</a:t>
+              <a:t>Ověření: konkrétní kroky a výsledky, které lze znovu zopakovat.</a:t>
             </a:r>
           </a:p>
         </p:txBody>

</xml_diff>